<commit_message>
feat: integrate and validate new research evidence
</commit_message>
<xml_diff>
--- a/docs/papers/thesis/thesis_presentation_zh.pptx
+++ b/docs/papers/thesis/thesis_presentation_zh.pptx
@@ -3434,8 +3434,8 @@
         </p:blipFill>
         <p:spPr>
           <a:xfrm>
-            <a:off x="6492240" y="1371600"/>
-            <a:ext cx="4389120" cy="4389120"/>
+            <a:off x="6126480" y="2132561"/>
+            <a:ext cx="5120640" cy="2867197"/>
           </a:xfrm>
           <a:prstGeom prst="rect">
             <a:avLst/>
@@ -23606,8 +23606,8 @@
         </p:blipFill>
         <p:spPr>
           <a:xfrm>
-            <a:off x="3474720" y="1143000"/>
-            <a:ext cx="5257800" cy="5257800"/>
+            <a:off x="1321317" y="1143000"/>
+            <a:ext cx="9564604" cy="5257800"/>
           </a:xfrm>
           <a:prstGeom prst="rect">
             <a:avLst/>
@@ -33743,8 +33743,8 @@
         </p:blipFill>
         <p:spPr>
           <a:xfrm>
-            <a:off x="1051560" y="1280160"/>
-            <a:ext cx="4846320" cy="4846320"/>
+            <a:off x="731520" y="2135777"/>
+            <a:ext cx="5486400" cy="3135085"/>
           </a:xfrm>
           <a:prstGeom prst="rect">
             <a:avLst/>
@@ -38285,8 +38285,8 @@
         </p:blipFill>
         <p:spPr>
           <a:xfrm>
-            <a:off x="3488436" y="1024128"/>
-            <a:ext cx="5230368" cy="5230368"/>
+            <a:off x="1571318" y="1024128"/>
+            <a:ext cx="9064602" cy="5230368"/>
           </a:xfrm>
           <a:prstGeom prst="rect">
             <a:avLst/>
@@ -40764,8 +40764,8 @@
         </p:blipFill>
         <p:spPr>
           <a:xfrm>
-            <a:off x="1051560" y="1234440"/>
-            <a:ext cx="4663440" cy="4663440"/>
+            <a:off x="731520" y="2116026"/>
+            <a:ext cx="5303520" cy="2900267"/>
           </a:xfrm>
           <a:prstGeom prst="rect">
             <a:avLst/>

</xml_diff>

<commit_message>
research: synchronize enclosure evidence and LQR briefing artifacts
</commit_message>
<xml_diff>
--- a/docs/papers/thesis/thesis_presentation_zh.pptx
+++ b/docs/papers/thesis/thesis_presentation_zh.pptx
@@ -47,6 +47,16 @@
     <p:sldId id="295" r:id="rId46"/>
     <p:sldId id="296" r:id="rId47"/>
     <p:sldId id="297" r:id="rId48"/>
+    <p:sldId id="298" r:id="rId49"/>
+    <p:sldId id="299" r:id="rId50"/>
+    <p:sldId id="300" r:id="rId51"/>
+    <p:sldId id="301" r:id="rId52"/>
+    <p:sldId id="302" r:id="rId53"/>
+    <p:sldId id="303" r:id="rId54"/>
+    <p:sldId id="304" r:id="rId55"/>
+    <p:sldId id="305" r:id="rId56"/>
+    <p:sldId id="306" r:id="rId58"/>
+    <p:sldId id="307" r:id="rId59"/>
   </p:sldIdLst>
   <p:sldSz cx="12191695" cy="6858000" type="screen4x3"/>
   <p:notesSz cx="6858000" cy="9144000"/>
@@ -146,6 +156,591 @@
     </a:lvl9pPr>
   </p:defaultTextStyle>
 </p:presentation>
+</file>
+
+<file path=ppt/notesMasters/notesMaster1.xml><?xml version="1.0" encoding="utf-8"?>
+<p:notesMaster xmlns:a="http://schemas.openxmlformats.org/drawingml/2006/main" xmlns:p="http://schemas.openxmlformats.org/presentationml/2006/main" xmlns:r="http://schemas.openxmlformats.org/officeDocument/2006/relationships">
+  <p:cSld>
+    <p:bg>
+      <p:bgRef idx="1001">
+        <a:schemeClr val="bg1"/>
+      </p:bgRef>
+    </p:bg>
+    <p:spTree>
+      <p:nvGrpSpPr>
+        <p:cNvPr id="1" name=""/>
+        <p:cNvGrpSpPr/>
+        <p:nvPr/>
+      </p:nvGrpSpPr>
+      <p:grpSpPr>
+        <a:xfrm>
+          <a:off x="0" y="0"/>
+          <a:ext cx="0" cy="0"/>
+          <a:chOff x="0" y="0"/>
+          <a:chExt cx="0" cy="0"/>
+        </a:xfrm>
+      </p:grpSpPr>
+      <p:sp>
+        <p:nvSpPr>
+          <p:cNvPr id="2" name="Header Placeholder 1"/>
+          <p:cNvSpPr>
+            <a:spLocks noGrp="1"/>
+          </p:cNvSpPr>
+          <p:nvPr>
+            <p:ph type="hdr" sz="quarter"/>
+          </p:nvPr>
+        </p:nvSpPr>
+        <p:spPr>
+          <a:xfrm>
+            <a:off x="0" y="0"/>
+            <a:ext cx="2971800" cy="457200"/>
+          </a:xfrm>
+          <a:prstGeom prst="rect">
+            <a:avLst/>
+          </a:prstGeom>
+        </p:spPr>
+        <p:txBody>
+          <a:bodyPr vert="horz" lIns="91440" tIns="45720" rIns="91440" bIns="45720" rtlCol="0"/>
+          <a:lstStyle>
+            <a:lvl1pPr algn="l">
+              <a:defRPr sz="1200"/>
+            </a:lvl1pPr>
+          </a:lstStyle>
+          <a:p>
+            <a:endParaRPr lang="en-US"/>
+          </a:p>
+        </p:txBody>
+      </p:sp>
+      <p:sp>
+        <p:nvSpPr>
+          <p:cNvPr id="3" name="Date Placeholder 2"/>
+          <p:cNvSpPr>
+            <a:spLocks noGrp="1"/>
+          </p:cNvSpPr>
+          <p:nvPr>
+            <p:ph type="dt" idx="1"/>
+          </p:nvPr>
+        </p:nvSpPr>
+        <p:spPr>
+          <a:xfrm>
+            <a:off x="3884613" y="0"/>
+            <a:ext cx="2971800" cy="457200"/>
+          </a:xfrm>
+          <a:prstGeom prst="rect">
+            <a:avLst/>
+          </a:prstGeom>
+        </p:spPr>
+        <p:txBody>
+          <a:bodyPr vert="horz" lIns="91440" tIns="45720" rIns="91440" bIns="45720" rtlCol="0"/>
+          <a:lstStyle>
+            <a:lvl1pPr algn="r">
+              <a:defRPr sz="1200"/>
+            </a:lvl1pPr>
+          </a:lstStyle>
+          <a:p>
+            <a:fld id="{0F89C1C7-3DCD-1040-A9CF-14679D8B5DDD}" type="datetimeFigureOut">
+              <a:rPr lang="en-US" smtClean="0"/>
+              <a:t>10/17/16</a:t>
+            </a:fld>
+            <a:endParaRPr lang="en-US"/>
+          </a:p>
+        </p:txBody>
+      </p:sp>
+      <p:sp>
+        <p:nvSpPr>
+          <p:cNvPr id="4" name="Slide Image Placeholder 3"/>
+          <p:cNvSpPr>
+            <a:spLocks noGrp="1" noRot="1" noChangeAspect="1"/>
+          </p:cNvSpPr>
+          <p:nvPr>
+            <p:ph type="sldImg" idx="2"/>
+          </p:nvPr>
+        </p:nvSpPr>
+        <p:spPr>
+          <a:xfrm>
+            <a:off x="1143000" y="685800"/>
+            <a:ext cx="4572000" cy="3429000"/>
+          </a:xfrm>
+          <a:prstGeom prst="rect">
+            <a:avLst/>
+          </a:prstGeom>
+          <a:noFill/>
+          <a:ln w="12700">
+            <a:solidFill>
+              <a:prstClr val="black"/>
+            </a:solidFill>
+          </a:ln>
+        </p:spPr>
+        <p:txBody>
+          <a:bodyPr vert="horz" lIns="91440" tIns="45720" rIns="91440" bIns="45720" rtlCol="0" anchor="ctr"/>
+          <a:lstStyle/>
+          <a:p>
+            <a:endParaRPr lang="en-US"/>
+          </a:p>
+        </p:txBody>
+      </p:sp>
+      <p:sp>
+        <p:nvSpPr>
+          <p:cNvPr id="5" name="Notes Placeholder 4"/>
+          <p:cNvSpPr>
+            <a:spLocks noGrp="1"/>
+          </p:cNvSpPr>
+          <p:nvPr>
+            <p:ph type="body" sz="quarter" idx="3"/>
+          </p:nvPr>
+        </p:nvSpPr>
+        <p:spPr>
+          <a:xfrm>
+            <a:off x="685800" y="4343400"/>
+            <a:ext cx="5486400" cy="4114800"/>
+          </a:xfrm>
+          <a:prstGeom prst="rect">
+            <a:avLst/>
+          </a:prstGeom>
+        </p:spPr>
+        <p:txBody>
+          <a:bodyPr vert="horz" lIns="91440" tIns="45720" rIns="91440" bIns="45720" rtlCol="0"/>
+          <a:lstStyle/>
+          <a:p>
+            <a:pPr lvl="0"/>
+            <a:r>
+              <a:rPr lang="en-US" smtClean="0"/>
+              <a:t>Click to edit Master text styles</a:t>
+            </a:r>
+          </a:p>
+          <a:p>
+            <a:pPr lvl="1"/>
+            <a:r>
+              <a:rPr lang="en-US" smtClean="0"/>
+              <a:t>Second level</a:t>
+            </a:r>
+          </a:p>
+          <a:p>
+            <a:pPr lvl="2"/>
+            <a:r>
+              <a:rPr lang="en-US" smtClean="0"/>
+              <a:t>Third level</a:t>
+            </a:r>
+          </a:p>
+          <a:p>
+            <a:pPr lvl="3"/>
+            <a:r>
+              <a:rPr lang="en-US" smtClean="0"/>
+              <a:t>Fourth level</a:t>
+            </a:r>
+          </a:p>
+          <a:p>
+            <a:pPr lvl="4"/>
+            <a:r>
+              <a:rPr lang="en-US" smtClean="0"/>
+              <a:t>Fifth level</a:t>
+            </a:r>
+            <a:endParaRPr lang="en-US"/>
+          </a:p>
+        </p:txBody>
+      </p:sp>
+      <p:sp>
+        <p:nvSpPr>
+          <p:cNvPr id="6" name="Footer Placeholder 5"/>
+          <p:cNvSpPr>
+            <a:spLocks noGrp="1"/>
+          </p:cNvSpPr>
+          <p:nvPr>
+            <p:ph type="ftr" sz="quarter" idx="4"/>
+          </p:nvPr>
+        </p:nvSpPr>
+        <p:spPr>
+          <a:xfrm>
+            <a:off x="0" y="8685213"/>
+            <a:ext cx="2971800" cy="457200"/>
+          </a:xfrm>
+          <a:prstGeom prst="rect">
+            <a:avLst/>
+          </a:prstGeom>
+        </p:spPr>
+        <p:txBody>
+          <a:bodyPr vert="horz" lIns="91440" tIns="45720" rIns="91440" bIns="45720" rtlCol="0" anchor="b"/>
+          <a:lstStyle>
+            <a:lvl1pPr algn="l">
+              <a:defRPr sz="1200"/>
+            </a:lvl1pPr>
+          </a:lstStyle>
+          <a:p>
+            <a:endParaRPr lang="en-US"/>
+          </a:p>
+        </p:txBody>
+      </p:sp>
+      <p:sp>
+        <p:nvSpPr>
+          <p:cNvPr id="7" name="Slide Number Placeholder 6"/>
+          <p:cNvSpPr>
+            <a:spLocks noGrp="1"/>
+          </p:cNvSpPr>
+          <p:nvPr>
+            <p:ph type="sldNum" sz="quarter" idx="5"/>
+          </p:nvPr>
+        </p:nvSpPr>
+        <p:spPr>
+          <a:xfrm>
+            <a:off x="3884613" y="8685213"/>
+            <a:ext cx="2971800" cy="457200"/>
+          </a:xfrm>
+          <a:prstGeom prst="rect">
+            <a:avLst/>
+          </a:prstGeom>
+        </p:spPr>
+        <p:txBody>
+          <a:bodyPr vert="horz" lIns="91440" tIns="45720" rIns="91440" bIns="45720" rtlCol="0" anchor="b"/>
+          <a:lstStyle>
+            <a:lvl1pPr algn="r">
+              <a:defRPr sz="1200"/>
+            </a:lvl1pPr>
+          </a:lstStyle>
+          <a:p>
+            <a:fld id="{BB5E49A5-4136-284D-997B-48E1D791AD67}" type="slidenum">
+              <a:rPr lang="en-US" smtClean="0"/>
+              <a:t>‹#›</a:t>
+            </a:fld>
+            <a:endParaRPr lang="en-US"/>
+          </a:p>
+        </p:txBody>
+      </p:sp>
+    </p:spTree>
+    <p:extLst>
+      <p:ext uri="{BB962C8B-B14F-4D97-AF65-F5344CB8AC3E}">
+        <p14:creationId xmlns:p14="http://schemas.microsoft.com/office/powerpoint/2010/main" val="2623252185"/>
+      </p:ext>
+    </p:extLst>
+  </p:cSld>
+  <p:clrMap bg1="lt1" tx1="dk1" bg2="lt2" tx2="dk2" accent1="accent1" accent2="accent2" accent3="accent3" accent4="accent4" accent5="accent5" accent6="accent6" hlink="hlink" folHlink="folHlink"/>
+  <p:notesStyle>
+    <a:lvl1pPr marL="0" algn="l" defTabSz="457200" rtl="0" eaLnBrk="1" latinLnBrk="0" hangingPunct="1">
+      <a:defRPr sz="1200" kern="1200">
+        <a:solidFill>
+          <a:schemeClr val="tx1"/>
+        </a:solidFill>
+        <a:latin typeface="+mn-lt"/>
+        <a:ea typeface="+mn-ea"/>
+        <a:cs typeface="+mn-cs"/>
+      </a:defRPr>
+    </a:lvl1pPr>
+    <a:lvl2pPr marL="457200" algn="l" defTabSz="457200" rtl="0" eaLnBrk="1" latinLnBrk="0" hangingPunct="1">
+      <a:defRPr sz="1200" kern="1200">
+        <a:solidFill>
+          <a:schemeClr val="tx1"/>
+        </a:solidFill>
+        <a:latin typeface="+mn-lt"/>
+        <a:ea typeface="+mn-ea"/>
+        <a:cs typeface="+mn-cs"/>
+      </a:defRPr>
+    </a:lvl2pPr>
+    <a:lvl3pPr marL="914400" algn="l" defTabSz="457200" rtl="0" eaLnBrk="1" latinLnBrk="0" hangingPunct="1">
+      <a:defRPr sz="1200" kern="1200">
+        <a:solidFill>
+          <a:schemeClr val="tx1"/>
+        </a:solidFill>
+        <a:latin typeface="+mn-lt"/>
+        <a:ea typeface="+mn-ea"/>
+        <a:cs typeface="+mn-cs"/>
+      </a:defRPr>
+    </a:lvl3pPr>
+    <a:lvl4pPr marL="1371600" algn="l" defTabSz="457200" rtl="0" eaLnBrk="1" latinLnBrk="0" hangingPunct="1">
+      <a:defRPr sz="1200" kern="1200">
+        <a:solidFill>
+          <a:schemeClr val="tx1"/>
+        </a:solidFill>
+        <a:latin typeface="+mn-lt"/>
+        <a:ea typeface="+mn-ea"/>
+        <a:cs typeface="+mn-cs"/>
+      </a:defRPr>
+    </a:lvl4pPr>
+    <a:lvl5pPr marL="1828800" algn="l" defTabSz="457200" rtl="0" eaLnBrk="1" latinLnBrk="0" hangingPunct="1">
+      <a:defRPr sz="1200" kern="1200">
+        <a:solidFill>
+          <a:schemeClr val="tx1"/>
+        </a:solidFill>
+        <a:latin typeface="+mn-lt"/>
+        <a:ea typeface="+mn-ea"/>
+        <a:cs typeface="+mn-cs"/>
+      </a:defRPr>
+    </a:lvl5pPr>
+    <a:lvl6pPr marL="2286000" algn="l" defTabSz="457200" rtl="0" eaLnBrk="1" latinLnBrk="0" hangingPunct="1">
+      <a:defRPr sz="1200" kern="1200">
+        <a:solidFill>
+          <a:schemeClr val="tx1"/>
+        </a:solidFill>
+        <a:latin typeface="+mn-lt"/>
+        <a:ea typeface="+mn-ea"/>
+        <a:cs typeface="+mn-cs"/>
+      </a:defRPr>
+    </a:lvl6pPr>
+    <a:lvl7pPr marL="2743200" algn="l" defTabSz="457200" rtl="0" eaLnBrk="1" latinLnBrk="0" hangingPunct="1">
+      <a:defRPr sz="1200" kern="1200">
+        <a:solidFill>
+          <a:schemeClr val="tx1"/>
+        </a:solidFill>
+        <a:latin typeface="+mn-lt"/>
+        <a:ea typeface="+mn-ea"/>
+        <a:cs typeface="+mn-cs"/>
+      </a:defRPr>
+    </a:lvl7pPr>
+    <a:lvl8pPr marL="3200400" algn="l" defTabSz="457200" rtl="0" eaLnBrk="1" latinLnBrk="0" hangingPunct="1">
+      <a:defRPr sz="1200" kern="1200">
+        <a:solidFill>
+          <a:schemeClr val="tx1"/>
+        </a:solidFill>
+        <a:latin typeface="+mn-lt"/>
+        <a:ea typeface="+mn-ea"/>
+        <a:cs typeface="+mn-cs"/>
+      </a:defRPr>
+    </a:lvl8pPr>
+    <a:lvl9pPr marL="3657600" algn="l" defTabSz="457200" rtl="0" eaLnBrk="1" latinLnBrk="0" hangingPunct="1">
+      <a:defRPr sz="1200" kern="1200">
+        <a:solidFill>
+          <a:schemeClr val="tx1"/>
+        </a:solidFill>
+        <a:latin typeface="+mn-lt"/>
+        <a:ea typeface="+mn-ea"/>
+        <a:cs typeface="+mn-cs"/>
+      </a:defRPr>
+    </a:lvl9pPr>
+  </p:notesStyle>
+</p:notesMaster>
+</file>
+
+<file path=ppt/notesSlides/notesSlide1.xml><?xml version="1.0" encoding="utf-8"?>
+<p:notes xmlns:a="http://schemas.openxmlformats.org/drawingml/2006/main" xmlns:p="http://schemas.openxmlformats.org/presentationml/2006/main" xmlns:r="http://schemas.openxmlformats.org/officeDocument/2006/relationships">
+  <p:cSld>
+    <p:spTree>
+      <p:nvGrpSpPr>
+        <p:cNvPr id="1" name=""/>
+        <p:cNvGrpSpPr/>
+        <p:nvPr/>
+      </p:nvGrpSpPr>
+      <p:grpSpPr>
+        <a:xfrm>
+          <a:off x="0" y="0"/>
+          <a:ext cx="0" cy="0"/>
+          <a:chOff x="0" y="0"/>
+          <a:chExt cx="0" cy="0"/>
+        </a:xfrm>
+      </p:grpSpPr>
+      <p:sp>
+        <p:nvSpPr>
+          <p:cNvPr id="2" name="Slide Image Placeholder 1"/>
+          <p:cNvSpPr>
+            <a:spLocks noGrp="1"/>
+          </p:cNvSpPr>
+          <p:nvPr>
+            <p:ph type="sldImg" idx="2"/>
+          </p:nvPr>
+        </p:nvSpPr>
+        <p:spPr/>
+      </p:sp>
+      <p:sp>
+        <p:nvSpPr>
+          <p:cNvPr id="3" name="Notes Placeholder 2"/>
+          <p:cNvSpPr>
+            <a:spLocks noGrp="1"/>
+          </p:cNvSpPr>
+          <p:nvPr>
+            <p:ph type="body" idx="3" sz="quarter"/>
+          </p:nvPr>
+        </p:nvSpPr>
+        <p:spPr/>
+        <p:txBody>
+          <a:bodyPr/>
+          <a:lstStyle/>
+          <a:p>
+            <a:r>
+              <a:t>2026-10-05 完成 CPU/GPU 雙熱節點與風扇延遲的受限制 MPC 探索性模擬。calibration 後鎖定控制器，另跑 36 回合、4,320 個控制步，涵蓋 validation、holdout、模型失配與過載。holdout 的三 seed macro tracking MAE 為固定風扇 5.4378°C、PID 2.6034°C、MPC 1.4426°C，MPC 相對 PID 降低 44.59%。nominal 六個 MPC 回合均無 PWM／slew 違例、超溫或求解回退。</a:t>
+            </a:r>
+          </a:p>
+          <a:p>
+            <a:r>
+              <a:t>代價是 holdout 風扇能耗 proxy 由 PID 0.5873 Wh 增至 MPC 0.8234 Wh，PWM total variation 亦增加。過載仍超溫，MPC 平均每回合 63.33 步求解回退；溫度為軟限制，不能視為安全保證。參數、負載與功耗曲線均為假設，plant 與 predictor 雖採不同數值積分，仍共享名義熱參數。本結果只支持假設模型內的探索性可行性與追蹤改善，不代表機箱辨識、NTC、實體控制、throttling、整機功耗或跨設備確認。E8 保持 NOT_EVALUATED，LQR 保持 TODO。</a:t>
+            </a:r>
+          </a:p>
+        </p:txBody>
+      </p:sp>
+      <p:sp>
+        <p:nvSpPr>
+          <p:cNvPr id="4" name="Slide Number Placeholder 3"/>
+          <p:cNvSpPr>
+            <a:spLocks noGrp="1"/>
+          </p:cNvSpPr>
+          <p:nvPr>
+            <p:ph type="sldNum" idx="5" sz="quarter"/>
+          </p:nvPr>
+        </p:nvSpPr>
+        <p:spPr/>
+      </p:sp>
+    </p:spTree>
+  </p:cSld>
+  <p:clrMapOvr>
+    <a:masterClrMapping/>
+  </p:clrMapOvr>
+</p:notes>
+</file>
+
+<file path=ppt/notesSlides/notesSlide2.xml><?xml version="1.0" encoding="utf-8"?>
+<p:notes xmlns:a="http://schemas.openxmlformats.org/drawingml/2006/main" xmlns:p="http://schemas.openxmlformats.org/presentationml/2006/main" xmlns:r="http://schemas.openxmlformats.org/officeDocument/2006/relationships">
+  <p:cSld>
+    <p:spTree>
+      <p:nvGrpSpPr>
+        <p:cNvPr id="1" name=""/>
+        <p:cNvGrpSpPr/>
+        <p:nvPr/>
+      </p:nvGrpSpPr>
+      <p:grpSpPr>
+        <a:xfrm>
+          <a:off x="0" y="0"/>
+          <a:ext cx="0" cy="0"/>
+          <a:chOff x="0" y="0"/>
+          <a:chExt cx="0" cy="0"/>
+        </a:xfrm>
+      </p:grpSpPr>
+      <p:sp>
+        <p:nvSpPr>
+          <p:cNvPr id="2" name="Slide Image Placeholder 1"/>
+          <p:cNvSpPr>
+            <a:spLocks noGrp="1"/>
+          </p:cNvSpPr>
+          <p:nvPr>
+            <p:ph type="sldImg" idx="2"/>
+          </p:nvPr>
+        </p:nvSpPr>
+        <p:spPr/>
+      </p:sp>
+      <p:sp>
+        <p:nvSpPr>
+          <p:cNvPr id="3" name="Notes Placeholder 2"/>
+          <p:cNvSpPr>
+            <a:spLocks noGrp="1"/>
+          </p:cNvSpPr>
+          <p:nvPr>
+            <p:ph type="body" idx="3" sz="quarter"/>
+          </p:nvPr>
+        </p:nvSpPr>
+        <p:spPr/>
+        <p:txBody>
+          <a:bodyPr/>
+          <a:lstStyle/>
+          <a:p>
+            <a:r>
+              <a:t>2026-10-05 第二階段完成四方法假設模型探索性比較，共 48 回合、5,760 控制步。每方法依相同三個 calibration seeds 評估三個候選，選參後凍結，再開啟新的 validation、holdout、假設模型變體與過載。holdout 三 seed 等權 tracking MAE：固定風扇 2.9051°C、PID＋平衡點前饋 1.7713°C、經限制的 LQR 1.7304°C、受限制 MPC 1.8071°C。相同方法順序的風扇能耗 proxy 為 0.7200／0.9832／1.0034／1.0567 Wh。研究判準：H-CTRL-01=SUPPORTED_SIMULATION_ONLY；H-CTRL-02=NOT_SUPPORTED；H-CTRL-03=NOT_SUPPORTED。</a:t>
+            </a:r>
+          </a:p>
+          <a:p>
+            <a:r>
+              <a:t>固定風扇：取樣超溫 1096.7 s、數值回退 0.00 步／回合；PID＋平衡點前饋：取樣超溫 1040.0 s、數值回退 0.00 步／回合；經限制的 LQR：取樣超溫 1126.7 s、數值回退 0.00 步／回合；受限制 MPC：取樣超溫 1040.0 s、數值回退 0.00 步／回合</a:t>
+            </a:r>
+          </a:p>
+          <a:p>
+            <a:r>
+              <a:t>四方法使用相同候選評估回合預算，CPU 計算時間並不相等。PID＋前饋、LQR 與 MPC 知道名義假設參數，且完整狀態可見；數值積分方式不同不等於獨立物理驗證。plant_holdout 是三組預先指定的假設參數變體，不能支持跨實體設備泛化。新合成 seeds 也不是實體設備樣本。超溫秒數按每 10 秒末端取樣估計；風扇能耗採 10u³ W 假設，不能代替整機功耗。溫度限制為軟限制，求解成功不代表熱能力足夠或硬體安全。實體機箱、NTC、throttling、整機功耗與 E8 仍為 NOT_EVALUATED。舊 v1 報告中的 LQR TODO 是第一階段的歷史狀態。</a:t>
+            </a:r>
+          </a:p>
+        </p:txBody>
+      </p:sp>
+      <p:sp>
+        <p:nvSpPr>
+          <p:cNvPr id="4" name="Slide Number Placeholder 3"/>
+          <p:cNvSpPr>
+            <a:spLocks noGrp="1"/>
+          </p:cNvSpPr>
+          <p:nvPr>
+            <p:ph type="sldNum" idx="5" sz="quarter"/>
+          </p:nvPr>
+        </p:nvSpPr>
+        <p:spPr/>
+      </p:sp>
+    </p:spTree>
+  </p:cSld>
+  <p:clrMapOvr>
+    <a:masterClrMapping/>
+  </p:clrMapOvr>
+</p:notes>
+</file>
+
+<file path=ppt/notesSlides/notesSlide3.xml><?xml version="1.0" encoding="utf-8"?>
+<p:notes xmlns:a="http://schemas.openxmlformats.org/drawingml/2006/main" xmlns:p="http://schemas.openxmlformats.org/presentationml/2006/main" xmlns:r="http://schemas.openxmlformats.org/officeDocument/2006/relationships">
+  <p:cSld>
+    <p:spTree>
+      <p:nvGrpSpPr>
+        <p:cNvPr id="1" name=""/>
+        <p:cNvGrpSpPr/>
+        <p:nvPr/>
+      </p:nvGrpSpPr>
+      <p:grpSpPr>
+        <a:xfrm>
+          <a:off x="0" y="0"/>
+          <a:ext cx="0" cy="0"/>
+          <a:chOff x="0" y="0"/>
+          <a:chExt cx="0" cy="0"/>
+        </a:xfrm>
+      </p:grpSpPr>
+      <p:sp>
+        <p:nvSpPr>
+          <p:cNvPr id="2" name="Slide Image Placeholder 1"/>
+          <p:cNvSpPr>
+            <a:spLocks noGrp="1"/>
+          </p:cNvSpPr>
+          <p:nvPr>
+            <p:ph type="sldImg" idx="2"/>
+          </p:nvPr>
+        </p:nvSpPr>
+        <p:spPr/>
+      </p:sp>
+      <p:sp>
+        <p:nvSpPr>
+          <p:cNvPr id="3" name="Notes Placeholder 2"/>
+          <p:cNvSpPr>
+            <a:spLocks noGrp="1"/>
+          </p:cNvSpPr>
+          <p:nvPr>
+            <p:ph type="body" idx="3" sz="quarter"/>
+          </p:nvPr>
+        </p:nvSpPr>
+        <p:spPr/>
+        <p:txBody>
+          <a:bodyPr/>
+          <a:lstStyle/>
+          <a:p>
+            <a:r>
+              <a:t>2026-10-06 依教授交辦查證金屬傳熱與風管場景，建立熱源／金屬片／空氣熱網路候選原型，以金屬片、空氣與風扇觀測估測未提供的熱源溫度。三組假設平台採相同有限辨識程序，完成 108 回合、19,440 步。新的合成 holdout 上，名義物理／辨識物理／稀疏校正熱源估測 MAE 為 0.9610/0.6580/0.3352°C；稀疏校正相對辨識物理減少 49.06%，6/6 組改善。固定／PI／PID／單步排序／六步排序／六步無校正的 tracking MAE 為 1.5458/1.2219/1.2221/1.3969/1.2708/1.3644°C。六步相對單步減少 9.03%，仍未優於 PI；六步排序平均取樣超溫 103.33 秒／回合。H-ENC-31／H-ENC-32 只在此 exploratory simulation 的事前判準內 supported。</a:t>
+            </a:r>
+          </a:p>
+          <a:p>
+            <a:r>
+              <a:t>本輪為溫度子問題與假設熱網路：已知熱容量和部分係數，單一方程家族、三組指定參數與合成噪聲。金屬片／風管增益是假設，未量測實際裝置；有限候選排序不是 LQR 或完整 MPC。20–30°C 外的樣本完整保留，但不擴張原室內模型適用域。濕度、光照、三維空間場、完整三因子遷移與實體辨識／介入均未評估。</a:t>
+            </a:r>
+          </a:p>
+          <a:p>
+            <a:r>
+              <a:t>已為下週準備 LQR 與 Kalman (1960) Contributions to the Theory of Optimal Control 的介紹。重點查閱原文問題、狀態精確已知假設、可控／可觀測與 Riccati／穩定定理敘述；未重證全部證明，亦尚未口頭報告。</a:t>
+            </a:r>
+          </a:p>
+        </p:txBody>
+      </p:sp>
+      <p:sp>
+        <p:nvSpPr>
+          <p:cNvPr id="4" name="Slide Number Placeholder 3"/>
+          <p:cNvSpPr>
+            <a:spLocks noGrp="1"/>
+          </p:cNvSpPr>
+          <p:nvPr>
+            <p:ph type="sldNum" idx="5" sz="quarter"/>
+          </p:nvPr>
+        </p:nvSpPr>
+        <p:spPr/>
+      </p:sp>
+    </p:spTree>
+  </p:cSld>
+  <p:clrMapOvr>
+    <a:masterClrMapping/>
+  </p:clrMapOvr>
+</p:notes>
 </file>
 
 <file path=ppt/slideLayouts/slideLayout1.xml><?xml version="1.0" encoding="utf-8"?>
@@ -6576,7 +7171,7 @@
                 </a:solidFill>
                 <a:latin typeface="Noto Sans TC"/>
               </a:rPr>
-              <a:t>• PID：相同 plant / setpoint / disturbance 的閉環控制 baseline（尚未評估）</a:t>
+              <a:t>• PID：相同 plant / setpoint / disturbance 的閉環控制 baseline（實體未評估；機箱假設模型已比較）</a:t>
             </a:r>
           </a:p>
           <a:p>
@@ -37242,6 +37837,2387 @@
 </p:sld>
 </file>
 
+<file path=ppt/slides/slide43.xml><?xml version="1.0" encoding="utf-8"?>
+<p:sld xmlns:a="http://schemas.openxmlformats.org/drawingml/2006/main" xmlns:p="http://schemas.openxmlformats.org/presentationml/2006/main" xmlns:r="http://schemas.openxmlformats.org/officeDocument/2006/relationships">
+  <p:cSld>
+    <p:bg>
+      <p:bgPr>
+        <a:solidFill>
+          <a:srgbClr val="F4F7FB"/>
+        </a:solidFill>
+        <a:effectLst/>
+      </p:bgPr>
+    </p:bg>
+    <p:spTree>
+      <p:nvGrpSpPr>
+        <p:cNvPr id="1" name=""/>
+        <p:cNvGrpSpPr/>
+        <p:nvPr/>
+      </p:nvGrpSpPr>
+      <p:grpSpPr/>
+      <p:sp>
+        <p:nvSpPr>
+          <p:cNvPr id="2" name="Rectangle 1"/>
+          <p:cNvSpPr/>
+          <p:nvPr/>
+        </p:nvSpPr>
+        <p:spPr>
+          <a:xfrm>
+            <a:off x="0" y="0"/>
+            <a:ext cx="12191695" cy="896112"/>
+          </a:xfrm>
+          <a:prstGeom prst="rect">
+            <a:avLst/>
+          </a:prstGeom>
+          <a:solidFill>
+            <a:srgbClr val="122033"/>
+          </a:solidFill>
+          <a:ln>
+            <a:solidFill>
+              <a:srgbClr val="122033"/>
+            </a:solidFill>
+          </a:ln>
+        </p:spPr>
+        <p:style>
+          <a:lnRef idx="1">
+            <a:schemeClr val="accent1"/>
+          </a:lnRef>
+          <a:fillRef idx="3">
+            <a:schemeClr val="accent1"/>
+          </a:fillRef>
+          <a:effectRef idx="2">
+            <a:schemeClr val="accent1"/>
+          </a:effectRef>
+          <a:fontRef idx="minor">
+            <a:schemeClr val="lt1"/>
+          </a:fontRef>
+        </p:style>
+        <p:txBody>
+          <a:bodyPr rtlCol="0" anchor="ctr"/>
+          <a:lstStyle/>
+          <a:p>
+            <a:pPr algn="ctr"/>
+          </a:p>
+        </p:txBody>
+      </p:sp>
+      <p:sp>
+        <p:nvSpPr>
+          <p:cNvPr id="3" name="Rectangle 2"/>
+          <p:cNvSpPr/>
+          <p:nvPr/>
+        </p:nvSpPr>
+        <p:spPr>
+          <a:xfrm>
+            <a:off x="0" y="868680"/>
+            <a:ext cx="12191695" cy="27432"/>
+          </a:xfrm>
+          <a:prstGeom prst="rect">
+            <a:avLst/>
+          </a:prstGeom>
+          <a:solidFill>
+            <a:srgbClr val="2D9BC8"/>
+          </a:solidFill>
+          <a:ln>
+            <a:solidFill>
+              <a:srgbClr val="2D9BC8"/>
+            </a:solidFill>
+          </a:ln>
+        </p:spPr>
+        <p:style>
+          <a:lnRef idx="1">
+            <a:schemeClr val="accent1"/>
+          </a:lnRef>
+          <a:fillRef idx="3">
+            <a:schemeClr val="accent1"/>
+          </a:fillRef>
+          <a:effectRef idx="2">
+            <a:schemeClr val="accent1"/>
+          </a:effectRef>
+          <a:fontRef idx="minor">
+            <a:schemeClr val="lt1"/>
+          </a:fontRef>
+        </p:style>
+        <p:txBody>
+          <a:bodyPr rtlCol="0" anchor="ctr"/>
+          <a:lstStyle/>
+          <a:p>
+            <a:pPr algn="ctr"/>
+          </a:p>
+        </p:txBody>
+      </p:sp>
+      <p:sp>
+        <p:nvSpPr>
+          <p:cNvPr id="4" name="TextBox 3"/>
+          <p:cNvSpPr txBox="1"/>
+          <p:nvPr/>
+        </p:nvSpPr>
+        <p:spPr>
+          <a:xfrm>
+            <a:off x="530352" y="109728"/>
+            <a:ext cx="11155680" cy="438912"/>
+          </a:xfrm>
+          <a:prstGeom prst="rect">
+            <a:avLst/>
+          </a:prstGeom>
+          <a:noFill/>
+        </p:spPr>
+        <p:txBody>
+          <a:bodyPr wrap="square" lIns="0" rIns="0" tIns="0" bIns="0">
+            <a:normAutofit/>
+          </a:bodyPr>
+          <a:lstStyle/>
+          <a:p>
+            <a:r>
+              <a:rPr sz="2200" b="1">
+                <a:solidFill>
+                  <a:srgbClr val="FFFFFF"/>
+                </a:solidFill>
+                <a:latin typeface="Noto Sans TC"/>
+              </a:rPr>
+              <a:t>E11D：角色語意的獨立確認</a:t>
+            </a:r>
+          </a:p>
+        </p:txBody>
+      </p:sp>
+      <p:sp>
+        <p:nvSpPr>
+          <p:cNvPr id="5" name="TextBox 4"/>
+          <p:cNvSpPr txBox="1"/>
+          <p:nvPr/>
+        </p:nvSpPr>
+        <p:spPr>
+          <a:xfrm>
+            <a:off x="822960" y="1417320"/>
+            <a:ext cx="10515600" cy="4800600"/>
+          </a:xfrm>
+          <a:prstGeom prst="rect">
+            <a:avLst/>
+          </a:prstGeom>
+          <a:noFill/>
+        </p:spPr>
+        <p:txBody>
+          <a:bodyPr wrap="square" lIns="18288" rIns="18288" tIns="18288" bIns="18288">
+            <a:normAutofit/>
+          </a:bodyPr>
+          <a:lstStyle/>
+          <a:p>
+            <a:pPr>
+              <a:lnSpc>
+                <a:spcPct val="112000"/>
+              </a:lnSpc>
+              <a:spcAft>
+                <a:spcPts val="900"/>
+              </a:spcAft>
+              <a:defRPr sz="2000">
+                <a:solidFill>
+                  <a:srgbClr val="1E2733"/>
+                </a:solidFill>
+                <a:latin typeface="Noto Sans TC"/>
+              </a:defRPr>
+            </a:pPr>
+            <a:r>
+              <a:rPr sz="2000" b="0">
+                <a:solidFill>
+                  <a:srgbClr val="1E2733"/>
+                </a:solidFill>
+                <a:latin typeface="Noto Sans TC"/>
+              </a:rPr>
+              <a:t>• H-ENC-04 supported；11 x 4 MiB，1,505 分鐘快照</a:t>
+            </a:r>
+          </a:p>
+          <a:p>
+            <a:pPr>
+              <a:lnSpc>
+                <a:spcPct val="112000"/>
+              </a:lnSpc>
+              <a:spcAft>
+                <a:spcPts val="900"/>
+              </a:spcAft>
+              <a:defRPr sz="2000">
+                <a:solidFill>
+                  <a:srgbClr val="1E2733"/>
+                </a:solidFill>
+                <a:latin typeface="Noto Sans TC"/>
+              </a:defRPr>
+            </a:pPr>
+            <a:r>
+              <a:rPr sz="2000" b="0">
+                <a:solidFill>
+                  <a:srgbClr val="1E2733"/>
+                </a:solidFill>
+                <a:latin typeface="Noto Sans TC"/>
+              </a:rPr>
+              <a:t>• MAE：2.3972 -&gt; 1.6517 C；RMSE：2.9748 -&gt; 2.3648 C</a:t>
+            </a:r>
+          </a:p>
+          <a:p>
+            <a:pPr>
+              <a:lnSpc>
+                <a:spcPct val="112000"/>
+              </a:lnSpc>
+              <a:spcAft>
+                <a:spcPts val="900"/>
+              </a:spcAft>
+              <a:defRPr sz="2000">
+                <a:solidFill>
+                  <a:srgbClr val="1E2733"/>
+                </a:solidFill>
+                <a:latin typeface="Noto Sans TC"/>
+              </a:defRPr>
+            </a:pPr>
+            <a:r>
+              <a:rPr sz="2000" b="0">
+                <a:solidFill>
+                  <a:srgbClr val="1E2733"/>
+                </a:solidFill>
+                <a:latin typeface="Noto Sans TC"/>
+              </a:rPr>
+              <a:t>• 逐感測器勝出 30/42；配對改善 0.7455 C</a:t>
+            </a:r>
+          </a:p>
+          <a:p>
+            <a:pPr>
+              <a:lnSpc>
+                <a:spcPct val="112000"/>
+              </a:lnSpc>
+              <a:spcAft>
+                <a:spcPts val="900"/>
+              </a:spcAft>
+              <a:defRPr sz="2000">
+                <a:solidFill>
+                  <a:srgbClr val="1E2733"/>
+                </a:solidFill>
+                <a:latin typeface="Noto Sans TC"/>
+              </a:defRPr>
+            </a:pPr>
+            <a:r>
+              <a:rPr sz="2000" b="0">
+                <a:solidFill>
+                  <a:srgbClr val="1E2733"/>
+                </a:solidFill>
+                <a:latin typeface="Noto Sans TC"/>
+              </a:rPr>
+              <a:t>• 20,000 次日區塊 bootstrap 95% CI：[0.6867, 0.8124] C</a:t>
+            </a:r>
+          </a:p>
+          <a:p>
+            <a:pPr>
+              <a:lnSpc>
+                <a:spcPct val="112000"/>
+              </a:lnSpc>
+              <a:spcAft>
+                <a:spcPts val="900"/>
+              </a:spcAft>
+              <a:defRPr sz="2000">
+                <a:solidFill>
+                  <a:srgbClr val="1E2733"/>
+                </a:solidFill>
+                <a:latin typeface="Noto Sans TC"/>
+              </a:defRPr>
+            </a:pPr>
+            <a:r>
+              <a:rPr sz="2000" b="0">
+                <a:solidFill>
+                  <a:srgbClr val="1E2733"/>
+                </a:solidFill>
+                <a:latin typeface="Noto Sans TC"/>
+              </a:rPr>
+              <a:t>• 限制：預測性角色資訊，不是氣流因果；仍屬次要機箱證據</a:t>
+            </a:r>
+          </a:p>
+        </p:txBody>
+      </p:sp>
+      <p:sp>
+        <p:nvSpPr>
+          <p:cNvPr id="6" name="footer_page_number"/>
+          <p:cNvSpPr txBox="1"/>
+          <p:nvPr/>
+        </p:nvSpPr>
+        <p:spPr>
+          <a:xfrm>
+            <a:off x="11201400" y="6400800"/>
+            <a:ext cx="548640" cy="228600"/>
+          </a:xfrm>
+          <a:prstGeom prst="rect">
+            <a:avLst/>
+          </a:prstGeom>
+          <a:noFill/>
+        </p:spPr>
+        <p:txBody>
+          <a:bodyPr wrap="none">
+            <a:spAutoFit/>
+          </a:bodyPr>
+          <a:lstStyle/>
+          <a:p>
+            <a:pPr algn="r"/>
+            <a:r>
+              <a:rPr sz="900">
+                <a:solidFill>
+                  <a:srgbClr val="46505C"/>
+                </a:solidFill>
+                <a:latin typeface="Arial"/>
+              </a:rPr>
+              <a:t>43</a:t>
+            </a:r>
+          </a:p>
+        </p:txBody>
+      </p:sp>
+    </p:spTree>
+  </p:cSld>
+  <p:clrMapOvr>
+    <a:masterClrMapping/>
+  </p:clrMapOvr>
+</p:sld>
+</file>
+
+<file path=ppt/slides/slide44.xml><?xml version="1.0" encoding="utf-8"?>
+<p:sld xmlns:a="http://schemas.openxmlformats.org/drawingml/2006/main" xmlns:p="http://schemas.openxmlformats.org/presentationml/2006/main" xmlns:r="http://schemas.openxmlformats.org/officeDocument/2006/relationships">
+  <p:cSld>
+    <p:bg>
+      <p:bgPr>
+        <a:solidFill>
+          <a:srgbClr val="F4F7FB"/>
+        </a:solidFill>
+        <a:effectLst/>
+      </p:bgPr>
+    </p:bg>
+    <p:spTree>
+      <p:nvGrpSpPr>
+        <p:cNvPr id="1" name=""/>
+        <p:cNvGrpSpPr/>
+        <p:nvPr/>
+      </p:nvGrpSpPr>
+      <p:grpSpPr/>
+      <p:sp>
+        <p:nvSpPr>
+          <p:cNvPr id="2" name="Rectangle 1"/>
+          <p:cNvSpPr/>
+          <p:nvPr/>
+        </p:nvSpPr>
+        <p:spPr>
+          <a:xfrm>
+            <a:off x="0" y="0"/>
+            <a:ext cx="12191695" cy="896112"/>
+          </a:xfrm>
+          <a:prstGeom prst="rect">
+            <a:avLst/>
+          </a:prstGeom>
+          <a:solidFill>
+            <a:srgbClr val="122033"/>
+          </a:solidFill>
+          <a:ln>
+            <a:solidFill>
+              <a:srgbClr val="122033"/>
+            </a:solidFill>
+          </a:ln>
+        </p:spPr>
+        <p:style>
+          <a:lnRef idx="1">
+            <a:schemeClr val="accent1"/>
+          </a:lnRef>
+          <a:fillRef idx="3">
+            <a:schemeClr val="accent1"/>
+          </a:fillRef>
+          <a:effectRef idx="2">
+            <a:schemeClr val="accent1"/>
+          </a:effectRef>
+          <a:fontRef idx="minor">
+            <a:schemeClr val="lt1"/>
+          </a:fontRef>
+        </p:style>
+        <p:txBody>
+          <a:bodyPr rtlCol="0" anchor="ctr"/>
+          <a:lstStyle/>
+          <a:p>
+            <a:pPr algn="ctr"/>
+          </a:p>
+        </p:txBody>
+      </p:sp>
+      <p:sp>
+        <p:nvSpPr>
+          <p:cNvPr id="3" name="Rectangle 2"/>
+          <p:cNvSpPr/>
+          <p:nvPr/>
+        </p:nvSpPr>
+        <p:spPr>
+          <a:xfrm>
+            <a:off x="0" y="868680"/>
+            <a:ext cx="12191695" cy="27432"/>
+          </a:xfrm>
+          <a:prstGeom prst="rect">
+            <a:avLst/>
+          </a:prstGeom>
+          <a:solidFill>
+            <a:srgbClr val="2D9BC8"/>
+          </a:solidFill>
+          <a:ln>
+            <a:solidFill>
+              <a:srgbClr val="2D9BC8"/>
+            </a:solidFill>
+          </a:ln>
+        </p:spPr>
+        <p:style>
+          <a:lnRef idx="1">
+            <a:schemeClr val="accent1"/>
+          </a:lnRef>
+          <a:fillRef idx="3">
+            <a:schemeClr val="accent1"/>
+          </a:fillRef>
+          <a:effectRef idx="2">
+            <a:schemeClr val="accent1"/>
+          </a:effectRef>
+          <a:fontRef idx="minor">
+            <a:schemeClr val="lt1"/>
+          </a:fontRef>
+        </p:style>
+        <p:txBody>
+          <a:bodyPr rtlCol="0" anchor="ctr"/>
+          <a:lstStyle/>
+          <a:p>
+            <a:pPr algn="ctr"/>
+          </a:p>
+        </p:txBody>
+      </p:sp>
+      <p:sp>
+        <p:nvSpPr>
+          <p:cNvPr id="4" name="TextBox 3"/>
+          <p:cNvSpPr txBox="1"/>
+          <p:nvPr/>
+        </p:nvSpPr>
+        <p:spPr>
+          <a:xfrm>
+            <a:off x="530352" y="109728"/>
+            <a:ext cx="11155680" cy="438912"/>
+          </a:xfrm>
+          <a:prstGeom prst="rect">
+            <a:avLst/>
+          </a:prstGeom>
+          <a:noFill/>
+        </p:spPr>
+        <p:txBody>
+          <a:bodyPr wrap="square" lIns="0" rIns="0" tIns="0" bIns="0">
+            <a:normAutofit/>
+          </a:bodyPr>
+          <a:lstStyle/>
+          <a:p>
+            <a:r>
+              <a:rPr sz="2200" b="1">
+                <a:solidFill>
+                  <a:srgbClr val="FFFFFF"/>
+                </a:solidFill>
+                <a:latin typeface="Noto Sans TC"/>
+              </a:rPr>
+              <a:t>E11E：平均改善，但尾端 gate 未通過</a:t>
+            </a:r>
+          </a:p>
+        </p:txBody>
+      </p:sp>
+      <p:sp>
+        <p:nvSpPr>
+          <p:cNvPr id="5" name="TextBox 4"/>
+          <p:cNvSpPr txBox="1"/>
+          <p:nvPr/>
+        </p:nvSpPr>
+        <p:spPr>
+          <a:xfrm>
+            <a:off x="822960" y="1417320"/>
+            <a:ext cx="10515600" cy="4800600"/>
+          </a:xfrm>
+          <a:prstGeom prst="rect">
+            <a:avLst/>
+          </a:prstGeom>
+          <a:noFill/>
+        </p:spPr>
+        <p:txBody>
+          <a:bodyPr wrap="square" lIns="18288" rIns="18288" tIns="18288" bIns="18288">
+            <a:normAutofit/>
+          </a:bodyPr>
+          <a:lstStyle/>
+          <a:p>
+            <a:pPr>
+              <a:lnSpc>
+                <a:spcPct val="112000"/>
+              </a:lnSpc>
+              <a:spcAft>
+                <a:spcPts val="900"/>
+              </a:spcAft>
+              <a:defRPr sz="2000">
+                <a:solidFill>
+                  <a:srgbClr val="1E2733"/>
+                </a:solidFill>
+                <a:latin typeface="Noto Sans TC"/>
+              </a:defRPr>
+            </a:pPr>
+            <a:r>
+              <a:rPr sz="2000" b="0">
+                <a:solidFill>
+                  <a:srgbClr val="1E2733"/>
+                </a:solidFill>
+                <a:latin typeface="Noto Sans TC"/>
+              </a:rPr>
+              <a:t>• 開發集：1,502 分鐘快照；E11F 未下載</a:t>
+            </a:r>
+          </a:p>
+          <a:p>
+            <a:pPr>
+              <a:lnSpc>
+                <a:spcPct val="112000"/>
+              </a:lnSpc>
+              <a:spcAft>
+                <a:spcPts val="900"/>
+              </a:spcAft>
+              <a:defRPr sz="2000">
+                <a:solidFill>
+                  <a:srgbClr val="1E2733"/>
+                </a:solidFill>
+                <a:latin typeface="Noto Sans TC"/>
+              </a:defRPr>
+            </a:pPr>
+            <a:r>
+              <a:rPr sz="2000" b="0">
+                <a:solidFill>
+                  <a:srgbClr val="1E2733"/>
+                </a:solidFill>
+                <a:latin typeface="Noto Sans TC"/>
+              </a:rPr>
+              <a:t>• Baseline MAE/RMSE/P95：1.1168/1.7250/3.4900 C</a:t>
+            </a:r>
+          </a:p>
+          <a:p>
+            <a:pPr>
+              <a:lnSpc>
+                <a:spcPct val="112000"/>
+              </a:lnSpc>
+              <a:spcAft>
+                <a:spcPts val="900"/>
+              </a:spcAft>
+              <a:defRPr sz="2000">
+                <a:solidFill>
+                  <a:srgbClr val="1E2733"/>
+                </a:solidFill>
+                <a:latin typeface="Noto Sans TC"/>
+              </a:defRPr>
+            </a:pPr>
+            <a:r>
+              <a:rPr sz="2000" b="0">
+                <a:solidFill>
+                  <a:srgbClr val="1E2733"/>
+                </a:solidFill>
+                <a:latin typeface="Noto Sans TC"/>
+              </a:rPr>
+              <a:t>• role_local_k5_p2：1.0187/1.6792/3.7699 C</a:t>
+            </a:r>
+          </a:p>
+          <a:p>
+            <a:pPr>
+              <a:lnSpc>
+                <a:spcPct val="112000"/>
+              </a:lnSpc>
+              <a:spcAft>
+                <a:spcPts val="900"/>
+              </a:spcAft>
+              <a:defRPr sz="2000">
+                <a:solidFill>
+                  <a:srgbClr val="1E2733"/>
+                </a:solidFill>
+                <a:latin typeface="Noto Sans TC"/>
+              </a:defRPr>
+            </a:pPr>
+            <a:r>
+              <a:rPr sz="2000" b="0">
+                <a:solidFill>
+                  <a:srgbClr val="1E2733"/>
+                </a:solidFill>
+                <a:latin typeface="Noto Sans TC"/>
+              </a:rPr>
+              <a:t>• Bootstrap CI：[0.0708, 0.1292] C；但只贏 25/42</a:t>
+            </a:r>
+          </a:p>
+          <a:p>
+            <a:pPr>
+              <a:lnSpc>
+                <a:spcPct val="112000"/>
+              </a:lnSpc>
+              <a:spcAft>
+                <a:spcPts val="900"/>
+              </a:spcAft>
+              <a:defRPr sz="2000">
+                <a:solidFill>
+                  <a:srgbClr val="1E2733"/>
+                </a:solidFill>
+                <a:latin typeface="Noto Sans TC"/>
+              </a:defRPr>
+            </a:pPr>
+            <a:r>
+              <a:rPr sz="2000" b="0">
+                <a:solidFill>
+                  <a:srgbClr val="1E2733"/>
+                </a:solidFill>
+                <a:latin typeface="Noto Sans TC"/>
+              </a:rPr>
+              <a:t>• 決策：no_candidate_forwarded，不宣稱確認改善</a:t>
+            </a:r>
+          </a:p>
+        </p:txBody>
+      </p:sp>
+      <p:sp>
+        <p:nvSpPr>
+          <p:cNvPr id="6" name="footer_page_number"/>
+          <p:cNvSpPr txBox="1"/>
+          <p:nvPr/>
+        </p:nvSpPr>
+        <p:spPr>
+          <a:xfrm>
+            <a:off x="11201400" y="6400800"/>
+            <a:ext cx="548640" cy="228600"/>
+          </a:xfrm>
+          <a:prstGeom prst="rect">
+            <a:avLst/>
+          </a:prstGeom>
+          <a:noFill/>
+        </p:spPr>
+        <p:txBody>
+          <a:bodyPr wrap="none">
+            <a:spAutoFit/>
+          </a:bodyPr>
+          <a:lstStyle/>
+          <a:p>
+            <a:pPr algn="r"/>
+            <a:r>
+              <a:rPr sz="900">
+                <a:solidFill>
+                  <a:srgbClr val="46505C"/>
+                </a:solidFill>
+                <a:latin typeface="Arial"/>
+              </a:rPr>
+              <a:t>44</a:t>
+            </a:r>
+          </a:p>
+        </p:txBody>
+      </p:sp>
+    </p:spTree>
+  </p:cSld>
+  <p:clrMapOvr>
+    <a:masterClrMapping/>
+  </p:clrMapOvr>
+</p:sld>
+</file>
+
+<file path=ppt/slides/slide45.xml><?xml version="1.0" encoding="utf-8"?>
+<p:sld xmlns:a="http://schemas.openxmlformats.org/drawingml/2006/main" xmlns:p="http://schemas.openxmlformats.org/presentationml/2006/main" xmlns:r="http://schemas.openxmlformats.org/officeDocument/2006/relationships">
+  <p:cSld>
+    <p:bg>
+      <p:bgPr>
+        <a:solidFill>
+          <a:srgbClr val="F4F7FB"/>
+        </a:solidFill>
+        <a:effectLst/>
+      </p:bgPr>
+    </p:bg>
+    <p:spTree>
+      <p:nvGrpSpPr>
+        <p:cNvPr id="1" name=""/>
+        <p:cNvGrpSpPr/>
+        <p:nvPr/>
+      </p:nvGrpSpPr>
+      <p:grpSpPr/>
+      <p:sp>
+        <p:nvSpPr>
+          <p:cNvPr id="2" name="Rectangle 1"/>
+          <p:cNvSpPr/>
+          <p:nvPr/>
+        </p:nvSpPr>
+        <p:spPr>
+          <a:xfrm>
+            <a:off x="0" y="0"/>
+            <a:ext cx="12191695" cy="896112"/>
+          </a:xfrm>
+          <a:prstGeom prst="rect">
+            <a:avLst/>
+          </a:prstGeom>
+          <a:solidFill>
+            <a:srgbClr val="122033"/>
+          </a:solidFill>
+          <a:ln>
+            <a:solidFill>
+              <a:srgbClr val="122033"/>
+            </a:solidFill>
+          </a:ln>
+        </p:spPr>
+        <p:style>
+          <a:lnRef idx="1">
+            <a:schemeClr val="accent1"/>
+          </a:lnRef>
+          <a:fillRef idx="3">
+            <a:schemeClr val="accent1"/>
+          </a:fillRef>
+          <a:effectRef idx="2">
+            <a:schemeClr val="accent1"/>
+          </a:effectRef>
+          <a:fontRef idx="minor">
+            <a:schemeClr val="lt1"/>
+          </a:fontRef>
+        </p:style>
+        <p:txBody>
+          <a:bodyPr rtlCol="0" anchor="ctr"/>
+          <a:lstStyle/>
+          <a:p>
+            <a:pPr algn="ctr"/>
+          </a:p>
+        </p:txBody>
+      </p:sp>
+      <p:sp>
+        <p:nvSpPr>
+          <p:cNvPr id="3" name="Rectangle 2"/>
+          <p:cNvSpPr/>
+          <p:nvPr/>
+        </p:nvSpPr>
+        <p:spPr>
+          <a:xfrm>
+            <a:off x="0" y="868680"/>
+            <a:ext cx="12191695" cy="27432"/>
+          </a:xfrm>
+          <a:prstGeom prst="rect">
+            <a:avLst/>
+          </a:prstGeom>
+          <a:solidFill>
+            <a:srgbClr val="2D9BC8"/>
+          </a:solidFill>
+          <a:ln>
+            <a:solidFill>
+              <a:srgbClr val="2D9BC8"/>
+            </a:solidFill>
+          </a:ln>
+        </p:spPr>
+        <p:style>
+          <a:lnRef idx="1">
+            <a:schemeClr val="accent1"/>
+          </a:lnRef>
+          <a:fillRef idx="3">
+            <a:schemeClr val="accent1"/>
+          </a:fillRef>
+          <a:effectRef idx="2">
+            <a:schemeClr val="accent1"/>
+          </a:effectRef>
+          <a:fontRef idx="minor">
+            <a:schemeClr val="lt1"/>
+          </a:fontRef>
+        </p:style>
+        <p:txBody>
+          <a:bodyPr rtlCol="0" anchor="ctr"/>
+          <a:lstStyle/>
+          <a:p>
+            <a:pPr algn="ctr"/>
+          </a:p>
+        </p:txBody>
+      </p:sp>
+      <p:sp>
+        <p:nvSpPr>
+          <p:cNvPr id="4" name="TextBox 3"/>
+          <p:cNvSpPr txBox="1"/>
+          <p:nvPr/>
+        </p:nvSpPr>
+        <p:spPr>
+          <a:xfrm>
+            <a:off x="530352" y="109728"/>
+            <a:ext cx="11155680" cy="438912"/>
+          </a:xfrm>
+          <a:prstGeom prst="rect">
+            <a:avLst/>
+          </a:prstGeom>
+          <a:noFill/>
+        </p:spPr>
+        <p:txBody>
+          <a:bodyPr wrap="square" lIns="0" rIns="0" tIns="0" bIns="0">
+            <a:normAutofit/>
+          </a:bodyPr>
+          <a:lstStyle/>
+          <a:p>
+            <a:r>
+              <a:rPr sz="2200" b="1">
+                <a:solidFill>
+                  <a:srgbClr val="FFFFFF"/>
+                </a:solidFill>
+                <a:latin typeface="Noto Sans TC"/>
+              </a:rPr>
+              <a:t>E11G tail-safe：尾端改善但覆蓋未過</a:t>
+            </a:r>
+          </a:p>
+        </p:txBody>
+      </p:sp>
+      <p:sp>
+        <p:nvSpPr>
+          <p:cNvPr id="5" name="TextBox 4"/>
+          <p:cNvSpPr txBox="1"/>
+          <p:nvPr/>
+        </p:nvSpPr>
+        <p:spPr>
+          <a:xfrm>
+            <a:off x="822960" y="1417320"/>
+            <a:ext cx="10515600" cy="4800600"/>
+          </a:xfrm>
+          <a:prstGeom prst="rect">
+            <a:avLst/>
+          </a:prstGeom>
+          <a:noFill/>
+        </p:spPr>
+        <p:txBody>
+          <a:bodyPr wrap="square" lIns="18288" rIns="18288" tIns="18288" bIns="18288">
+            <a:normAutofit/>
+          </a:bodyPr>
+          <a:lstStyle/>
+          <a:p>
+            <a:pPr>
+              <a:lnSpc>
+                <a:spcPct val="112000"/>
+              </a:lnSpc>
+              <a:spcAft>
+                <a:spcPts val="900"/>
+              </a:spcAft>
+              <a:defRPr sz="2000">
+                <a:solidFill>
+                  <a:srgbClr val="1E2733"/>
+                </a:solidFill>
+                <a:latin typeface="Noto Sans TC"/>
+              </a:defRPr>
+            </a:pPr>
+            <a:r>
+              <a:rPr sz="2000" b="0">
+                <a:solidFill>
+                  <a:srgbClr val="1E2733"/>
+                </a:solidFill>
+                <a:latin typeface="Noto Sans TC"/>
+              </a:rPr>
+              <a:t>• 12 日 leave-one-day-out，42 感測器，30 候選</a:t>
+            </a:r>
+          </a:p>
+          <a:p>
+            <a:pPr>
+              <a:lnSpc>
+                <a:spcPct val="112000"/>
+              </a:lnSpc>
+              <a:spcAft>
+                <a:spcPts val="900"/>
+              </a:spcAft>
+              <a:defRPr sz="2000">
+                <a:solidFill>
+                  <a:srgbClr val="1E2733"/>
+                </a:solidFill>
+                <a:latin typeface="Noto Sans TC"/>
+              </a:defRPr>
+            </a:pPr>
+            <a:r>
+              <a:rPr sz="2000" b="0">
+                <a:solidFill>
+                  <a:srgbClr val="1E2733"/>
+                </a:solidFill>
+                <a:latin typeface="Noto Sans TC"/>
+              </a:rPr>
+              <a:t>• MAE：1.1168 → 0.8945°C</a:t>
+            </a:r>
+          </a:p>
+          <a:p>
+            <a:pPr>
+              <a:lnSpc>
+                <a:spcPct val="112000"/>
+              </a:lnSpc>
+              <a:spcAft>
+                <a:spcPts val="900"/>
+              </a:spcAft>
+              <a:defRPr sz="2000">
+                <a:solidFill>
+                  <a:srgbClr val="1E2733"/>
+                </a:solidFill>
+                <a:latin typeface="Noto Sans TC"/>
+              </a:defRPr>
+            </a:pPr>
+            <a:r>
+              <a:rPr sz="2000" b="0">
+                <a:solidFill>
+                  <a:srgbClr val="1E2733"/>
+                </a:solidFill>
+                <a:latin typeface="Noto Sans TC"/>
+              </a:rPr>
+              <a:t>• RMSE：1.7250 → 1.5415°C</a:t>
+            </a:r>
+          </a:p>
+          <a:p>
+            <a:pPr>
+              <a:lnSpc>
+                <a:spcPct val="112000"/>
+              </a:lnSpc>
+              <a:spcAft>
+                <a:spcPts val="900"/>
+              </a:spcAft>
+              <a:defRPr sz="2000">
+                <a:solidFill>
+                  <a:srgbClr val="1E2733"/>
+                </a:solidFill>
+                <a:latin typeface="Noto Sans TC"/>
+              </a:defRPr>
+            </a:pPr>
+            <a:r>
+              <a:rPr sz="2000" b="0">
+                <a:solidFill>
+                  <a:srgbClr val="1E2733"/>
+                </a:solidFill>
+                <a:latin typeface="Noto Sans TC"/>
+              </a:rPr>
+              <a:t>• P95：3.4900 → 3.1013°C</a:t>
+            </a:r>
+          </a:p>
+          <a:p>
+            <a:pPr>
+              <a:lnSpc>
+                <a:spcPct val="112000"/>
+              </a:lnSpc>
+              <a:spcAft>
+                <a:spcPts val="900"/>
+              </a:spcAft>
+              <a:defRPr sz="2000">
+                <a:solidFill>
+                  <a:srgbClr val="1E2733"/>
+                </a:solidFill>
+                <a:latin typeface="Noto Sans TC"/>
+              </a:defRPr>
+            </a:pPr>
+            <a:r>
+              <a:rPr sz="2000" b="0">
+                <a:solidFill>
+                  <a:srgbClr val="1E2733"/>
+                </a:solidFill>
+                <a:latin typeface="Noto Sans TC"/>
+              </a:rPr>
+              <a:t>• 日區塊改善 95% CI：[0.1847, 0.2620]°C</a:t>
+            </a:r>
+          </a:p>
+          <a:p>
+            <a:pPr>
+              <a:lnSpc>
+                <a:spcPct val="112000"/>
+              </a:lnSpc>
+              <a:spcAft>
+                <a:spcPts val="900"/>
+              </a:spcAft>
+              <a:defRPr sz="2000">
+                <a:solidFill>
+                  <a:srgbClr val="1E2733"/>
+                </a:solidFill>
+                <a:latin typeface="Noto Sans TC"/>
+              </a:defRPr>
+            </a:pPr>
+            <a:r>
+              <a:rPr sz="2000" b="0">
+                <a:solidFill>
+                  <a:srgbClr val="1E2733"/>
+                </a:solidFill>
+                <a:latin typeface="Noto Sans TC"/>
+              </a:rPr>
+              <a:t>• 嚴格勝率 21/42 &lt; 26/42；no_candidate_forwarded，E11F 未存取</a:t>
+            </a:r>
+          </a:p>
+        </p:txBody>
+      </p:sp>
+      <p:sp>
+        <p:nvSpPr>
+          <p:cNvPr id="6" name="footer_page_number"/>
+          <p:cNvSpPr txBox="1"/>
+          <p:nvPr/>
+        </p:nvSpPr>
+        <p:spPr>
+          <a:xfrm>
+            <a:off x="11201400" y="6400800"/>
+            <a:ext cx="548640" cy="228600"/>
+          </a:xfrm>
+          <a:prstGeom prst="rect">
+            <a:avLst/>
+          </a:prstGeom>
+          <a:noFill/>
+        </p:spPr>
+        <p:txBody>
+          <a:bodyPr wrap="none">
+            <a:spAutoFit/>
+          </a:bodyPr>
+          <a:lstStyle/>
+          <a:p>
+            <a:pPr algn="r"/>
+            <a:r>
+              <a:rPr sz="900">
+                <a:solidFill>
+                  <a:srgbClr val="46505C"/>
+                </a:solidFill>
+                <a:latin typeface="Arial"/>
+              </a:rPr>
+              <a:t>45</a:t>
+            </a:r>
+          </a:p>
+        </p:txBody>
+      </p:sp>
+    </p:spTree>
+  </p:cSld>
+  <p:clrMapOvr>
+    <a:masterClrMapping/>
+  </p:clrMapOvr>
+</p:sld>
+</file>
+
+<file path=ppt/slides/slide46.xml><?xml version="1.0" encoding="utf-8"?>
+<p:sld xmlns:a="http://schemas.openxmlformats.org/drawingml/2006/main" xmlns:p="http://schemas.openxmlformats.org/presentationml/2006/main" xmlns:r="http://schemas.openxmlformats.org/officeDocument/2006/relationships">
+  <p:cSld>
+    <p:bg>
+      <p:bgPr>
+        <a:solidFill>
+          <a:srgbClr val="F4F7FB"/>
+        </a:solidFill>
+        <a:effectLst/>
+      </p:bgPr>
+    </p:bg>
+    <p:spTree>
+      <p:nvGrpSpPr>
+        <p:cNvPr id="1" name=""/>
+        <p:cNvGrpSpPr/>
+        <p:nvPr/>
+      </p:nvGrpSpPr>
+      <p:grpSpPr/>
+      <p:sp>
+        <p:nvSpPr>
+          <p:cNvPr id="2" name="Rectangle 1"/>
+          <p:cNvSpPr/>
+          <p:nvPr/>
+        </p:nvSpPr>
+        <p:spPr>
+          <a:xfrm>
+            <a:off x="0" y="0"/>
+            <a:ext cx="12191695" cy="896112"/>
+          </a:xfrm>
+          <a:prstGeom prst="rect">
+            <a:avLst/>
+          </a:prstGeom>
+          <a:solidFill>
+            <a:srgbClr val="122033"/>
+          </a:solidFill>
+          <a:ln>
+            <a:solidFill>
+              <a:srgbClr val="122033"/>
+            </a:solidFill>
+          </a:ln>
+        </p:spPr>
+        <p:style>
+          <a:lnRef idx="1">
+            <a:schemeClr val="accent1"/>
+          </a:lnRef>
+          <a:fillRef idx="3">
+            <a:schemeClr val="accent1"/>
+          </a:fillRef>
+          <a:effectRef idx="2">
+            <a:schemeClr val="accent1"/>
+          </a:effectRef>
+          <a:fontRef idx="minor">
+            <a:schemeClr val="lt1"/>
+          </a:fontRef>
+        </p:style>
+        <p:txBody>
+          <a:bodyPr rtlCol="0" anchor="ctr"/>
+          <a:lstStyle/>
+          <a:p>
+            <a:pPr algn="ctr"/>
+          </a:p>
+        </p:txBody>
+      </p:sp>
+      <p:sp>
+        <p:nvSpPr>
+          <p:cNvPr id="3" name="Rectangle 2"/>
+          <p:cNvSpPr/>
+          <p:nvPr/>
+        </p:nvSpPr>
+        <p:spPr>
+          <a:xfrm>
+            <a:off x="0" y="868680"/>
+            <a:ext cx="12191695" cy="27432"/>
+          </a:xfrm>
+          <a:prstGeom prst="rect">
+            <a:avLst/>
+          </a:prstGeom>
+          <a:solidFill>
+            <a:srgbClr val="2D9BC8"/>
+          </a:solidFill>
+          <a:ln>
+            <a:solidFill>
+              <a:srgbClr val="2D9BC8"/>
+            </a:solidFill>
+          </a:ln>
+        </p:spPr>
+        <p:style>
+          <a:lnRef idx="1">
+            <a:schemeClr val="accent1"/>
+          </a:lnRef>
+          <a:fillRef idx="3">
+            <a:schemeClr val="accent1"/>
+          </a:fillRef>
+          <a:effectRef idx="2">
+            <a:schemeClr val="accent1"/>
+          </a:effectRef>
+          <a:fontRef idx="minor">
+            <a:schemeClr val="lt1"/>
+          </a:fontRef>
+        </p:style>
+        <p:txBody>
+          <a:bodyPr rtlCol="0" anchor="ctr"/>
+          <a:lstStyle/>
+          <a:p>
+            <a:pPr algn="ctr"/>
+          </a:p>
+        </p:txBody>
+      </p:sp>
+      <p:sp>
+        <p:nvSpPr>
+          <p:cNvPr id="4" name="TextBox 3"/>
+          <p:cNvSpPr txBox="1"/>
+          <p:nvPr/>
+        </p:nvSpPr>
+        <p:spPr>
+          <a:xfrm>
+            <a:off x="530352" y="109728"/>
+            <a:ext cx="11155680" cy="438912"/>
+          </a:xfrm>
+          <a:prstGeom prst="rect">
+            <a:avLst/>
+          </a:prstGeom>
+          <a:noFill/>
+        </p:spPr>
+        <p:txBody>
+          <a:bodyPr wrap="square" lIns="0" rIns="0" tIns="0" bIns="0">
+            <a:normAutofit/>
+          </a:bodyPr>
+          <a:lstStyle/>
+          <a:p>
+            <a:r>
+              <a:rPr sz="2200" b="1">
+                <a:solidFill>
+                  <a:srgbClr val="FFFFFF"/>
+                </a:solidFill>
+                <a:latin typeface="Noto Sans TC"/>
+              </a:rPr>
+              <a:t>E11H commissioning：開發通過</a:t>
+            </a:r>
+          </a:p>
+        </p:txBody>
+      </p:sp>
+      <p:sp>
+        <p:nvSpPr>
+          <p:cNvPr id="5" name="TextBox 4"/>
+          <p:cNvSpPr txBox="1"/>
+          <p:nvPr/>
+        </p:nvSpPr>
+        <p:spPr>
+          <a:xfrm>
+            <a:off x="822960" y="1417320"/>
+            <a:ext cx="10515600" cy="4800600"/>
+          </a:xfrm>
+          <a:prstGeom prst="rect">
+            <a:avLst/>
+          </a:prstGeom>
+          <a:noFill/>
+        </p:spPr>
+        <p:txBody>
+          <a:bodyPr wrap="square" lIns="18288" rIns="18288" tIns="18288" bIns="18288">
+            <a:normAutofit/>
+          </a:bodyPr>
+          <a:lstStyle/>
+          <a:p>
+            <a:pPr>
+              <a:lnSpc>
+                <a:spcPct val="112000"/>
+              </a:lnSpc>
+              <a:spcAft>
+                <a:spcPts val="900"/>
+              </a:spcAft>
+              <a:defRPr sz="2000">
+                <a:solidFill>
+                  <a:srgbClr val="1E2733"/>
+                </a:solidFill>
+                <a:latin typeface="Noto Sans TC"/>
+              </a:defRPr>
+            </a:pPr>
+            <a:r>
+              <a:rPr sz="2000" b="0">
+                <a:solidFill>
+                  <a:srgbClr val="1E2733"/>
+                </a:solidFill>
+                <a:latin typeface="Noto Sans TC"/>
+              </a:rPr>
+              <a:t>• 2 日校正、1 日選模、9 日凍結測試</a:t>
+            </a:r>
+          </a:p>
+          <a:p>
+            <a:pPr>
+              <a:lnSpc>
+                <a:spcPct val="112000"/>
+              </a:lnSpc>
+              <a:spcAft>
+                <a:spcPts val="900"/>
+              </a:spcAft>
+              <a:defRPr sz="2000">
+                <a:solidFill>
+                  <a:srgbClr val="1E2733"/>
+                </a:solidFill>
+                <a:latin typeface="Noto Sans TC"/>
+              </a:defRPr>
+            </a:pPr>
+            <a:r>
+              <a:rPr sz="2000" b="0">
+                <a:solidFill>
+                  <a:srgbClr val="1E2733"/>
+                </a:solidFill>
+                <a:latin typeface="Noto Sans TC"/>
+              </a:rPr>
+              <a:t>• MAE：1.0958 → 0.4039°C；P95：3.5061 → 1.2900°C</a:t>
+            </a:r>
+          </a:p>
+          <a:p>
+            <a:pPr>
+              <a:lnSpc>
+                <a:spcPct val="112000"/>
+              </a:lnSpc>
+              <a:spcAft>
+                <a:spcPts val="900"/>
+              </a:spcAft>
+              <a:defRPr sz="2000">
+                <a:solidFill>
+                  <a:srgbClr val="1E2733"/>
+                </a:solidFill>
+                <a:latin typeface="Noto Sans TC"/>
+              </a:defRPr>
+            </a:pPr>
+            <a:r>
+              <a:rPr sz="2000" b="0">
+                <a:solidFill>
+                  <a:srgbClr val="1E2733"/>
+                </a:solidFill>
+                <a:latin typeface="Noto Sans TC"/>
+              </a:rPr>
+              <a:t>• 39/42 感測器改善；95% CI：[0.4854, 0.9271]°C</a:t>
+            </a:r>
+          </a:p>
+          <a:p>
+            <a:pPr>
+              <a:lnSpc>
+                <a:spcPct val="112000"/>
+              </a:lnSpc>
+              <a:spcAft>
+                <a:spcPts val="900"/>
+              </a:spcAft>
+              <a:defRPr sz="2000">
+                <a:solidFill>
+                  <a:srgbClr val="1E2733"/>
+                </a:solidFill>
+                <a:latin typeface="Noto Sans TC"/>
+              </a:defRPr>
+            </a:pPr>
+            <a:r>
+              <a:rPr sz="2000" b="0">
+                <a:solidFill>
+                  <a:srgbClr val="1E2733"/>
+                </a:solidFill>
+                <a:latin typeface="Noto Sans TC"/>
+              </a:rPr>
+              <a:t>• 限制：Huber slope 邊界與 commissioning prerequisite</a:t>
+            </a:r>
+          </a:p>
+        </p:txBody>
+      </p:sp>
+      <p:sp>
+        <p:nvSpPr>
+          <p:cNvPr id="6" name="footer_page_number"/>
+          <p:cNvSpPr txBox="1"/>
+          <p:nvPr/>
+        </p:nvSpPr>
+        <p:spPr>
+          <a:xfrm>
+            <a:off x="11201400" y="6400800"/>
+            <a:ext cx="548640" cy="228600"/>
+          </a:xfrm>
+          <a:prstGeom prst="rect">
+            <a:avLst/>
+          </a:prstGeom>
+          <a:noFill/>
+        </p:spPr>
+        <p:txBody>
+          <a:bodyPr wrap="none">
+            <a:spAutoFit/>
+          </a:bodyPr>
+          <a:lstStyle/>
+          <a:p>
+            <a:pPr algn="r"/>
+            <a:r>
+              <a:rPr sz="900">
+                <a:solidFill>
+                  <a:srgbClr val="46505C"/>
+                </a:solidFill>
+                <a:latin typeface="Arial"/>
+              </a:rPr>
+              <a:t>46</a:t>
+            </a:r>
+          </a:p>
+        </p:txBody>
+      </p:sp>
+    </p:spTree>
+  </p:cSld>
+  <p:clrMapOvr>
+    <a:masterClrMapping/>
+  </p:clrMapOvr>
+</p:sld>
+</file>
+
+<file path=ppt/slides/slide47.xml><?xml version="1.0" encoding="utf-8"?>
+<p:sld xmlns:a="http://schemas.openxmlformats.org/drawingml/2006/main" xmlns:p="http://schemas.openxmlformats.org/presentationml/2006/main" xmlns:r="http://schemas.openxmlformats.org/officeDocument/2006/relationships">
+  <p:cSld>
+    <p:bg>
+      <p:bgPr>
+        <a:solidFill>
+          <a:srgbClr val="F4F7FB"/>
+        </a:solidFill>
+        <a:effectLst/>
+      </p:bgPr>
+    </p:bg>
+    <p:spTree>
+      <p:nvGrpSpPr>
+        <p:cNvPr id="1" name=""/>
+        <p:cNvGrpSpPr/>
+        <p:nvPr/>
+      </p:nvGrpSpPr>
+      <p:grpSpPr/>
+      <p:sp>
+        <p:nvSpPr>
+          <p:cNvPr id="2" name="Rectangle 1"/>
+          <p:cNvSpPr/>
+          <p:nvPr/>
+        </p:nvSpPr>
+        <p:spPr>
+          <a:xfrm>
+            <a:off x="0" y="0"/>
+            <a:ext cx="12191695" cy="896112"/>
+          </a:xfrm>
+          <a:prstGeom prst="rect">
+            <a:avLst/>
+          </a:prstGeom>
+          <a:solidFill>
+            <a:srgbClr val="122033"/>
+          </a:solidFill>
+          <a:ln>
+            <a:solidFill>
+              <a:srgbClr val="122033"/>
+            </a:solidFill>
+          </a:ln>
+        </p:spPr>
+        <p:style>
+          <a:lnRef idx="1">
+            <a:schemeClr val="accent1"/>
+          </a:lnRef>
+          <a:fillRef idx="3">
+            <a:schemeClr val="accent1"/>
+          </a:fillRef>
+          <a:effectRef idx="2">
+            <a:schemeClr val="accent1"/>
+          </a:effectRef>
+          <a:fontRef idx="minor">
+            <a:schemeClr val="lt1"/>
+          </a:fontRef>
+        </p:style>
+        <p:txBody>
+          <a:bodyPr rtlCol="0" anchor="ctr"/>
+          <a:lstStyle/>
+          <a:p>
+            <a:pPr algn="ctr"/>
+          </a:p>
+        </p:txBody>
+      </p:sp>
+      <p:sp>
+        <p:nvSpPr>
+          <p:cNvPr id="3" name="Rectangle 2"/>
+          <p:cNvSpPr/>
+          <p:nvPr/>
+        </p:nvSpPr>
+        <p:spPr>
+          <a:xfrm>
+            <a:off x="0" y="868680"/>
+            <a:ext cx="12191695" cy="27432"/>
+          </a:xfrm>
+          <a:prstGeom prst="rect">
+            <a:avLst/>
+          </a:prstGeom>
+          <a:solidFill>
+            <a:srgbClr val="2D9BC8"/>
+          </a:solidFill>
+          <a:ln>
+            <a:solidFill>
+              <a:srgbClr val="2D9BC8"/>
+            </a:solidFill>
+          </a:ln>
+        </p:spPr>
+        <p:style>
+          <a:lnRef idx="1">
+            <a:schemeClr val="accent1"/>
+          </a:lnRef>
+          <a:fillRef idx="3">
+            <a:schemeClr val="accent1"/>
+          </a:fillRef>
+          <a:effectRef idx="2">
+            <a:schemeClr val="accent1"/>
+          </a:effectRef>
+          <a:fontRef idx="minor">
+            <a:schemeClr val="lt1"/>
+          </a:fontRef>
+        </p:style>
+        <p:txBody>
+          <a:bodyPr rtlCol="0" anchor="ctr"/>
+          <a:lstStyle/>
+          <a:p>
+            <a:pPr algn="ctr"/>
+          </a:p>
+        </p:txBody>
+      </p:sp>
+      <p:sp>
+        <p:nvSpPr>
+          <p:cNvPr id="4" name="TextBox 3"/>
+          <p:cNvSpPr txBox="1"/>
+          <p:nvPr/>
+        </p:nvSpPr>
+        <p:spPr>
+          <a:xfrm>
+            <a:off x="530352" y="109728"/>
+            <a:ext cx="11155680" cy="438912"/>
+          </a:xfrm>
+          <a:prstGeom prst="rect">
+            <a:avLst/>
+          </a:prstGeom>
+          <a:noFill/>
+        </p:spPr>
+        <p:txBody>
+          <a:bodyPr wrap="square" lIns="0" rIns="0" tIns="0" bIns="0">
+            <a:normAutofit/>
+          </a:bodyPr>
+          <a:lstStyle/>
+          <a:p>
+            <a:r>
+              <a:rPr sz="2000" b="1">
+                <a:solidFill>
+                  <a:srgbClr val="FFFFFF"/>
+                </a:solidFill>
+                <a:latin typeface="Noto Sans TC"/>
+              </a:rPr>
+              <a:t>E11F：frozen no-refit confirmation</a:t>
+            </a:r>
+          </a:p>
+        </p:txBody>
+      </p:sp>
+      <p:sp>
+        <p:nvSpPr>
+          <p:cNvPr id="5" name="TextBox 4"/>
+          <p:cNvSpPr txBox="1"/>
+          <p:nvPr/>
+        </p:nvSpPr>
+        <p:spPr>
+          <a:xfrm>
+            <a:off x="822960" y="1417320"/>
+            <a:ext cx="10515600" cy="4800600"/>
+          </a:xfrm>
+          <a:prstGeom prst="rect">
+            <a:avLst/>
+          </a:prstGeom>
+          <a:noFill/>
+        </p:spPr>
+        <p:txBody>
+          <a:bodyPr wrap="square" lIns="18288" rIns="18288" tIns="18288" bIns="18288">
+            <a:normAutofit/>
+          </a:bodyPr>
+          <a:lstStyle/>
+          <a:p>
+            <a:pPr>
+              <a:lnSpc>
+                <a:spcPct val="112000"/>
+              </a:lnSpc>
+              <a:spcAft>
+                <a:spcPts val="900"/>
+              </a:spcAft>
+              <a:defRPr sz="2000">
+                <a:solidFill>
+                  <a:srgbClr val="1E2733"/>
+                </a:solidFill>
+                <a:latin typeface="Noto Sans TC"/>
+              </a:defRPr>
+            </a:pPr>
+            <a:r>
+              <a:rPr sz="2000" b="0">
+                <a:solidFill>
+                  <a:srgbClr val="1E2733"/>
+                </a:solidFill>
+                <a:latin typeface="Noto Sans TC"/>
+              </a:rPr>
+              <a:t>• MAE/RMSE/P95：0.3966/0.6723/1.2756°C</a:t>
+            </a:r>
+          </a:p>
+          <a:p>
+            <a:pPr>
+              <a:lnSpc>
+                <a:spcPct val="112000"/>
+              </a:lnSpc>
+              <a:spcAft>
+                <a:spcPts val="900"/>
+              </a:spcAft>
+              <a:defRPr sz="2000">
+                <a:solidFill>
+                  <a:srgbClr val="1E2733"/>
+                </a:solidFill>
+                <a:latin typeface="Noto Sans TC"/>
+              </a:defRPr>
+            </a:pPr>
+            <a:r>
+              <a:rPr sz="2000" b="0">
+                <a:solidFill>
+                  <a:srgbClr val="1E2733"/>
+                </a:solidFill>
+                <a:latin typeface="Noto Sans TC"/>
+              </a:rPr>
+              <a:t>• 39/42 感測器改善；95% CI：[0.5851, 0.9274]°C</a:t>
+            </a:r>
+          </a:p>
+          <a:p>
+            <a:pPr>
+              <a:lnSpc>
+                <a:spcPct val="112000"/>
+              </a:lnSpc>
+              <a:spcAft>
+                <a:spcPts val="900"/>
+              </a:spcAft>
+              <a:defRPr sz="2000">
+                <a:solidFill>
+                  <a:srgbClr val="1E2733"/>
+                </a:solidFill>
+                <a:latin typeface="Noto Sans TC"/>
+              </a:defRPr>
+            </a:pPr>
+            <a:r>
+              <a:rPr sz="2000" b="0">
+                <a:solidFill>
+                  <a:srgbClr val="1E2733"/>
+                </a:solidFill>
+                <a:latin typeface="Noto Sans TC"/>
+              </a:rPr>
+              <a:t>• h_enc_05_supported_within_campaign</a:t>
+            </a:r>
+          </a:p>
+          <a:p>
+            <a:pPr>
+              <a:lnSpc>
+                <a:spcPct val="112000"/>
+              </a:lnSpc>
+              <a:spcAft>
+                <a:spcPts val="900"/>
+              </a:spcAft>
+              <a:defRPr sz="2000">
+                <a:solidFill>
+                  <a:srgbClr val="1E2733"/>
+                </a:solidFill>
+                <a:latin typeface="Noto Sans TC"/>
+              </a:defRPr>
+            </a:pPr>
+            <a:r>
+              <a:rPr sz="2000" b="0">
+                <a:solidFill>
+                  <a:srgbClr val="1E2733"/>
+                </a:solidFill>
+                <a:latin typeface="Noto Sans TC"/>
+              </a:rPr>
+              <a:t>• 日期與開發重疊：僅同 campaign unseen-byte evidence</a:t>
+            </a:r>
+          </a:p>
+          <a:p>
+            <a:pPr>
+              <a:lnSpc>
+                <a:spcPct val="112000"/>
+              </a:lnSpc>
+              <a:spcAft>
+                <a:spcPts val="900"/>
+              </a:spcAft>
+              <a:defRPr sz="2000">
+                <a:solidFill>
+                  <a:srgbClr val="1E2733"/>
+                </a:solidFill>
+                <a:latin typeface="Noto Sans TC"/>
+              </a:defRPr>
+            </a:pPr>
+            <a:r>
+              <a:rPr sz="2000" b="0">
+                <a:solidFill>
+                  <a:srgbClr val="1E2733"/>
+                </a:solidFill>
+                <a:latin typeface="Noto Sans TC"/>
+              </a:rPr>
+              <a:t>• 不是跨機箱、氣流因果或 NTC 硬體驗證</a:t>
+            </a:r>
+          </a:p>
+        </p:txBody>
+      </p:sp>
+      <p:sp>
+        <p:nvSpPr>
+          <p:cNvPr id="6" name="footer_page_number"/>
+          <p:cNvSpPr txBox="1"/>
+          <p:nvPr/>
+        </p:nvSpPr>
+        <p:spPr>
+          <a:xfrm>
+            <a:off x="11201400" y="6400800"/>
+            <a:ext cx="548640" cy="228600"/>
+          </a:xfrm>
+          <a:prstGeom prst="rect">
+            <a:avLst/>
+          </a:prstGeom>
+          <a:noFill/>
+        </p:spPr>
+        <p:txBody>
+          <a:bodyPr wrap="none">
+            <a:spAutoFit/>
+          </a:bodyPr>
+          <a:lstStyle/>
+          <a:p>
+            <a:pPr algn="r"/>
+            <a:r>
+              <a:rPr sz="900">
+                <a:solidFill>
+                  <a:srgbClr val="46505C"/>
+                </a:solidFill>
+                <a:latin typeface="Arial"/>
+              </a:rPr>
+              <a:t>47</a:t>
+            </a:r>
+          </a:p>
+        </p:txBody>
+      </p:sp>
+    </p:spTree>
+  </p:cSld>
+  <p:clrMapOvr>
+    <a:masterClrMapping/>
+  </p:clrMapOvr>
+</p:sld>
+</file>
+
+<file path=ppt/slides/slide48.xml><?xml version="1.0" encoding="utf-8"?>
+<p:sld xmlns:a="http://schemas.openxmlformats.org/drawingml/2006/main" xmlns:p="http://schemas.openxmlformats.org/presentationml/2006/main" xmlns:r="http://schemas.openxmlformats.org/officeDocument/2006/relationships">
+  <p:cSld>
+    <p:bg>
+      <p:bgPr>
+        <a:solidFill>
+          <a:srgbClr val="F4F7FB"/>
+        </a:solidFill>
+        <a:effectLst/>
+      </p:bgPr>
+    </p:bg>
+    <p:spTree>
+      <p:nvGrpSpPr>
+        <p:cNvPr id="1" name=""/>
+        <p:cNvGrpSpPr/>
+        <p:nvPr/>
+      </p:nvGrpSpPr>
+      <p:grpSpPr/>
+      <p:sp>
+        <p:nvSpPr>
+          <p:cNvPr id="2" name="Rectangle 1"/>
+          <p:cNvSpPr/>
+          <p:nvPr/>
+        </p:nvSpPr>
+        <p:spPr>
+          <a:xfrm>
+            <a:off x="0" y="0"/>
+            <a:ext cx="12191695" cy="896112"/>
+          </a:xfrm>
+          <a:prstGeom prst="rect">
+            <a:avLst/>
+          </a:prstGeom>
+          <a:solidFill>
+            <a:srgbClr val="122033"/>
+          </a:solidFill>
+          <a:ln>
+            <a:solidFill>
+              <a:srgbClr val="122033"/>
+            </a:solidFill>
+          </a:ln>
+        </p:spPr>
+        <p:style>
+          <a:lnRef idx="1">
+            <a:schemeClr val="accent1"/>
+          </a:lnRef>
+          <a:fillRef idx="3">
+            <a:schemeClr val="accent1"/>
+          </a:fillRef>
+          <a:effectRef idx="2">
+            <a:schemeClr val="accent1"/>
+          </a:effectRef>
+          <a:fontRef idx="minor">
+            <a:schemeClr val="lt1"/>
+          </a:fontRef>
+        </p:style>
+        <p:txBody>
+          <a:bodyPr rtlCol="0" anchor="ctr"/>
+          <a:lstStyle/>
+          <a:p>
+            <a:pPr algn="ctr"/>
+          </a:p>
+        </p:txBody>
+      </p:sp>
+      <p:sp>
+        <p:nvSpPr>
+          <p:cNvPr id="3" name="Rectangle 2"/>
+          <p:cNvSpPr/>
+          <p:nvPr/>
+        </p:nvSpPr>
+        <p:spPr>
+          <a:xfrm>
+            <a:off x="0" y="868680"/>
+            <a:ext cx="12191695" cy="27432"/>
+          </a:xfrm>
+          <a:prstGeom prst="rect">
+            <a:avLst/>
+          </a:prstGeom>
+          <a:solidFill>
+            <a:srgbClr val="2D9BC8"/>
+          </a:solidFill>
+          <a:ln>
+            <a:solidFill>
+              <a:srgbClr val="2D9BC8"/>
+            </a:solidFill>
+          </a:ln>
+        </p:spPr>
+        <p:style>
+          <a:lnRef idx="1">
+            <a:schemeClr val="accent1"/>
+          </a:lnRef>
+          <a:fillRef idx="3">
+            <a:schemeClr val="accent1"/>
+          </a:fillRef>
+          <a:effectRef idx="2">
+            <a:schemeClr val="accent1"/>
+          </a:effectRef>
+          <a:fontRef idx="minor">
+            <a:schemeClr val="lt1"/>
+          </a:fontRef>
+        </p:style>
+        <p:txBody>
+          <a:bodyPr rtlCol="0" anchor="ctr"/>
+          <a:lstStyle/>
+          <a:p>
+            <a:pPr algn="ctr"/>
+          </a:p>
+        </p:txBody>
+      </p:sp>
+      <p:sp>
+        <p:nvSpPr>
+          <p:cNvPr id="4" name="TextBox 3"/>
+          <p:cNvSpPr txBox="1"/>
+          <p:nvPr/>
+        </p:nvSpPr>
+        <p:spPr>
+          <a:xfrm>
+            <a:off x="530352" y="109728"/>
+            <a:ext cx="11155680" cy="438912"/>
+          </a:xfrm>
+          <a:prstGeom prst="rect">
+            <a:avLst/>
+          </a:prstGeom>
+          <a:noFill/>
+        </p:spPr>
+        <p:txBody>
+          <a:bodyPr wrap="square" lIns="0" rIns="0" tIns="0" bIns="0">
+            <a:normAutofit/>
+          </a:bodyPr>
+          <a:lstStyle/>
+          <a:p>
+            <a:r>
+              <a:rPr sz="2200" b="1">
+                <a:solidFill>
+                  <a:srgbClr val="FFFFFF"/>
+                </a:solidFill>
+                <a:latin typeface="Noto Sans TC"/>
+              </a:rPr>
+              <a:t>BMC E12–E15：修正與同伺服器確認</a:t>
+            </a:r>
+          </a:p>
+        </p:txBody>
+      </p:sp>
+      <p:sp>
+        <p:nvSpPr>
+          <p:cNvPr id="5" name="TextBox 4"/>
+          <p:cNvSpPr txBox="1"/>
+          <p:nvPr/>
+        </p:nvSpPr>
+        <p:spPr>
+          <a:xfrm>
+            <a:off x="822960" y="1417320"/>
+            <a:ext cx="10515600" cy="4800600"/>
+          </a:xfrm>
+          <a:prstGeom prst="rect">
+            <a:avLst/>
+          </a:prstGeom>
+          <a:noFill/>
+        </p:spPr>
+        <p:txBody>
+          <a:bodyPr wrap="square" lIns="18288" rIns="18288" tIns="18288" bIns="18288">
+            <a:normAutofit/>
+          </a:bodyPr>
+          <a:lstStyle/>
+          <a:p>
+            <a:pPr>
+              <a:lnSpc>
+                <a:spcPct val="112000"/>
+              </a:lnSpc>
+              <a:spcAft>
+                <a:spcPts val="900"/>
+              </a:spcAft>
+              <a:defRPr sz="2000">
+                <a:solidFill>
+                  <a:srgbClr val="1E2733"/>
+                </a:solidFill>
+                <a:latin typeface="Noto Sans TC"/>
+              </a:defRPr>
+            </a:pPr>
+            <a:r>
+              <a:rPr sz="2000" b="0">
+                <a:solidFill>
+                  <a:srgbClr val="1E2733"/>
+                </a:solidFill>
+                <a:latin typeface="Noto Sans TC"/>
+              </a:rPr>
+              <a:t>• E12：6 個 development files 未達 30 rows；final test 未開啟</a:t>
+            </a:r>
+          </a:p>
+          <a:p>
+            <a:pPr>
+              <a:lnSpc>
+                <a:spcPct val="112000"/>
+              </a:lnSpc>
+              <a:spcAft>
+                <a:spcPts val="900"/>
+              </a:spcAft>
+              <a:defRPr sz="2000">
+                <a:solidFill>
+                  <a:srgbClr val="1E2733"/>
+                </a:solidFill>
+                <a:latin typeface="Noto Sans TC"/>
+              </a:defRPr>
+            </a:pPr>
+            <a:r>
+              <a:rPr sz="2000" b="0">
+                <a:solidFill>
+                  <a:srgbClr val="1E2733"/>
+                </a:solidFill>
+                <a:latin typeface="Noto Sans TC"/>
+              </a:rPr>
+              <a:t>• E13：舊 parser／unit pipeline 結果標記 PARSER_INVALIDATED</a:t>
+            </a:r>
+          </a:p>
+          <a:p>
+            <a:pPr>
+              <a:lnSpc>
+                <a:spcPct val="112000"/>
+              </a:lnSpc>
+              <a:spcAft>
+                <a:spcPts val="900"/>
+              </a:spcAft>
+              <a:defRPr sz="2000">
+                <a:solidFill>
+                  <a:srgbClr val="1E2733"/>
+                </a:solidFill>
+                <a:latin typeface="Noto Sans TC"/>
+              </a:defRPr>
+            </a:pPr>
+            <a:r>
+              <a:rPr sz="2000" b="0">
+                <a:solidFill>
+                  <a:srgbClr val="1E2733"/>
+                </a:solidFill>
+                <a:latin typeface="Noto Sans TC"/>
+              </a:rPr>
+              <a:t>• E14A/B：4,038 rows 完成來源與單位稽核；三檔 raw-unit regime 被正規化</a:t>
+            </a:r>
+          </a:p>
+          <a:p>
+            <a:pPr>
+              <a:lnSpc>
+                <a:spcPct val="112000"/>
+              </a:lnSpc>
+              <a:spcAft>
+                <a:spcPts val="900"/>
+              </a:spcAft>
+              <a:defRPr sz="2000">
+                <a:solidFill>
+                  <a:srgbClr val="1E2733"/>
+                </a:solidFill>
+                <a:latin typeface="Noto Sans TC"/>
+              </a:defRPr>
+            </a:pPr>
+            <a:r>
+              <a:rPr sz="2000" b="0">
+                <a:solidFill>
+                  <a:srgbClr val="1E2733"/>
+                </a:solidFill>
+                <a:latin typeface="Noto Sans TC"/>
+              </a:rPr>
+              <a:t>• E14C retrospective：MAE 4.0882 → 1.8054°C；13/14 runs；95% CI [1.4271, 2.7939]°C</a:t>
+            </a:r>
+          </a:p>
+          <a:p>
+            <a:pPr>
+              <a:lnSpc>
+                <a:spcPct val="112000"/>
+              </a:lnSpc>
+              <a:spcAft>
+                <a:spcPts val="900"/>
+              </a:spcAft>
+              <a:defRPr sz="2000">
+                <a:solidFill>
+                  <a:srgbClr val="1E2733"/>
+                </a:solidFill>
+                <a:latin typeface="Noto Sans TC"/>
+              </a:defRPr>
+            </a:pPr>
+            <a:r>
+              <a:rPr sz="2000" b="0">
+                <a:solidFill>
+                  <a:srgbClr val="1E2733"/>
+                </a:solidFill>
+                <a:latin typeface="Noto Sans TC"/>
+              </a:rPr>
+              <a:t>• E15：另 14 檔、3,112 rows 不重訓確認；H-ENC-08 支持；12/14 runs 勝出</a:t>
+            </a:r>
+          </a:p>
+          <a:p>
+            <a:pPr>
+              <a:lnSpc>
+                <a:spcPct val="112000"/>
+              </a:lnSpc>
+              <a:spcAft>
+                <a:spcPts val="900"/>
+              </a:spcAft>
+              <a:defRPr sz="2000">
+                <a:solidFill>
+                  <a:srgbClr val="1E2733"/>
+                </a:solidFill>
+                <a:latin typeface="Noto Sans TC"/>
+              </a:defRPr>
+            </a:pPr>
+            <a:r>
+              <a:rPr sz="2000" b="0">
+                <a:solidFill>
+                  <a:srgbClr val="1E2733"/>
+                </a:solidFill>
+                <a:latin typeface="Noto Sans TC"/>
+              </a:rPr>
+              <a:t>• E15 只支持同伺服器 temporal/workload transfer；E14C 仍屬回溯證據</a:t>
+            </a:r>
+          </a:p>
+        </p:txBody>
+      </p:sp>
+      <p:sp>
+        <p:nvSpPr>
+          <p:cNvPr id="6" name="footer_page_number"/>
+          <p:cNvSpPr txBox="1"/>
+          <p:nvPr/>
+        </p:nvSpPr>
+        <p:spPr>
+          <a:xfrm>
+            <a:off x="11201400" y="6400800"/>
+            <a:ext cx="548640" cy="228600"/>
+          </a:xfrm>
+          <a:prstGeom prst="rect">
+            <a:avLst/>
+          </a:prstGeom>
+          <a:noFill/>
+        </p:spPr>
+        <p:txBody>
+          <a:bodyPr wrap="none">
+            <a:spAutoFit/>
+          </a:bodyPr>
+          <a:lstStyle/>
+          <a:p>
+            <a:pPr algn="r"/>
+            <a:r>
+              <a:rPr sz="900">
+                <a:solidFill>
+                  <a:srgbClr val="46505C"/>
+                </a:solidFill>
+                <a:latin typeface="Arial"/>
+              </a:rPr>
+              <a:t>48</a:t>
+            </a:r>
+          </a:p>
+        </p:txBody>
+      </p:sp>
+    </p:spTree>
+  </p:cSld>
+  <p:clrMapOvr>
+    <a:masterClrMapping/>
+  </p:clrMapOvr>
+</p:sld>
+</file>
+
+<file path=ppt/slides/slide49.xml><?xml version="1.0" encoding="utf-8"?>
+<p:sld xmlns:a="http://schemas.openxmlformats.org/drawingml/2006/main" xmlns:p="http://schemas.openxmlformats.org/presentationml/2006/main" xmlns:r="http://schemas.openxmlformats.org/officeDocument/2006/relationships">
+  <p:cSld>
+    <p:bg>
+      <p:bgPr>
+        <a:solidFill>
+          <a:srgbClr val="F4F7FB"/>
+        </a:solidFill>
+        <a:effectLst/>
+      </p:bgPr>
+    </p:bg>
+    <p:spTree>
+      <p:nvGrpSpPr>
+        <p:cNvPr id="1" name=""/>
+        <p:cNvGrpSpPr/>
+        <p:nvPr/>
+      </p:nvGrpSpPr>
+      <p:grpSpPr/>
+      <p:sp>
+        <p:nvSpPr>
+          <p:cNvPr id="2" name="Rectangle 1"/>
+          <p:cNvSpPr/>
+          <p:nvPr/>
+        </p:nvSpPr>
+        <p:spPr>
+          <a:xfrm>
+            <a:off x="0" y="0"/>
+            <a:ext cx="12191695" cy="896112"/>
+          </a:xfrm>
+          <a:prstGeom prst="rect">
+            <a:avLst/>
+          </a:prstGeom>
+          <a:solidFill>
+            <a:srgbClr val="122033"/>
+          </a:solidFill>
+          <a:ln>
+            <a:solidFill>
+              <a:srgbClr val="122033"/>
+            </a:solidFill>
+          </a:ln>
+        </p:spPr>
+        <p:style>
+          <a:lnRef idx="1">
+            <a:schemeClr val="accent1"/>
+          </a:lnRef>
+          <a:fillRef idx="3">
+            <a:schemeClr val="accent1"/>
+          </a:fillRef>
+          <a:effectRef idx="2">
+            <a:schemeClr val="accent1"/>
+          </a:effectRef>
+          <a:fontRef idx="minor">
+            <a:schemeClr val="lt1"/>
+          </a:fontRef>
+        </p:style>
+        <p:txBody>
+          <a:bodyPr rtlCol="0" anchor="ctr"/>
+          <a:lstStyle/>
+          <a:p>
+            <a:pPr algn="ctr"/>
+          </a:p>
+        </p:txBody>
+      </p:sp>
+      <p:sp>
+        <p:nvSpPr>
+          <p:cNvPr id="3" name="Rectangle 2"/>
+          <p:cNvSpPr/>
+          <p:nvPr/>
+        </p:nvSpPr>
+        <p:spPr>
+          <a:xfrm>
+            <a:off x="0" y="868680"/>
+            <a:ext cx="12191695" cy="27432"/>
+          </a:xfrm>
+          <a:prstGeom prst="rect">
+            <a:avLst/>
+          </a:prstGeom>
+          <a:solidFill>
+            <a:srgbClr val="2D9BC8"/>
+          </a:solidFill>
+          <a:ln>
+            <a:solidFill>
+              <a:srgbClr val="2D9BC8"/>
+            </a:solidFill>
+          </a:ln>
+        </p:spPr>
+        <p:style>
+          <a:lnRef idx="1">
+            <a:schemeClr val="accent1"/>
+          </a:lnRef>
+          <a:fillRef idx="3">
+            <a:schemeClr val="accent1"/>
+          </a:fillRef>
+          <a:effectRef idx="2">
+            <a:schemeClr val="accent1"/>
+          </a:effectRef>
+          <a:fontRef idx="minor">
+            <a:schemeClr val="lt1"/>
+          </a:fontRef>
+        </p:style>
+        <p:txBody>
+          <a:bodyPr rtlCol="0" anchor="ctr"/>
+          <a:lstStyle/>
+          <a:p>
+            <a:pPr algn="ctr"/>
+          </a:p>
+        </p:txBody>
+      </p:sp>
+      <p:sp>
+        <p:nvSpPr>
+          <p:cNvPr id="4" name="TextBox 3"/>
+          <p:cNvSpPr txBox="1"/>
+          <p:nvPr/>
+        </p:nvSpPr>
+        <p:spPr>
+          <a:xfrm>
+            <a:off x="530352" y="109728"/>
+            <a:ext cx="11155680" cy="438912"/>
+          </a:xfrm>
+          <a:prstGeom prst="rect">
+            <a:avLst/>
+          </a:prstGeom>
+          <a:noFill/>
+        </p:spPr>
+        <p:txBody>
+          <a:bodyPr wrap="square" lIns="0" rIns="0" tIns="0" bIns="0">
+            <a:normAutofit/>
+          </a:bodyPr>
+          <a:lstStyle/>
+          <a:p>
+            <a:r>
+              <a:rPr sz="2000" b="1">
+                <a:solidFill>
+                  <a:srgbClr val="FFFFFF"/>
+                </a:solidFill>
+                <a:latin typeface="Noto Sans TC"/>
+              </a:rPr>
+              <a:t>E15：同伺服器 temporal/workload 確認</a:t>
+            </a:r>
+          </a:p>
+        </p:txBody>
+      </p:sp>
+      <p:sp>
+        <p:nvSpPr>
+          <p:cNvPr id="5" name="TextBox 4"/>
+          <p:cNvSpPr txBox="1"/>
+          <p:nvPr/>
+        </p:nvSpPr>
+        <p:spPr>
+          <a:xfrm>
+            <a:off x="822960" y="1417320"/>
+            <a:ext cx="10515600" cy="4800600"/>
+          </a:xfrm>
+          <a:prstGeom prst="rect">
+            <a:avLst/>
+          </a:prstGeom>
+          <a:noFill/>
+        </p:spPr>
+        <p:txBody>
+          <a:bodyPr wrap="square" lIns="18288" rIns="18288" tIns="18288" bIns="18288">
+            <a:normAutofit/>
+          </a:bodyPr>
+          <a:lstStyle/>
+          <a:p>
+            <a:pPr>
+              <a:lnSpc>
+                <a:spcPct val="112000"/>
+              </a:lnSpc>
+              <a:spcAft>
+                <a:spcPts val="900"/>
+              </a:spcAft>
+              <a:defRPr sz="2000">
+                <a:solidFill>
+                  <a:srgbClr val="1E2733"/>
+                </a:solidFill>
+                <a:latin typeface="Noto Sans TC"/>
+              </a:defRPr>
+            </a:pPr>
+            <a:r>
+              <a:rPr sz="2000" b="0">
+                <a:solidFill>
+                  <a:srgbClr val="1E2733"/>
+                </a:solidFill>
+                <a:latin typeface="Noto Sans TC"/>
+              </a:rPr>
+              <a:t>• 14 個先前未開啟檔案、3,112 rows；frozen ridge 一次不重訓確認；十項閘門全通過</a:t>
+            </a:r>
+          </a:p>
+          <a:p>
+            <a:pPr>
+              <a:lnSpc>
+                <a:spcPct val="112000"/>
+              </a:lnSpc>
+              <a:spcAft>
+                <a:spcPts val="900"/>
+              </a:spcAft>
+              <a:defRPr sz="2000">
+                <a:solidFill>
+                  <a:srgbClr val="1E2733"/>
+                </a:solidFill>
+                <a:latin typeface="Noto Sans TC"/>
+              </a:defRPr>
+            </a:pPr>
+            <a:r>
+              <a:rPr sz="2000" b="0">
+                <a:solidFill>
+                  <a:srgbClr val="1E2733"/>
+                </a:solidFill>
+                <a:latin typeface="Noto Sans TC"/>
+              </a:rPr>
+              <a:t>• MAE / RMSE / P95：1.6939 / 1.9672 / 3.5000 → 0.9744 / 1.2056 / 2.3888°C</a:t>
+            </a:r>
+          </a:p>
+          <a:p>
+            <a:pPr>
+              <a:lnSpc>
+                <a:spcPct val="112000"/>
+              </a:lnSpc>
+              <a:spcAft>
+                <a:spcPts val="900"/>
+              </a:spcAft>
+              <a:defRPr sz="2000">
+                <a:solidFill>
+                  <a:srgbClr val="1E2733"/>
+                </a:solidFill>
+                <a:latin typeface="Noto Sans TC"/>
+              </a:defRPr>
+            </a:pPr>
+            <a:r>
+              <a:rPr sz="2000" b="0">
+                <a:solidFill>
+                  <a:srgbClr val="1E2733"/>
+                </a:solidFill>
+                <a:latin typeface="Noto Sans TC"/>
+              </a:rPr>
+              <a:t>• Macro run MAE gain 0.6134°C；95% CI [0.2721, 0.9831]°C；12/14 runs 勝出</a:t>
+            </a:r>
+          </a:p>
+          <a:p>
+            <a:pPr>
+              <a:lnSpc>
+                <a:spcPct val="112000"/>
+              </a:lnSpc>
+              <a:spcAft>
+                <a:spcPts val="900"/>
+              </a:spcAft>
+              <a:defRPr sz="2000">
+                <a:solidFill>
+                  <a:srgbClr val="1E2733"/>
+                </a:solidFill>
+                <a:latin typeface="Noto Sans TC"/>
+              </a:defRPr>
+            </a:pPr>
+            <a:r>
+              <a:rPr sz="2000" b="0">
+                <a:solidFill>
+                  <a:srgbClr val="1E2733"/>
+                </a:solidFill>
+                <a:latin typeface="Noto Sans TC"/>
+              </a:rPr>
+              <a:t>• 退步 runs：202308051757.csv（-0.5537°C）、202310252230.csv（-0.3011°C）</a:t>
+            </a:r>
+          </a:p>
+          <a:p>
+            <a:pPr>
+              <a:lnSpc>
+                <a:spcPct val="112000"/>
+              </a:lnSpc>
+              <a:spcAft>
+                <a:spcPts val="900"/>
+              </a:spcAft>
+              <a:defRPr sz="2000">
+                <a:solidFill>
+                  <a:srgbClr val="1E2733"/>
+                </a:solidFill>
+                <a:latin typeface="Noto Sans TC"/>
+              </a:defRPr>
+            </a:pPr>
+            <a:r>
+              <a:rPr sz="2000" b="0">
+                <a:solidFill>
+                  <a:srgbClr val="1E2733"/>
+                </a:solidFill>
+                <a:latin typeface="Noto Sans TC"/>
+              </a:rPr>
+              <a:t>• 只支持同伺服器轉移；PC 機箱、NTC、跨伺服器、空間熱場與控制尚未驗證</a:t>
+            </a:r>
+          </a:p>
+          <a:p>
+            <a:pPr>
+              <a:lnSpc>
+                <a:spcPct val="112000"/>
+              </a:lnSpc>
+              <a:spcAft>
+                <a:spcPts val="900"/>
+              </a:spcAft>
+              <a:defRPr sz="2000">
+                <a:solidFill>
+                  <a:srgbClr val="1E2733"/>
+                </a:solidFill>
+                <a:latin typeface="Noto Sans TC"/>
+              </a:defRPr>
+            </a:pPr>
+            <a:r>
+              <a:rPr sz="2000" b="0">
+                <a:solidFill>
+                  <a:srgbClr val="1E2733"/>
+                </a:solidFill>
+                <a:latin typeface="Noto Sans TC"/>
+              </a:rPr>
+              <a:t>• 目前應用方向為機箱；單房間仍屬整體論文範圍</a:t>
+            </a:r>
+          </a:p>
+        </p:txBody>
+      </p:sp>
+      <p:sp>
+        <p:nvSpPr>
+          <p:cNvPr id="6" name="footer_page_number"/>
+          <p:cNvSpPr txBox="1"/>
+          <p:nvPr/>
+        </p:nvSpPr>
+        <p:spPr>
+          <a:xfrm>
+            <a:off x="11201400" y="6400800"/>
+            <a:ext cx="548640" cy="228600"/>
+          </a:xfrm>
+          <a:prstGeom prst="rect">
+            <a:avLst/>
+          </a:prstGeom>
+          <a:noFill/>
+        </p:spPr>
+        <p:txBody>
+          <a:bodyPr wrap="none">
+            <a:spAutoFit/>
+          </a:bodyPr>
+          <a:lstStyle/>
+          <a:p>
+            <a:pPr algn="r"/>
+            <a:r>
+              <a:rPr sz="900">
+                <a:solidFill>
+                  <a:srgbClr val="46505C"/>
+                </a:solidFill>
+                <a:latin typeface="Arial"/>
+              </a:rPr>
+              <a:t>49</a:t>
+            </a:r>
+          </a:p>
+        </p:txBody>
+      </p:sp>
+    </p:spTree>
+  </p:cSld>
+  <p:clrMapOvr>
+    <a:masterClrMapping/>
+  </p:clrMapOvr>
+</p:sld>
+</file>
+
 <file path=ppt/slides/slide5.xml><?xml version="1.0" encoding="utf-8"?>
 <p:sld xmlns:a="http://schemas.openxmlformats.org/drawingml/2006/main" xmlns:p="http://schemas.openxmlformats.org/presentationml/2006/main" xmlns:r="http://schemas.openxmlformats.org/officeDocument/2006/relationships">
   <p:cSld>
@@ -38115,6 +41091,1132 @@
                 <a:latin typeface="Arial"/>
               </a:rPr>
               <a:t>5</a:t>
+            </a:r>
+          </a:p>
+        </p:txBody>
+      </p:sp>
+    </p:spTree>
+  </p:cSld>
+  <p:clrMapOvr>
+    <a:masterClrMapping/>
+  </p:clrMapOvr>
+</p:sld>
+</file>
+
+<file path=ppt/slides/slide50.xml><?xml version="1.0" encoding="utf-8"?>
+<p:sld xmlns:a="http://schemas.openxmlformats.org/drawingml/2006/main" xmlns:p="http://schemas.openxmlformats.org/presentationml/2006/main" xmlns:r="http://schemas.openxmlformats.org/officeDocument/2006/relationships">
+  <p:cSld>
+    <p:bg>
+      <p:bgPr>
+        <a:solidFill>
+          <a:srgbClr val="F4F7FB"/>
+        </a:solidFill>
+        <a:effectLst/>
+      </p:bgPr>
+    </p:bg>
+    <p:spTree>
+      <p:nvGrpSpPr>
+        <p:cNvPr id="1" name=""/>
+        <p:cNvGrpSpPr/>
+        <p:nvPr/>
+      </p:nvGrpSpPr>
+      <p:grpSpPr/>
+      <p:sp>
+        <p:nvSpPr>
+          <p:cNvPr id="2" name="Rectangle 1"/>
+          <p:cNvSpPr/>
+          <p:nvPr/>
+        </p:nvSpPr>
+        <p:spPr>
+          <a:xfrm>
+            <a:off x="0" y="0"/>
+            <a:ext cx="12191695" cy="896112"/>
+          </a:xfrm>
+          <a:prstGeom prst="rect">
+            <a:avLst/>
+          </a:prstGeom>
+          <a:solidFill>
+            <a:srgbClr val="122033"/>
+          </a:solidFill>
+          <a:ln>
+            <a:solidFill>
+              <a:srgbClr val="122033"/>
+            </a:solidFill>
+          </a:ln>
+        </p:spPr>
+        <p:style>
+          <a:lnRef idx="1">
+            <a:schemeClr val="accent1"/>
+          </a:lnRef>
+          <a:fillRef idx="3">
+            <a:schemeClr val="accent1"/>
+          </a:fillRef>
+          <a:effectRef idx="2">
+            <a:schemeClr val="accent1"/>
+          </a:effectRef>
+          <a:fontRef idx="minor">
+            <a:schemeClr val="lt1"/>
+          </a:fontRef>
+        </p:style>
+        <p:txBody>
+          <a:bodyPr rtlCol="0" anchor="ctr"/>
+          <a:lstStyle/>
+          <a:p>
+            <a:pPr algn="ctr"/>
+          </a:p>
+        </p:txBody>
+      </p:sp>
+      <p:sp>
+        <p:nvSpPr>
+          <p:cNvPr id="3" name="Rectangle 2"/>
+          <p:cNvSpPr/>
+          <p:nvPr/>
+        </p:nvSpPr>
+        <p:spPr>
+          <a:xfrm>
+            <a:off x="0" y="868680"/>
+            <a:ext cx="12191695" cy="27432"/>
+          </a:xfrm>
+          <a:prstGeom prst="rect">
+            <a:avLst/>
+          </a:prstGeom>
+          <a:solidFill>
+            <a:srgbClr val="2D9BC8"/>
+          </a:solidFill>
+          <a:ln>
+            <a:solidFill>
+              <a:srgbClr val="2D9BC8"/>
+            </a:solidFill>
+          </a:ln>
+        </p:spPr>
+        <p:style>
+          <a:lnRef idx="1">
+            <a:schemeClr val="accent1"/>
+          </a:lnRef>
+          <a:fillRef idx="3">
+            <a:schemeClr val="accent1"/>
+          </a:fillRef>
+          <a:effectRef idx="2">
+            <a:schemeClr val="accent1"/>
+          </a:effectRef>
+          <a:fontRef idx="minor">
+            <a:schemeClr val="lt1"/>
+          </a:fontRef>
+        </p:style>
+        <p:txBody>
+          <a:bodyPr rtlCol="0" anchor="ctr"/>
+          <a:lstStyle/>
+          <a:p>
+            <a:pPr algn="ctr"/>
+          </a:p>
+        </p:txBody>
+      </p:sp>
+      <p:sp>
+        <p:nvSpPr>
+          <p:cNvPr id="4" name="TextBox 3"/>
+          <p:cNvSpPr txBox="1"/>
+          <p:nvPr/>
+        </p:nvSpPr>
+        <p:spPr>
+          <a:xfrm>
+            <a:off x="530352" y="109728"/>
+            <a:ext cx="11155680" cy="438912"/>
+          </a:xfrm>
+          <a:prstGeom prst="rect">
+            <a:avLst/>
+          </a:prstGeom>
+          <a:noFill/>
+        </p:spPr>
+        <p:txBody>
+          <a:bodyPr wrap="square" lIns="0" rIns="0" tIns="0" bIns="0">
+            <a:normAutofit/>
+          </a:bodyPr>
+          <a:lstStyle/>
+          <a:p>
+            <a:r>
+              <a:rPr sz="2200" b="1">
+                <a:solidFill>
+                  <a:srgbClr val="FFFFFF"/>
+                </a:solidFill>
+                <a:latin typeface="Noto Sans TC"/>
+              </a:rPr>
+              <a:t>機箱受限制 MPC 探索性模擬</a:t>
+            </a:r>
+          </a:p>
+        </p:txBody>
+      </p:sp>
+      <p:sp>
+        <p:nvSpPr>
+          <p:cNvPr id="5" name="TextBox 4"/>
+          <p:cNvSpPr txBox="1"/>
+          <p:nvPr/>
+        </p:nvSpPr>
+        <p:spPr>
+          <a:xfrm>
+            <a:off x="548640" y="566928"/>
+            <a:ext cx="11064240" cy="237744"/>
+          </a:xfrm>
+          <a:prstGeom prst="rect">
+            <a:avLst/>
+          </a:prstGeom>
+          <a:noFill/>
+        </p:spPr>
+        <p:txBody>
+          <a:bodyPr wrap="none" lIns="0" rIns="0" tIns="0" bIns="0">
+            <a:normAutofit/>
+          </a:bodyPr>
+          <a:lstStyle/>
+          <a:p>
+            <a:r>
+              <a:rPr sz="1000">
+                <a:solidFill>
+                  <a:srgbClr val="D3E1F1"/>
+                </a:solidFill>
+                <a:latin typeface="Noto Sans TC"/>
+              </a:rPr>
+              <a:t>2026-10-05 探索結果，參數為事前假設</a:t>
+            </a:r>
+          </a:p>
+        </p:txBody>
+      </p:sp>
+      <p:sp>
+        <p:nvSpPr>
+          <p:cNvPr id="6" name="TextBox 5"/>
+          <p:cNvSpPr txBox="1"/>
+          <p:nvPr/>
+        </p:nvSpPr>
+        <p:spPr>
+          <a:xfrm>
+            <a:off x="731520" y="1463040"/>
+            <a:ext cx="10698480" cy="4754880"/>
+          </a:xfrm>
+          <a:prstGeom prst="rect">
+            <a:avLst/>
+          </a:prstGeom>
+          <a:noFill/>
+        </p:spPr>
+        <p:txBody>
+          <a:bodyPr wrap="square" lIns="18288" rIns="18288" tIns="18288" bIns="18288">
+            <a:normAutofit/>
+          </a:bodyPr>
+          <a:lstStyle/>
+          <a:p>
+            <a:pPr>
+              <a:lnSpc>
+                <a:spcPct val="112000"/>
+              </a:lnSpc>
+              <a:spcAft>
+                <a:spcPts val="900"/>
+              </a:spcAft>
+              <a:defRPr sz="2000">
+                <a:solidFill>
+                  <a:srgbClr val="1E2733"/>
+                </a:solidFill>
+                <a:latin typeface="Noto Sans TC"/>
+              </a:defRPr>
+            </a:pPr>
+            <a:r>
+              <a:rPr sz="2000" b="0">
+                <a:solidFill>
+                  <a:srgbClr val="1E2733"/>
+                </a:solidFill>
+                <a:latin typeface="Noto Sans TC"/>
+              </a:rPr>
+              <a:t>• 假設熱模型，36 回合與 4,320 控制步</a:t>
+            </a:r>
+          </a:p>
+          <a:p>
+            <a:pPr>
+              <a:lnSpc>
+                <a:spcPct val="112000"/>
+              </a:lnSpc>
+              <a:spcAft>
+                <a:spcPts val="900"/>
+              </a:spcAft>
+              <a:defRPr sz="2000">
+                <a:solidFill>
+                  <a:srgbClr val="1E2733"/>
+                </a:solidFill>
+                <a:latin typeface="Noto Sans TC"/>
+              </a:defRPr>
+            </a:pPr>
+            <a:r>
+              <a:rPr sz="2000" b="0">
+                <a:solidFill>
+                  <a:srgbClr val="1E2733"/>
+                </a:solidFill>
+                <a:latin typeface="Noto Sans TC"/>
+              </a:rPr>
+              <a:t>• holdout MAE：固定 5.438 / PID 2.603 / MPC 1.443°C</a:t>
+            </a:r>
+          </a:p>
+          <a:p>
+            <a:pPr>
+              <a:lnSpc>
+                <a:spcPct val="112000"/>
+              </a:lnSpc>
+              <a:spcAft>
+                <a:spcPts val="900"/>
+              </a:spcAft>
+              <a:defRPr sz="2000">
+                <a:solidFill>
+                  <a:srgbClr val="1E2733"/>
+                </a:solidFill>
+                <a:latin typeface="Noto Sans TC"/>
+              </a:defRPr>
+            </a:pPr>
+            <a:r>
+              <a:rPr sz="2000" b="0">
+                <a:solidFill>
+                  <a:srgbClr val="1E2733"/>
+                </a:solidFill>
+                <a:latin typeface="Noto Sans TC"/>
+              </a:rPr>
+              <a:t>• nominal 無命令違例、超溫或求解回退</a:t>
+            </a:r>
+          </a:p>
+          <a:p>
+            <a:pPr>
+              <a:lnSpc>
+                <a:spcPct val="112000"/>
+              </a:lnSpc>
+              <a:spcAft>
+                <a:spcPts val="900"/>
+              </a:spcAft>
+              <a:defRPr sz="2000">
+                <a:solidFill>
+                  <a:srgbClr val="1E2733"/>
+                </a:solidFill>
+                <a:latin typeface="Noto Sans TC"/>
+              </a:defRPr>
+            </a:pPr>
+            <a:r>
+              <a:rPr sz="2000" b="0">
+                <a:solidFill>
+                  <a:srgbClr val="1E2733"/>
+                </a:solidFill>
+                <a:latin typeface="Noto Sans TC"/>
+              </a:rPr>
+              <a:t>• MPC 風扇能耗 proxy 與 PWM 變化增加</a:t>
+            </a:r>
+          </a:p>
+          <a:p>
+            <a:pPr>
+              <a:lnSpc>
+                <a:spcPct val="112000"/>
+              </a:lnSpc>
+              <a:spcAft>
+                <a:spcPts val="900"/>
+              </a:spcAft>
+              <a:defRPr sz="2000">
+                <a:solidFill>
+                  <a:srgbClr val="1E2733"/>
+                </a:solidFill>
+                <a:latin typeface="Noto Sans TC"/>
+              </a:defRPr>
+            </a:pPr>
+            <a:r>
+              <a:rPr sz="2000" b="0">
+                <a:solidFill>
+                  <a:srgbClr val="1E2733"/>
+                </a:solidFill>
+                <a:latin typeface="Noto Sans TC"/>
+              </a:rPr>
+              <a:t>• 過載仍超溫並出現求解回退，溫度是軟限制</a:t>
+            </a:r>
+          </a:p>
+          <a:p>
+            <a:pPr>
+              <a:lnSpc>
+                <a:spcPct val="112000"/>
+              </a:lnSpc>
+              <a:spcAft>
+                <a:spcPts val="900"/>
+              </a:spcAft>
+              <a:defRPr sz="2000">
+                <a:solidFill>
+                  <a:srgbClr val="1E2733"/>
+                </a:solidFill>
+                <a:latin typeface="Noto Sans TC"/>
+              </a:defRPr>
+            </a:pPr>
+            <a:r>
+              <a:rPr sz="2000" b="0">
+                <a:solidFill>
+                  <a:srgbClr val="1E2733"/>
+                </a:solidFill>
+                <a:latin typeface="Noto Sans TC"/>
+              </a:rPr>
+              <a:t>• 實體機箱與 E8：NOT_EVALUATED，LQR：TODO</a:t>
+            </a:r>
+          </a:p>
+        </p:txBody>
+      </p:sp>
+      <p:sp>
+        <p:nvSpPr>
+          <p:cNvPr id="7" name="footer_page_number"/>
+          <p:cNvSpPr txBox="1"/>
+          <p:nvPr/>
+        </p:nvSpPr>
+        <p:spPr>
+          <a:xfrm>
+            <a:off x="11201400" y="6400800"/>
+            <a:ext cx="548640" cy="228600"/>
+          </a:xfrm>
+          <a:prstGeom prst="rect">
+            <a:avLst/>
+          </a:prstGeom>
+          <a:noFill/>
+        </p:spPr>
+        <p:txBody>
+          <a:bodyPr wrap="none">
+            <a:spAutoFit/>
+          </a:bodyPr>
+          <a:lstStyle/>
+          <a:p>
+            <a:pPr algn="r"/>
+            <a:r>
+              <a:rPr sz="900">
+                <a:solidFill>
+                  <a:srgbClr val="46505C"/>
+                </a:solidFill>
+                <a:latin typeface="Arial"/>
+              </a:rPr>
+              <a:t>50</a:t>
+            </a:r>
+          </a:p>
+        </p:txBody>
+      </p:sp>
+    </p:spTree>
+  </p:cSld>
+  <p:clrMapOvr>
+    <a:masterClrMapping/>
+  </p:clrMapOvr>
+</p:sld>
+</file>
+
+<file path=ppt/slides/slide51.xml><?xml version="1.0" encoding="utf-8"?>
+<p:sld xmlns:a="http://schemas.openxmlformats.org/drawingml/2006/main" xmlns:p="http://schemas.openxmlformats.org/presentationml/2006/main" xmlns:r="http://schemas.openxmlformats.org/officeDocument/2006/relationships">
+  <p:cSld>
+    <p:bg>
+      <p:bgPr>
+        <a:solidFill>
+          <a:srgbClr val="F4F7FB"/>
+        </a:solidFill>
+        <a:effectLst/>
+      </p:bgPr>
+    </p:bg>
+    <p:spTree>
+      <p:nvGrpSpPr>
+        <p:cNvPr id="1" name=""/>
+        <p:cNvGrpSpPr/>
+        <p:nvPr/>
+      </p:nvGrpSpPr>
+      <p:grpSpPr/>
+      <p:sp>
+        <p:nvSpPr>
+          <p:cNvPr id="2" name="Rectangle 1"/>
+          <p:cNvSpPr/>
+          <p:nvPr/>
+        </p:nvSpPr>
+        <p:spPr>
+          <a:xfrm>
+            <a:off x="0" y="0"/>
+            <a:ext cx="12191695" cy="896112"/>
+          </a:xfrm>
+          <a:prstGeom prst="rect">
+            <a:avLst/>
+          </a:prstGeom>
+          <a:solidFill>
+            <a:srgbClr val="122033"/>
+          </a:solidFill>
+          <a:ln>
+            <a:solidFill>
+              <a:srgbClr val="122033"/>
+            </a:solidFill>
+          </a:ln>
+        </p:spPr>
+        <p:style>
+          <a:lnRef idx="1">
+            <a:schemeClr val="accent1"/>
+          </a:lnRef>
+          <a:fillRef idx="3">
+            <a:schemeClr val="accent1"/>
+          </a:fillRef>
+          <a:effectRef idx="2">
+            <a:schemeClr val="accent1"/>
+          </a:effectRef>
+          <a:fontRef idx="minor">
+            <a:schemeClr val="lt1"/>
+          </a:fontRef>
+        </p:style>
+        <p:txBody>
+          <a:bodyPr rtlCol="0" anchor="ctr"/>
+          <a:lstStyle/>
+          <a:p>
+            <a:pPr algn="ctr"/>
+          </a:p>
+        </p:txBody>
+      </p:sp>
+      <p:sp>
+        <p:nvSpPr>
+          <p:cNvPr id="3" name="Rectangle 2"/>
+          <p:cNvSpPr/>
+          <p:nvPr/>
+        </p:nvSpPr>
+        <p:spPr>
+          <a:xfrm>
+            <a:off x="0" y="868680"/>
+            <a:ext cx="12191695" cy="27432"/>
+          </a:xfrm>
+          <a:prstGeom prst="rect">
+            <a:avLst/>
+          </a:prstGeom>
+          <a:solidFill>
+            <a:srgbClr val="2D9BC8"/>
+          </a:solidFill>
+          <a:ln>
+            <a:solidFill>
+              <a:srgbClr val="2D9BC8"/>
+            </a:solidFill>
+          </a:ln>
+        </p:spPr>
+        <p:style>
+          <a:lnRef idx="1">
+            <a:schemeClr val="accent1"/>
+          </a:lnRef>
+          <a:fillRef idx="3">
+            <a:schemeClr val="accent1"/>
+          </a:fillRef>
+          <a:effectRef idx="2">
+            <a:schemeClr val="accent1"/>
+          </a:effectRef>
+          <a:fontRef idx="minor">
+            <a:schemeClr val="lt1"/>
+          </a:fontRef>
+        </p:style>
+        <p:txBody>
+          <a:bodyPr rtlCol="0" anchor="ctr"/>
+          <a:lstStyle/>
+          <a:p>
+            <a:pPr algn="ctr"/>
+          </a:p>
+        </p:txBody>
+      </p:sp>
+      <p:sp>
+        <p:nvSpPr>
+          <p:cNvPr id="4" name="TextBox 3"/>
+          <p:cNvSpPr txBox="1"/>
+          <p:nvPr/>
+        </p:nvSpPr>
+        <p:spPr>
+          <a:xfrm>
+            <a:off x="530352" y="109728"/>
+            <a:ext cx="11155680" cy="438912"/>
+          </a:xfrm>
+          <a:prstGeom prst="rect">
+            <a:avLst/>
+          </a:prstGeom>
+          <a:noFill/>
+        </p:spPr>
+        <p:txBody>
+          <a:bodyPr wrap="square" lIns="0" rIns="0" tIns="0" bIns="0">
+            <a:normAutofit/>
+          </a:bodyPr>
+          <a:lstStyle/>
+          <a:p>
+            <a:r>
+              <a:rPr sz="2200" b="1">
+                <a:solidFill>
+                  <a:srgbClr val="FFFFFF"/>
+                </a:solidFill>
+                <a:latin typeface="Noto Sans TC"/>
+              </a:rPr>
+              <a:t>機箱四方法探索性模擬（v2）</a:t>
+            </a:r>
+          </a:p>
+        </p:txBody>
+      </p:sp>
+      <p:sp>
+        <p:nvSpPr>
+          <p:cNvPr id="5" name="TextBox 4"/>
+          <p:cNvSpPr txBox="1"/>
+          <p:nvPr/>
+        </p:nvSpPr>
+        <p:spPr>
+          <a:xfrm>
+            <a:off x="548640" y="566928"/>
+            <a:ext cx="11064240" cy="237744"/>
+          </a:xfrm>
+          <a:prstGeom prst="rect">
+            <a:avLst/>
+          </a:prstGeom>
+          <a:noFill/>
+        </p:spPr>
+        <p:txBody>
+          <a:bodyPr wrap="none" lIns="0" rIns="0" tIns="0" bIns="0">
+            <a:normAutofit/>
+          </a:bodyPr>
+          <a:lstStyle/>
+          <a:p>
+            <a:r>
+              <a:rPr sz="1000">
+                <a:solidFill>
+                  <a:srgbClr val="D3E1F1"/>
+                </a:solidFill>
+                <a:latin typeface="Noto Sans TC"/>
+              </a:rPr>
+              <a:t>2026-10-05；結果由 v2 evidence 產生</a:t>
+            </a:r>
+          </a:p>
+        </p:txBody>
+      </p:sp>
+      <p:sp>
+        <p:nvSpPr>
+          <p:cNvPr id="6" name="TextBox 5"/>
+          <p:cNvSpPr txBox="1"/>
+          <p:nvPr/>
+        </p:nvSpPr>
+        <p:spPr>
+          <a:xfrm>
+            <a:off x="731520" y="1463040"/>
+            <a:ext cx="10698480" cy="4754880"/>
+          </a:xfrm>
+          <a:prstGeom prst="rect">
+            <a:avLst/>
+          </a:prstGeom>
+          <a:noFill/>
+        </p:spPr>
+        <p:txBody>
+          <a:bodyPr wrap="square" lIns="18288" rIns="18288" tIns="18288" bIns="18288">
+            <a:normAutofit/>
+          </a:bodyPr>
+          <a:lstStyle/>
+          <a:p>
+            <a:pPr>
+              <a:lnSpc>
+                <a:spcPct val="112000"/>
+              </a:lnSpc>
+              <a:spcAft>
+                <a:spcPts val="900"/>
+              </a:spcAft>
+              <a:defRPr sz="2000">
+                <a:solidFill>
+                  <a:srgbClr val="1E2733"/>
+                </a:solidFill>
+                <a:latin typeface="Noto Sans TC"/>
+              </a:defRPr>
+            </a:pPr>
+            <a:r>
+              <a:rPr sz="2000" b="0">
+                <a:solidFill>
+                  <a:srgbClr val="1E2733"/>
+                </a:solidFill>
+                <a:latin typeface="Noto Sans TC"/>
+              </a:rPr>
+              <a:t>• 假設模型：48 回合／5,760 步</a:t>
+            </a:r>
+          </a:p>
+          <a:p>
+            <a:pPr>
+              <a:lnSpc>
+                <a:spcPct val="112000"/>
+              </a:lnSpc>
+              <a:spcAft>
+                <a:spcPts val="900"/>
+              </a:spcAft>
+              <a:defRPr sz="2000">
+                <a:solidFill>
+                  <a:srgbClr val="1E2733"/>
+                </a:solidFill>
+                <a:latin typeface="Noto Sans TC"/>
+              </a:defRPr>
+            </a:pPr>
+            <a:r>
+              <a:rPr sz="2000" b="0">
+                <a:solidFill>
+                  <a:srgbClr val="1E2733"/>
+                </a:solidFill>
+                <a:latin typeface="Noto Sans TC"/>
+              </a:rPr>
+              <a:t>• fixed／PID＋FF／LQR／MPC holdout MAE：2.905/1.771/1.730/1.807°C</a:t>
+            </a:r>
+          </a:p>
+          <a:p>
+            <a:pPr>
+              <a:lnSpc>
+                <a:spcPct val="112000"/>
+              </a:lnSpc>
+              <a:spcAft>
+                <a:spcPts val="900"/>
+              </a:spcAft>
+              <a:defRPr sz="2000">
+                <a:solidFill>
+                  <a:srgbClr val="1E2733"/>
+                </a:solidFill>
+                <a:latin typeface="Noto Sans TC"/>
+              </a:defRPr>
+            </a:pPr>
+            <a:r>
+              <a:rPr sz="2000" b="0">
+                <a:solidFill>
+                  <a:srgbClr val="1E2733"/>
+                </a:solidFill>
+                <a:latin typeface="Noto Sans TC"/>
+              </a:rPr>
+              <a:t>• 相同候選回合預算；CPU 時間並不相等</a:t>
+            </a:r>
+          </a:p>
+          <a:p>
+            <a:pPr>
+              <a:lnSpc>
+                <a:spcPct val="112000"/>
+              </a:lnSpc>
+              <a:spcAft>
+                <a:spcPts val="900"/>
+              </a:spcAft>
+              <a:defRPr sz="2000">
+                <a:solidFill>
+                  <a:srgbClr val="1E2733"/>
+                </a:solidFill>
+                <a:latin typeface="Noto Sans TC"/>
+              </a:defRPr>
+            </a:pPr>
+            <a:r>
+              <a:rPr sz="2000" b="0">
+                <a:solidFill>
+                  <a:srgbClr val="1E2733"/>
+                </a:solidFill>
+                <a:latin typeface="Noto Sans TC"/>
+              </a:rPr>
+              <a:t>• 完整狀態與已知名義參數；參數變體並非實體跨設備確認</a:t>
+            </a:r>
+          </a:p>
+          <a:p>
+            <a:pPr>
+              <a:lnSpc>
+                <a:spcPct val="112000"/>
+              </a:lnSpc>
+              <a:spcAft>
+                <a:spcPts val="900"/>
+              </a:spcAft>
+              <a:defRPr sz="2000">
+                <a:solidFill>
+                  <a:srgbClr val="1E2733"/>
+                </a:solidFill>
+                <a:latin typeface="Noto Sans TC"/>
+              </a:defRPr>
+            </a:pPr>
+            <a:r>
+              <a:rPr sz="2000" b="0">
+                <a:solidFill>
+                  <a:srgbClr val="1E2733"/>
+                </a:solidFill>
+                <a:latin typeface="Noto Sans TC"/>
+              </a:rPr>
+              <a:t>• 超溫與數值失敗分開；實體機箱與 E8：NOT_EVALUATED</a:t>
+            </a:r>
+          </a:p>
+        </p:txBody>
+      </p:sp>
+      <p:sp>
+        <p:nvSpPr>
+          <p:cNvPr id="7" name="footer_page_number"/>
+          <p:cNvSpPr txBox="1"/>
+          <p:nvPr/>
+        </p:nvSpPr>
+        <p:spPr>
+          <a:xfrm>
+            <a:off x="11201400" y="6400800"/>
+            <a:ext cx="548640" cy="228600"/>
+          </a:xfrm>
+          <a:prstGeom prst="rect">
+            <a:avLst/>
+          </a:prstGeom>
+          <a:noFill/>
+        </p:spPr>
+        <p:txBody>
+          <a:bodyPr wrap="none">
+            <a:spAutoFit/>
+          </a:bodyPr>
+          <a:lstStyle/>
+          <a:p>
+            <a:pPr algn="r"/>
+            <a:r>
+              <a:rPr sz="900">
+                <a:solidFill>
+                  <a:srgbClr val="46505C"/>
+                </a:solidFill>
+                <a:latin typeface="Arial"/>
+              </a:rPr>
+              <a:t>51</a:t>
+            </a:r>
+          </a:p>
+        </p:txBody>
+      </p:sp>
+    </p:spTree>
+  </p:cSld>
+  <p:clrMapOvr>
+    <a:masterClrMapping/>
+  </p:clrMapOvr>
+</p:sld>
+</file>
+
+<file path=ppt/slides/slide52.xml><?xml version="1.0" encoding="utf-8"?>
+<p:sld xmlns:a="http://schemas.openxmlformats.org/drawingml/2006/main" xmlns:p="http://schemas.openxmlformats.org/presentationml/2006/main" xmlns:r="http://schemas.openxmlformats.org/officeDocument/2006/relationships">
+  <p:cSld>
+    <p:bg>
+      <p:bgPr>
+        <a:solidFill>
+          <a:srgbClr val="F4F7FB"/>
+        </a:solidFill>
+        <a:effectLst/>
+      </p:bgPr>
+    </p:bg>
+    <p:spTree>
+      <p:nvGrpSpPr>
+        <p:cNvPr id="1" name=""/>
+        <p:cNvGrpSpPr/>
+        <p:nvPr/>
+      </p:nvGrpSpPr>
+      <p:grpSpPr/>
+      <p:sp>
+        <p:nvSpPr>
+          <p:cNvPr id="2" name="Rectangle 1"/>
+          <p:cNvSpPr/>
+          <p:nvPr/>
+        </p:nvSpPr>
+        <p:spPr>
+          <a:xfrm>
+            <a:off x="0" y="0"/>
+            <a:ext cx="12191695" cy="896112"/>
+          </a:xfrm>
+          <a:prstGeom prst="rect">
+            <a:avLst/>
+          </a:prstGeom>
+          <a:solidFill>
+            <a:srgbClr val="122033"/>
+          </a:solidFill>
+          <a:ln>
+            <a:solidFill>
+              <a:srgbClr val="122033"/>
+            </a:solidFill>
+          </a:ln>
+        </p:spPr>
+        <p:style>
+          <a:lnRef idx="1">
+            <a:schemeClr val="accent1"/>
+          </a:lnRef>
+          <a:fillRef idx="3">
+            <a:schemeClr val="accent1"/>
+          </a:fillRef>
+          <a:effectRef idx="2">
+            <a:schemeClr val="accent1"/>
+          </a:effectRef>
+          <a:fontRef idx="minor">
+            <a:schemeClr val="lt1"/>
+          </a:fontRef>
+        </p:style>
+        <p:txBody>
+          <a:bodyPr rtlCol="0" anchor="ctr"/>
+          <a:lstStyle/>
+          <a:p>
+            <a:pPr algn="ctr"/>
+          </a:p>
+        </p:txBody>
+      </p:sp>
+      <p:sp>
+        <p:nvSpPr>
+          <p:cNvPr id="3" name="Rectangle 2"/>
+          <p:cNvSpPr/>
+          <p:nvPr/>
+        </p:nvSpPr>
+        <p:spPr>
+          <a:xfrm>
+            <a:off x="0" y="868680"/>
+            <a:ext cx="12191695" cy="27432"/>
+          </a:xfrm>
+          <a:prstGeom prst="rect">
+            <a:avLst/>
+          </a:prstGeom>
+          <a:solidFill>
+            <a:srgbClr val="2D9BC8"/>
+          </a:solidFill>
+          <a:ln>
+            <a:solidFill>
+              <a:srgbClr val="2D9BC8"/>
+            </a:solidFill>
+          </a:ln>
+        </p:spPr>
+        <p:style>
+          <a:lnRef idx="1">
+            <a:schemeClr val="accent1"/>
+          </a:lnRef>
+          <a:fillRef idx="3">
+            <a:schemeClr val="accent1"/>
+          </a:fillRef>
+          <a:effectRef idx="2">
+            <a:schemeClr val="accent1"/>
+          </a:effectRef>
+          <a:fontRef idx="minor">
+            <a:schemeClr val="lt1"/>
+          </a:fontRef>
+        </p:style>
+        <p:txBody>
+          <a:bodyPr rtlCol="0" anchor="ctr"/>
+          <a:lstStyle/>
+          <a:p>
+            <a:pPr algn="ctr"/>
+          </a:p>
+        </p:txBody>
+      </p:sp>
+      <p:sp>
+        <p:nvSpPr>
+          <p:cNvPr id="4" name="TextBox 3"/>
+          <p:cNvSpPr txBox="1"/>
+          <p:nvPr/>
+        </p:nvSpPr>
+        <p:spPr>
+          <a:xfrm>
+            <a:off x="530352" y="109728"/>
+            <a:ext cx="11155680" cy="438912"/>
+          </a:xfrm>
+          <a:prstGeom prst="rect">
+            <a:avLst/>
+          </a:prstGeom>
+          <a:noFill/>
+        </p:spPr>
+        <p:txBody>
+          <a:bodyPr wrap="square" lIns="0" rIns="0" tIns="0" bIns="0">
+            <a:normAutofit/>
+          </a:bodyPr>
+          <a:lstStyle/>
+          <a:p>
+            <a:r>
+              <a:rPr sz="2200" b="1">
+                <a:solidFill>
+                  <a:srgbClr val="FFFFFF"/>
+                </a:solidFill>
+                <a:latin typeface="Noto Sans TC"/>
+              </a:rPr>
+              <a:t>稀疏機箱溫度候選原型（2026-10-06）</a:t>
+            </a:r>
+          </a:p>
+        </p:txBody>
+      </p:sp>
+      <p:sp>
+        <p:nvSpPr>
+          <p:cNvPr id="5" name="TextBox 4"/>
+          <p:cNvSpPr txBox="1"/>
+          <p:nvPr/>
+        </p:nvSpPr>
+        <p:spPr>
+          <a:xfrm>
+            <a:off x="548640" y="566928"/>
+            <a:ext cx="11064240" cy="237744"/>
+          </a:xfrm>
+          <a:prstGeom prst="rect">
+            <a:avLst/>
+          </a:prstGeom>
+          <a:noFill/>
+        </p:spPr>
+        <p:txBody>
+          <a:bodyPr wrap="none" lIns="0" rIns="0" tIns="0" bIns="0">
+            <a:normAutofit/>
+          </a:bodyPr>
+          <a:lstStyle/>
+          <a:p>
+            <a:r>
+              <a:rPr sz="1000">
+                <a:solidFill>
+                  <a:srgbClr val="D3E1F1"/>
+                </a:solidFill>
+                <a:latin typeface="Noto Sans TC"/>
+              </a:rPr>
+              <a:t>探索性溫度子問題；不擴張原方法的實測主張</a:t>
+            </a:r>
+          </a:p>
+        </p:txBody>
+      </p:sp>
+      <p:sp>
+        <p:nvSpPr>
+          <p:cNvPr id="6" name="TextBox 5"/>
+          <p:cNvSpPr txBox="1"/>
+          <p:nvPr/>
+        </p:nvSpPr>
+        <p:spPr>
+          <a:xfrm>
+            <a:off x="731520" y="1463040"/>
+            <a:ext cx="10698480" cy="4754880"/>
+          </a:xfrm>
+          <a:prstGeom prst="rect">
+            <a:avLst/>
+          </a:prstGeom>
+          <a:noFill/>
+        </p:spPr>
+        <p:txBody>
+          <a:bodyPr wrap="square" lIns="18288" rIns="18288" tIns="18288" bIns="18288">
+            <a:normAutofit/>
+          </a:bodyPr>
+          <a:lstStyle/>
+          <a:p>
+            <a:pPr>
+              <a:lnSpc>
+                <a:spcPct val="112000"/>
+              </a:lnSpc>
+              <a:spcAft>
+                <a:spcPts val="900"/>
+              </a:spcAft>
+              <a:defRPr sz="2000">
+                <a:solidFill>
+                  <a:srgbClr val="1E2733"/>
+                </a:solidFill>
+                <a:latin typeface="Noto Sans TC"/>
+              </a:defRPr>
+            </a:pPr>
+            <a:r>
+              <a:rPr sz="2000" b="0">
+                <a:solidFill>
+                  <a:srgbClr val="1E2733"/>
+                </a:solidFill>
+                <a:latin typeface="Noto Sans TC"/>
+              </a:rPr>
+              <a:t>• 物理主模型 → 金屬片／空氣稀疏校正 → 多步動作排序</a:t>
+            </a:r>
+          </a:p>
+          <a:p>
+            <a:pPr>
+              <a:lnSpc>
+                <a:spcPct val="112000"/>
+              </a:lnSpc>
+              <a:spcAft>
+                <a:spcPts val="900"/>
+              </a:spcAft>
+              <a:defRPr sz="2000">
+                <a:solidFill>
+                  <a:srgbClr val="1E2733"/>
+                </a:solidFill>
+                <a:latin typeface="Noto Sans TC"/>
+              </a:defRPr>
+            </a:pPr>
+            <a:r>
+              <a:rPr sz="2000" b="0">
+                <a:solidFill>
+                  <a:srgbClr val="1E2733"/>
+                </a:solidFill>
+                <a:latin typeface="Noto Sans TC"/>
+              </a:rPr>
+              <a:t>• 108 回合；熱源估測 MAE 0.658 → 0.335°C</a:t>
+            </a:r>
+          </a:p>
+          <a:p>
+            <a:pPr>
+              <a:lnSpc>
+                <a:spcPct val="112000"/>
+              </a:lnSpc>
+              <a:spcAft>
+                <a:spcPts val="900"/>
+              </a:spcAft>
+              <a:defRPr sz="2000">
+                <a:solidFill>
+                  <a:srgbClr val="1E2733"/>
+                </a:solidFill>
+                <a:latin typeface="Noto Sans TC"/>
+              </a:defRPr>
+            </a:pPr>
+            <a:r>
+              <a:rPr sz="2000" b="0">
+                <a:solidFill>
+                  <a:srgbClr val="1E2733"/>
+                </a:solidFill>
+                <a:latin typeface="Noto Sans TC"/>
+              </a:rPr>
+              <a:t>• 六步排序追蹤較單步改善 9.03%；仍未優於 PI</a:t>
+            </a:r>
+          </a:p>
+          <a:p>
+            <a:pPr>
+              <a:lnSpc>
+                <a:spcPct val="112000"/>
+              </a:lnSpc>
+              <a:spcAft>
+                <a:spcPts val="900"/>
+              </a:spcAft>
+              <a:defRPr sz="2000">
+                <a:solidFill>
+                  <a:srgbClr val="1E2733"/>
+                </a:solidFill>
+                <a:latin typeface="Noto Sans TC"/>
+              </a:defRPr>
+            </a:pPr>
+            <a:r>
+              <a:rPr sz="2000" b="0">
+                <a:solidFill>
+                  <a:srgbClr val="1E2733"/>
+                </a:solidFill>
+                <a:latin typeface="Noto Sans TC"/>
+              </a:rPr>
+              <a:t>• 指定假設平台；仍有超溫；實體辨識／介入未評估</a:t>
+            </a:r>
+          </a:p>
+          <a:p>
+            <a:pPr>
+              <a:lnSpc>
+                <a:spcPct val="112000"/>
+              </a:lnSpc>
+              <a:spcAft>
+                <a:spcPts val="900"/>
+              </a:spcAft>
+              <a:defRPr sz="2000">
+                <a:solidFill>
+                  <a:srgbClr val="1E2733"/>
+                </a:solidFill>
+                <a:latin typeface="Noto Sans TC"/>
+              </a:defRPr>
+            </a:pPr>
+            <a:r>
+              <a:rPr sz="2000" b="0">
+                <a:solidFill>
+                  <a:srgbClr val="1E2733"/>
+                </a:solidFill>
+                <a:latin typeface="Noto Sans TC"/>
+              </a:rPr>
+              <a:t>• 下週 LQR／Kalman 1960 原文介紹已備稿；尚未口頭報告</a:t>
+            </a:r>
+          </a:p>
+        </p:txBody>
+      </p:sp>
+      <p:sp>
+        <p:nvSpPr>
+          <p:cNvPr id="7" name="footer_page_number"/>
+          <p:cNvSpPr txBox="1"/>
+          <p:nvPr/>
+        </p:nvSpPr>
+        <p:spPr>
+          <a:xfrm>
+            <a:off x="11201400" y="6400800"/>
+            <a:ext cx="548640" cy="228600"/>
+          </a:xfrm>
+          <a:prstGeom prst="rect">
+            <a:avLst/>
+          </a:prstGeom>
+          <a:noFill/>
+        </p:spPr>
+        <p:txBody>
+          <a:bodyPr wrap="none">
+            <a:spAutoFit/>
+          </a:bodyPr>
+          <a:lstStyle/>
+          <a:p>
+            <a:pPr algn="r"/>
+            <a:r>
+              <a:rPr sz="900">
+                <a:solidFill>
+                  <a:srgbClr val="46505C"/>
+                </a:solidFill>
+                <a:latin typeface="Arial"/>
+              </a:rPr>
+              <a:t>52</a:t>
             </a:r>
           </a:p>
         </p:txBody>
@@ -41331,4 +45433,324 @@
   </a:objectDefaults>
   <a:extraClrSchemeLst/>
 </a:theme>
+</file>
+
+<file path=ppt/theme/theme2.xml><?xml version="1.0" encoding="utf-8"?>
+<a:theme xmlns:a="http://schemas.openxmlformats.org/drawingml/2006/main" name="Office Theme">
+  <a:themeElements>
+    <a:clrScheme name="Office">
+      <a:dk1>
+        <a:sysClr val="windowText" lastClr="000000"/>
+      </a:dk1>
+      <a:lt1>
+        <a:sysClr val="window" lastClr="FFFFFF"/>
+      </a:lt1>
+      <a:dk2>
+        <a:srgbClr val="1F497D"/>
+      </a:dk2>
+      <a:lt2>
+        <a:srgbClr val="EEECE1"/>
+      </a:lt2>
+      <a:accent1>
+        <a:srgbClr val="4F81BD"/>
+      </a:accent1>
+      <a:accent2>
+        <a:srgbClr val="C0504D"/>
+      </a:accent2>
+      <a:accent3>
+        <a:srgbClr val="9BBB59"/>
+      </a:accent3>
+      <a:accent4>
+        <a:srgbClr val="8064A2"/>
+      </a:accent4>
+      <a:accent5>
+        <a:srgbClr val="4BACC6"/>
+      </a:accent5>
+      <a:accent6>
+        <a:srgbClr val="F79646"/>
+      </a:accent6>
+      <a:hlink>
+        <a:srgbClr val="0000FF"/>
+      </a:hlink>
+      <a:folHlink>
+        <a:srgbClr val="800080"/>
+      </a:folHlink>
+    </a:clrScheme>
+    <a:fontScheme name="Office">
+      <a:majorFont>
+        <a:latin typeface="Calibri"/>
+        <a:ea typeface=""/>
+        <a:cs typeface=""/>
+        <a:font script="Jpan" typeface="ＭＳ Ｐゴシック"/>
+        <a:font script="Hang" typeface="맑은 고딕"/>
+        <a:font script="Hans" typeface="宋体"/>
+        <a:font script="Hant" typeface="新細明體"/>
+        <a:font script="Arab" typeface="Times New Roman"/>
+        <a:font script="Hebr" typeface="Times New Roman"/>
+        <a:font script="Thai" typeface="Angsana New"/>
+        <a:font script="Ethi" typeface="Nyala"/>
+        <a:font script="Beng" typeface="Vrinda"/>
+        <a:font script="Gujr" typeface="Shruti"/>
+        <a:font script="Khmr" typeface="MoolBoran"/>
+        <a:font script="Knda" typeface="Tunga"/>
+        <a:font script="Guru" typeface="Raavi"/>
+        <a:font script="Cans" typeface="Euphemia"/>
+        <a:font script="Cher" typeface="Plantagenet Cherokee"/>
+        <a:font script="Yiii" typeface="Microsoft Yi Baiti"/>
+        <a:font script="Tibt" typeface="Microsoft Himalaya"/>
+        <a:font script="Thaa" typeface="MV Boli"/>
+        <a:font script="Deva" typeface="Mangal"/>
+        <a:font script="Telu" typeface="Gautami"/>
+        <a:font script="Taml" typeface="Latha"/>
+        <a:font script="Syrc" typeface="Estrangelo Edessa"/>
+        <a:font script="Orya" typeface="Kalinga"/>
+        <a:font script="Mlym" typeface="Kartika"/>
+        <a:font script="Laoo" typeface="DokChampa"/>
+        <a:font script="Sinh" typeface="Iskoola Pota"/>
+        <a:font script="Mong" typeface="Mongolian Baiti"/>
+        <a:font script="Viet" typeface="Times New Roman"/>
+        <a:font script="Uigh" typeface="Microsoft Uighur"/>
+        <a:font script="Geor" typeface="Sylfaen"/>
+      </a:majorFont>
+      <a:minorFont>
+        <a:latin typeface="Calibri"/>
+        <a:ea typeface=""/>
+        <a:cs typeface=""/>
+        <a:font script="Jpan" typeface="ＭＳ Ｐゴシック"/>
+        <a:font script="Hang" typeface="맑은 고딕"/>
+        <a:font script="Hans" typeface="宋体"/>
+        <a:font script="Hant" typeface="新細明體"/>
+        <a:font script="Arab" typeface="Arial"/>
+        <a:font script="Hebr" typeface="Arial"/>
+        <a:font script="Thai" typeface="Cordia New"/>
+        <a:font script="Ethi" typeface="Nyala"/>
+        <a:font script="Beng" typeface="Vrinda"/>
+        <a:font script="Gujr" typeface="Shruti"/>
+        <a:font script="Khmr" typeface="DaunPenh"/>
+        <a:font script="Knda" typeface="Tunga"/>
+        <a:font script="Guru" typeface="Raavi"/>
+        <a:font script="Cans" typeface="Euphemia"/>
+        <a:font script="Cher" typeface="Plantagenet Cherokee"/>
+        <a:font script="Yiii" typeface="Microsoft Yi Baiti"/>
+        <a:font script="Tibt" typeface="Microsoft Himalaya"/>
+        <a:font script="Thaa" typeface="MV Boli"/>
+        <a:font script="Deva" typeface="Mangal"/>
+        <a:font script="Telu" typeface="Gautami"/>
+        <a:font script="Taml" typeface="Latha"/>
+        <a:font script="Syrc" typeface="Estrangelo Edessa"/>
+        <a:font script="Orya" typeface="Kalinga"/>
+        <a:font script="Mlym" typeface="Kartika"/>
+        <a:font script="Laoo" typeface="DokChampa"/>
+        <a:font script="Sinh" typeface="Iskoola Pota"/>
+        <a:font script="Mong" typeface="Mongolian Baiti"/>
+        <a:font script="Viet" typeface="Arial"/>
+        <a:font script="Uigh" typeface="Microsoft Uighur"/>
+        <a:font script="Geor" typeface="Sylfaen"/>
+      </a:minorFont>
+    </a:fontScheme>
+    <a:fmtScheme name="Office">
+      <a:fillStyleLst>
+        <a:solidFill>
+          <a:schemeClr val="phClr"/>
+        </a:solidFill>
+        <a:gradFill rotWithShape="1">
+          <a:gsLst>
+            <a:gs pos="0">
+              <a:schemeClr val="phClr">
+                <a:tint val="50000"/>
+                <a:satMod val="300000"/>
+              </a:schemeClr>
+            </a:gs>
+            <a:gs pos="35000">
+              <a:schemeClr val="phClr">
+                <a:tint val="37000"/>
+                <a:satMod val="300000"/>
+              </a:schemeClr>
+            </a:gs>
+            <a:gs pos="100000">
+              <a:schemeClr val="phClr">
+                <a:tint val="15000"/>
+                <a:satMod val="350000"/>
+              </a:schemeClr>
+            </a:gs>
+          </a:gsLst>
+          <a:lin ang="16200000" scaled="1"/>
+        </a:gradFill>
+        <a:gradFill rotWithShape="1">
+          <a:gsLst>
+            <a:gs pos="0">
+              <a:schemeClr val="phClr">
+                <a:tint val="100000"/>
+                <a:shade val="100000"/>
+                <a:satMod val="130000"/>
+              </a:schemeClr>
+            </a:gs>
+            <a:gs pos="100000">
+              <a:schemeClr val="phClr">
+                <a:tint val="50000"/>
+                <a:shade val="100000"/>
+                <a:satMod val="350000"/>
+              </a:schemeClr>
+            </a:gs>
+          </a:gsLst>
+          <a:lin ang="16200000" scaled="0"/>
+        </a:gradFill>
+      </a:fillStyleLst>
+      <a:lnStyleLst>
+        <a:ln w="9525" cap="flat" cmpd="sng" algn="ctr">
+          <a:solidFill>
+            <a:schemeClr val="phClr">
+              <a:shade val="95000"/>
+              <a:satMod val="105000"/>
+            </a:schemeClr>
+          </a:solidFill>
+          <a:prstDash val="solid"/>
+        </a:ln>
+        <a:ln w="25400" cap="flat" cmpd="sng" algn="ctr">
+          <a:solidFill>
+            <a:schemeClr val="phClr"/>
+          </a:solidFill>
+          <a:prstDash val="solid"/>
+        </a:ln>
+        <a:ln w="38100" cap="flat" cmpd="sng" algn="ctr">
+          <a:solidFill>
+            <a:schemeClr val="phClr"/>
+          </a:solidFill>
+          <a:prstDash val="solid"/>
+        </a:ln>
+      </a:lnStyleLst>
+      <a:effectStyleLst>
+        <a:effectStyle>
+          <a:effectLst>
+            <a:outerShdw blurRad="40000" dist="20000" dir="5400000" rotWithShape="0">
+              <a:srgbClr val="000000">
+                <a:alpha val="38000"/>
+              </a:srgbClr>
+            </a:outerShdw>
+          </a:effectLst>
+        </a:effectStyle>
+        <a:effectStyle>
+          <a:effectLst>
+            <a:outerShdw blurRad="40000" dist="23000" dir="5400000" rotWithShape="0">
+              <a:srgbClr val="000000">
+                <a:alpha val="35000"/>
+              </a:srgbClr>
+            </a:outerShdw>
+          </a:effectLst>
+        </a:effectStyle>
+        <a:effectStyle>
+          <a:effectLst>
+            <a:outerShdw blurRad="40000" dist="23000" dir="5400000" rotWithShape="0">
+              <a:srgbClr val="000000">
+                <a:alpha val="35000"/>
+              </a:srgbClr>
+            </a:outerShdw>
+          </a:effectLst>
+          <a:scene3d>
+            <a:camera prst="orthographicFront">
+              <a:rot lat="0" lon="0" rev="0"/>
+            </a:camera>
+            <a:lightRig rig="threePt" dir="t">
+              <a:rot lat="0" lon="0" rev="1200000"/>
+            </a:lightRig>
+          </a:scene3d>
+          <a:sp3d>
+            <a:bevelT w="63500" h="25400"/>
+          </a:sp3d>
+        </a:effectStyle>
+      </a:effectStyleLst>
+      <a:bgFillStyleLst>
+        <a:solidFill>
+          <a:schemeClr val="phClr"/>
+        </a:solidFill>
+        <a:gradFill rotWithShape="1">
+          <a:gsLst>
+            <a:gs pos="0">
+              <a:schemeClr val="phClr">
+                <a:tint val="40000"/>
+                <a:satMod val="350000"/>
+              </a:schemeClr>
+            </a:gs>
+            <a:gs pos="40000">
+              <a:schemeClr val="phClr">
+                <a:tint val="45000"/>
+                <a:shade val="99000"/>
+                <a:satMod val="350000"/>
+              </a:schemeClr>
+            </a:gs>
+            <a:gs pos="100000">
+              <a:schemeClr val="phClr">
+                <a:shade val="20000"/>
+                <a:satMod val="255000"/>
+              </a:schemeClr>
+            </a:gs>
+          </a:gsLst>
+          <a:path path="circle">
+            <a:fillToRect l="50000" t="-80000" r="50000" b="180000"/>
+          </a:path>
+        </a:gradFill>
+        <a:gradFill rotWithShape="1">
+          <a:gsLst>
+            <a:gs pos="0">
+              <a:schemeClr val="phClr">
+                <a:tint val="80000"/>
+                <a:satMod val="300000"/>
+              </a:schemeClr>
+            </a:gs>
+            <a:gs pos="100000">
+              <a:schemeClr val="phClr">
+                <a:shade val="30000"/>
+                <a:satMod val="200000"/>
+              </a:schemeClr>
+            </a:gs>
+          </a:gsLst>
+          <a:path path="circle">
+            <a:fillToRect l="50000" t="50000" r="50000" b="50000"/>
+          </a:path>
+        </a:gradFill>
+      </a:bgFillStyleLst>
+    </a:fmtScheme>
+  </a:themeElements>
+  <a:objectDefaults>
+    <a:spDef>
+      <a:spPr/>
+      <a:bodyPr/>
+      <a:lstStyle/>
+      <a:style>
+        <a:lnRef idx="1">
+          <a:schemeClr val="accent1"/>
+        </a:lnRef>
+        <a:fillRef idx="3">
+          <a:schemeClr val="accent1"/>
+        </a:fillRef>
+        <a:effectRef idx="2">
+          <a:schemeClr val="accent1"/>
+        </a:effectRef>
+        <a:fontRef idx="minor">
+          <a:schemeClr val="lt1"/>
+        </a:fontRef>
+      </a:style>
+    </a:spDef>
+    <a:lnDef>
+      <a:spPr/>
+      <a:bodyPr/>
+      <a:lstStyle/>
+      <a:style>
+        <a:lnRef idx="2">
+          <a:schemeClr val="accent1"/>
+        </a:lnRef>
+        <a:fillRef idx="0">
+          <a:schemeClr val="accent1"/>
+        </a:fillRef>
+        <a:effectRef idx="1">
+          <a:schemeClr val="accent1"/>
+        </a:effectRef>
+        <a:fontRef idx="minor">
+          <a:schemeClr val="tx1"/>
+        </a:fontRef>
+      </a:style>
+    </a:lnDef>
+  </a:objectDefaults>
+  <a:extraClrSchemeLst/>
+</a:theme>
 </file>
</xml_diff>

<commit_message>
fix(research): correct sparse warnings, trace audit and observed QA provenance
</commit_message>
<xml_diff>
--- a/docs/papers/thesis/thesis_presentation_zh.pptx
+++ b/docs/papers/thesis/thesis_presentation_zh.pptx
@@ -714,6 +714,11 @@
           <a:p>
             <a:r>
               <a:t>本輪為溫度子問題與假設熱網路：已知熱容量和部分係數，單一方程家族、三組指定參數與合成噪聲。金屬片／風管增益是假設，未量測實際裝置；有限候選排序不是 LQR 或完整 MPC。20–30°C 外的樣本完整保留，但不擴張原室內模型適用域。濕度、光照、三維空間場、完整三因子遷移與實體辨識／介入均未評估。</a:t>
+            </a:r>
+          </a:p>
+          <a:p>
+            <a:r>
+              <a:t>獨立審查後，我修正原始金屬片／空氣觀測可能被濾波掩蓋的警告判斷，並加上時間、真值連續性與獨立熱動態核對。原 108 回合通過加強核對；新版原始感測警告在既有 72 回合輸入回放中，命令與警告均無變化。這是已開啟資料的回歸檢查，未新增閉迴路或未見確認結果。另做事後散熱能力分析：接觸較差平台在入口 22°C、總熱量 3.35W 與全速風扇下，熱源平衡點為 32.40°C。該平台六步 holdout 的 360 步中，150 步的當下輸入若維持到穩態，全速平衡點仍高於 30°C；實際取樣超溫則為 124 步。兩者不能混用；穩態分析不是有限時域不可行證明，也未改原假設判準，應分開解釋散熱能力與控制誤差。</a:t>
             </a:r>
           </a:p>
           <a:p>
@@ -42157,6 +42162,31 @@
                 <a:latin typeface="Noto Sans TC"/>
               </a:rPr>
               <a:t>• 指定假設平台；仍有超溫；實體辨識／介入未評估</a:t>
+            </a:r>
+          </a:p>
+          <a:p>
+            <a:pPr>
+              <a:lnSpc>
+                <a:spcPct val="112000"/>
+              </a:lnSpc>
+              <a:spcAft>
+                <a:spcPts val="900"/>
+              </a:spcAft>
+              <a:defRPr sz="2000">
+                <a:solidFill>
+                  <a:srgbClr val="1E2733"/>
+                </a:solidFill>
+                <a:latin typeface="Noto Sans TC"/>
+              </a:defRPr>
+            </a:pPr>
+            <a:r>
+              <a:rPr sz="2000" b="0">
+                <a:solidFill>
+                  <a:srgbClr val="1E2733"/>
+                </a:solidFill>
+                <a:latin typeface="Noto Sans TC"/>
+              </a:rPr>
+              <a:t>• 全速平衡 32.40°C 案例：散熱能力與控制誤差分開</a:t>
             </a:r>
           </a:p>
           <a:p>

</xml_diff>

<commit_message>
research: integrate sparse enclosure session and verified professor briefing
</commit_message>
<xml_diff>
--- a/docs/papers/thesis/thesis_presentation_zh.pptx
+++ b/docs/papers/thesis/thesis_presentation_zh.pptx
@@ -57,6 +57,7 @@
     <p:sldId id="305" r:id="rId56"/>
     <p:sldId id="306" r:id="rId58"/>
     <p:sldId id="307" r:id="rId59"/>
+    <p:sldId id="308" r:id="rId60"/>
   </p:sldIdLst>
   <p:sldSz cx="12191695" cy="6858000" type="screen4x3"/>
   <p:notesSz cx="6858000" cy="9144000"/>
@@ -724,6 +725,91 @@
           <a:p>
             <a:r>
               <a:t>已為下週準備 LQR 與 Kalman (1960) Contributions to the Theory of Optimal Control 的介紹。重點查閱原文問題、狀態精確已知假設、可控／可觀測與 Riccati／穩定定理敘述；未重證全部證明，亦尚未口頭報告。</a:t>
+            </a:r>
+          </a:p>
+        </p:txBody>
+      </p:sp>
+      <p:sp>
+        <p:nvSpPr>
+          <p:cNvPr id="4" name="Slide Number Placeholder 3"/>
+          <p:cNvSpPr>
+            <a:spLocks noGrp="1"/>
+          </p:cNvSpPr>
+          <p:nvPr>
+            <p:ph type="sldNum" idx="5" sz="quarter"/>
+          </p:nvPr>
+        </p:nvSpPr>
+        <p:spPr/>
+      </p:sp>
+    </p:spTree>
+  </p:cSld>
+  <p:clrMapOvr>
+    <a:masterClrMapping/>
+  </p:clrMapOvr>
+</p:notes>
+</file>
+
+<file path=ppt/notesSlides/notesSlide4.xml><?xml version="1.0" encoding="utf-8"?>
+<p:notes xmlns:a="http://schemas.openxmlformats.org/drawingml/2006/main" xmlns:p="http://schemas.openxmlformats.org/presentationml/2006/main" xmlns:r="http://schemas.openxmlformats.org/officeDocument/2006/relationships">
+  <p:cSld>
+    <p:spTree>
+      <p:nvGrpSpPr>
+        <p:cNvPr id="1" name=""/>
+        <p:cNvGrpSpPr/>
+        <p:nvPr/>
+      </p:nvGrpSpPr>
+      <p:grpSpPr>
+        <a:xfrm>
+          <a:off x="0" y="0"/>
+          <a:ext cx="0" cy="0"/>
+          <a:chOff x="0" y="0"/>
+          <a:chExt cx="0" cy="0"/>
+        </a:xfrm>
+      </p:grpSpPr>
+      <p:sp>
+        <p:nvSpPr>
+          <p:cNvPr id="2" name="Slide Image Placeholder 1"/>
+          <p:cNvSpPr>
+            <a:spLocks noGrp="1"/>
+          </p:cNvSpPr>
+          <p:nvPr>
+            <p:ph type="sldImg" idx="2"/>
+          </p:nvPr>
+        </p:nvSpPr>
+        <p:spPr/>
+      </p:sp>
+      <p:sp>
+        <p:nvSpPr>
+          <p:cNvPr id="3" name="Notes Placeholder 2"/>
+          <p:cNvSpPr>
+            <a:spLocks noGrp="1"/>
+          </p:cNvSpPr>
+          <p:nvPr>
+            <p:ph type="body" idx="3" sz="quarter"/>
+          </p:nvPr>
+        </p:nvSpPr>
+        <p:spPr/>
+        <p:txBody>
+          <a:bodyPr/>
+          <a:lstStyle/>
+          <a:p>
+            <a:r>
+              <a:t>我把機箱溫度候選流程接入正式 Python 套件的獨立機箱介面，整合量測 CSV、有限參數辨識、稀疏估測、LQR／線性 MPC 與候選排序。新的四組假設平台共 88 回合、10,560 步，以相同 900 秒校正辨識接觸熱導、風扇對流增益、共同熱容量倍率與風扇延遲；固定容量比例和其他係數仍是假設。holdout 包含不同比例的熱容量與模型沒有的熱源直接傳到空氣路徑，所有方法只取得金屬片、空氣、風扇、入口與功率。名義／辨識／稀疏校正估測 MAE 為 1.0086/0.4681/0.3689°C。平均稀疏校正改善 21.19%，但只有 2/4 組改善，未達 3/4 判準，因此 H-ENC-51 不支持。</a:t>
+            </a:r>
+          </a:p>
+          <a:p>
+            <a:r>
+              <a:t>固定／PI／PID／LQR／線性 MPC／單步／六步／六步無校正追蹤 MAE 為 1.7310/1.3471/1.3472/1.4872/1.3695/1.3764/1.3755/1.3943°C。六步相對單步改善 0.069%，未達 5%，H-ENC-52 不支持；PI 追蹤誤差低於六步排序，線性 MPC 的風扇能耗 proxy 較低但追蹤稍差。六步平均取樣超溫 3.75 秒／回合，全部閉迴路命令違例為零。這些是不同閉迴路軌跡下的比較；不能把命令合規當成真實安全。</a:t>
+            </a:r>
+          </a:p>
+          <a:p>
+            <a:r>
+              <a:t>此次完成軟體流程、探索性模擬及實機實驗準備。相同有限校正是 commissioning-assisted synthetic transfer，並非零樣本或真實跨設備驗證；額外傳熱路徑只有一個指定反例，不證明任意方程家族泛化。LQR 經限幅後不再主張無限制最優性，MPC 使用當下線性化、六步預測與軟溫度代價。風扇 proxy 不是量測能耗。原室內濕度／照度和三維場維持原方法，未完成機箱三因子遷移；使用者於 2026-10-12 確認尚無設備或資料，實體辨識、NTC 精度與控制介入保留 NOT_EVALUATED；口頭報告尚無完成紀錄。</a:t>
+            </a:r>
+          </a:p>
+          <a:p>
+            <a:r>
+              <a:t>全部 88 回合、10,560 筆已重算指標，核對時間、合成噪聲、原始感測警告、獨立熱動態與只讀觀測的流程回放；372 個歷史研究檔案未改動，一次性 E15 沒有重跑。時間偏移、同步真值偏移、風扇端點、原始觀測與指標五種破壞案例均被拒絕。</a:t>
             </a:r>
           </a:p>
         </p:txBody>
@@ -42247,6 +42333,398 @@
                 <a:latin typeface="Arial"/>
               </a:rPr>
               <a:t>52</a:t>
+            </a:r>
+          </a:p>
+        </p:txBody>
+      </p:sp>
+    </p:spTree>
+  </p:cSld>
+  <p:clrMapOvr>
+    <a:masterClrMapping/>
+  </p:clrMapOvr>
+</p:sld>
+</file>
+
+<file path=ppt/slides/slide53.xml><?xml version="1.0" encoding="utf-8"?>
+<p:sld xmlns:a="http://schemas.openxmlformats.org/drawingml/2006/main" xmlns:p="http://schemas.openxmlformats.org/presentationml/2006/main" xmlns:r="http://schemas.openxmlformats.org/officeDocument/2006/relationships">
+  <p:cSld>
+    <p:bg>
+      <p:bgPr>
+        <a:solidFill>
+          <a:srgbClr val="F4F7FB"/>
+        </a:solidFill>
+        <a:effectLst/>
+      </p:bgPr>
+    </p:bg>
+    <p:spTree>
+      <p:nvGrpSpPr>
+        <p:cNvPr id="1" name=""/>
+        <p:cNvGrpSpPr/>
+        <p:nvPr/>
+      </p:nvGrpSpPr>
+      <p:grpSpPr/>
+      <p:sp>
+        <p:nvSpPr>
+          <p:cNvPr id="2" name="Rectangle 1"/>
+          <p:cNvSpPr/>
+          <p:nvPr/>
+        </p:nvSpPr>
+        <p:spPr>
+          <a:xfrm>
+            <a:off x="0" y="0"/>
+            <a:ext cx="12191695" cy="896112"/>
+          </a:xfrm>
+          <a:prstGeom prst="rect">
+            <a:avLst/>
+          </a:prstGeom>
+          <a:solidFill>
+            <a:srgbClr val="122033"/>
+          </a:solidFill>
+          <a:ln>
+            <a:solidFill>
+              <a:srgbClr val="122033"/>
+            </a:solidFill>
+          </a:ln>
+        </p:spPr>
+        <p:style>
+          <a:lnRef idx="1">
+            <a:schemeClr val="accent1"/>
+          </a:lnRef>
+          <a:fillRef idx="3">
+            <a:schemeClr val="accent1"/>
+          </a:fillRef>
+          <a:effectRef idx="2">
+            <a:schemeClr val="accent1"/>
+          </a:effectRef>
+          <a:fontRef idx="minor">
+            <a:schemeClr val="lt1"/>
+          </a:fontRef>
+        </p:style>
+        <p:txBody>
+          <a:bodyPr rtlCol="0" anchor="ctr"/>
+          <a:lstStyle/>
+          <a:p>
+            <a:pPr algn="ctr"/>
+          </a:p>
+        </p:txBody>
+      </p:sp>
+      <p:sp>
+        <p:nvSpPr>
+          <p:cNvPr id="3" name="Rectangle 2"/>
+          <p:cNvSpPr/>
+          <p:nvPr/>
+        </p:nvSpPr>
+        <p:spPr>
+          <a:xfrm>
+            <a:off x="0" y="868680"/>
+            <a:ext cx="12191695" cy="27432"/>
+          </a:xfrm>
+          <a:prstGeom prst="rect">
+            <a:avLst/>
+          </a:prstGeom>
+          <a:solidFill>
+            <a:srgbClr val="2D9BC8"/>
+          </a:solidFill>
+          <a:ln>
+            <a:solidFill>
+              <a:srgbClr val="2D9BC8"/>
+            </a:solidFill>
+          </a:ln>
+        </p:spPr>
+        <p:style>
+          <a:lnRef idx="1">
+            <a:schemeClr val="accent1"/>
+          </a:lnRef>
+          <a:fillRef idx="3">
+            <a:schemeClr val="accent1"/>
+          </a:fillRef>
+          <a:effectRef idx="2">
+            <a:schemeClr val="accent1"/>
+          </a:effectRef>
+          <a:fontRef idx="minor">
+            <a:schemeClr val="lt1"/>
+          </a:fontRef>
+        </p:style>
+        <p:txBody>
+          <a:bodyPr rtlCol="0" anchor="ctr"/>
+          <a:lstStyle/>
+          <a:p>
+            <a:pPr algn="ctr"/>
+          </a:p>
+        </p:txBody>
+      </p:sp>
+      <p:sp>
+        <p:nvSpPr>
+          <p:cNvPr id="4" name="TextBox 3"/>
+          <p:cNvSpPr txBox="1"/>
+          <p:nvPr/>
+        </p:nvSpPr>
+        <p:spPr>
+          <a:xfrm>
+            <a:off x="530352" y="109728"/>
+            <a:ext cx="11155680" cy="438912"/>
+          </a:xfrm>
+          <a:prstGeom prst="rect">
+            <a:avLst/>
+          </a:prstGeom>
+          <a:noFill/>
+        </p:spPr>
+        <p:txBody>
+          <a:bodyPr wrap="square" lIns="0" rIns="0" tIns="0" bIns="0">
+            <a:normAutofit/>
+          </a:bodyPr>
+          <a:lstStyle/>
+          <a:p>
+            <a:r>
+              <a:rPr sz="2000" b="1">
+                <a:solidFill>
+                  <a:srgbClr val="FFFFFF"/>
+                </a:solidFill>
+                <a:latin typeface="Noto Sans TC"/>
+              </a:rPr>
+              <a:t>機箱溫度流程整合與跨模型探索 2026-10-12</a:t>
+            </a:r>
+          </a:p>
+        </p:txBody>
+      </p:sp>
+      <p:sp>
+        <p:nvSpPr>
+          <p:cNvPr id="5" name="TextBox 4"/>
+          <p:cNvSpPr txBox="1"/>
+          <p:nvPr/>
+        </p:nvSpPr>
+        <p:spPr>
+          <a:xfrm>
+            <a:off x="548640" y="566928"/>
+            <a:ext cx="11064240" cy="237744"/>
+          </a:xfrm>
+          <a:prstGeom prst="rect">
+            <a:avLst/>
+          </a:prstGeom>
+          <a:noFill/>
+        </p:spPr>
+        <p:txBody>
+          <a:bodyPr wrap="none" lIns="0" rIns="0" tIns="0" bIns="0">
+            <a:normAutofit/>
+          </a:bodyPr>
+          <a:lstStyle/>
+          <a:p>
+            <a:r>
+              <a:rPr sz="1000">
+                <a:solidFill>
+                  <a:srgbClr val="D3E1F1"/>
+                </a:solidFill>
+                <a:latin typeface="Noto Sans TC"/>
+              </a:rPr>
+              <a:t>溫度軟體整合與探索性模擬；保留未達判準的結果</a:t>
+            </a:r>
+          </a:p>
+        </p:txBody>
+      </p:sp>
+      <p:sp>
+        <p:nvSpPr>
+          <p:cNvPr id="6" name="TextBox 5"/>
+          <p:cNvSpPr txBox="1"/>
+          <p:nvPr/>
+        </p:nvSpPr>
+        <p:spPr>
+          <a:xfrm>
+            <a:off x="731520" y="1463040"/>
+            <a:ext cx="10698480" cy="4754880"/>
+          </a:xfrm>
+          <a:prstGeom prst="rect">
+            <a:avLst/>
+          </a:prstGeom>
+          <a:noFill/>
+        </p:spPr>
+        <p:txBody>
+          <a:bodyPr wrap="square" lIns="18288" rIns="18288" tIns="18288" bIns="18288">
+            <a:normAutofit/>
+          </a:bodyPr>
+          <a:lstStyle/>
+          <a:p>
+            <a:pPr>
+              <a:lnSpc>
+                <a:spcPct val="112000"/>
+              </a:lnSpc>
+              <a:spcAft>
+                <a:spcPts val="900"/>
+              </a:spcAft>
+              <a:defRPr sz="2000">
+                <a:solidFill>
+                  <a:srgbClr val="1E2733"/>
+                </a:solidFill>
+                <a:latin typeface="Noto Sans TC"/>
+              </a:defRPr>
+            </a:pPr>
+            <a:r>
+              <a:rPr sz="2000" b="0">
+                <a:solidFill>
+                  <a:srgbClr val="1E2733"/>
+                </a:solidFill>
+                <a:latin typeface="Noto Sans TC"/>
+              </a:rPr>
+              <a:t>• 量測 CSV → 有限辨識 → 稀疏估測 → 可限制的控制輸出</a:t>
+            </a:r>
+          </a:p>
+          <a:p>
+            <a:pPr>
+              <a:lnSpc>
+                <a:spcPct val="112000"/>
+              </a:lnSpc>
+              <a:spcAft>
+                <a:spcPts val="900"/>
+              </a:spcAft>
+              <a:defRPr sz="2000">
+                <a:solidFill>
+                  <a:srgbClr val="1E2733"/>
+                </a:solidFill>
+                <a:latin typeface="Noto Sans TC"/>
+              </a:defRPr>
+            </a:pPr>
+            <a:r>
+              <a:rPr sz="2000" b="0">
+                <a:solidFill>
+                  <a:srgbClr val="1E2733"/>
+                </a:solidFill>
+                <a:latin typeface="Noto Sans TC"/>
+              </a:rPr>
+              <a:t>• 88 回合／10,560 步；熱容量與風扇延遲變體、額外傳熱路徑</a:t>
+            </a:r>
+          </a:p>
+          <a:p>
+            <a:pPr>
+              <a:lnSpc>
+                <a:spcPct val="112000"/>
+              </a:lnSpc>
+              <a:spcAft>
+                <a:spcPts val="900"/>
+              </a:spcAft>
+              <a:defRPr sz="2000">
+                <a:solidFill>
+                  <a:srgbClr val="1E2733"/>
+                </a:solidFill>
+                <a:latin typeface="Noto Sans TC"/>
+              </a:defRPr>
+            </a:pPr>
+            <a:r>
+              <a:rPr sz="2000" b="0">
+                <a:solidFill>
+                  <a:srgbClr val="1E2733"/>
+                </a:solidFill>
+                <a:latin typeface="Noto Sans TC"/>
+              </a:rPr>
+              <a:t>• 估測平均改善 21.19%，僅 2/4 組：覆蓋判準不支持</a:t>
+            </a:r>
+          </a:p>
+          <a:p>
+            <a:pPr>
+              <a:lnSpc>
+                <a:spcPct val="112000"/>
+              </a:lnSpc>
+              <a:spcAft>
+                <a:spcPts val="900"/>
+              </a:spcAft>
+              <a:defRPr sz="2000">
+                <a:solidFill>
+                  <a:srgbClr val="1E2733"/>
+                </a:solidFill>
+                <a:latin typeface="Noto Sans TC"/>
+              </a:defRPr>
+            </a:pPr>
+            <a:r>
+              <a:rPr sz="2000" b="0">
+                <a:solidFill>
+                  <a:srgbClr val="1E2733"/>
+                </a:solidFill>
+                <a:latin typeface="Noto Sans TC"/>
+              </a:rPr>
+              <a:t>• 六步改善僅 0.069%；未優於 PI，仍有取樣超溫</a:t>
+            </a:r>
+          </a:p>
+          <a:p>
+            <a:pPr>
+              <a:lnSpc>
+                <a:spcPct val="112000"/>
+              </a:lnSpc>
+              <a:spcAft>
+                <a:spcPts val="900"/>
+              </a:spcAft>
+              <a:defRPr sz="2000">
+                <a:solidFill>
+                  <a:srgbClr val="1E2733"/>
+                </a:solidFill>
+                <a:latin typeface="Noto Sans TC"/>
+              </a:defRPr>
+            </a:pPr>
+            <a:r>
+              <a:rPr sz="2000" b="0">
+                <a:solidFill>
+                  <a:srgbClr val="1E2733"/>
+                </a:solidFill>
+                <a:latin typeface="Noto Sans TC"/>
+              </a:rPr>
+              <a:t>• 新增稀疏觀測 LQR／線性 MPC；全部命令合規</a:t>
+            </a:r>
+          </a:p>
+          <a:p>
+            <a:pPr>
+              <a:lnSpc>
+                <a:spcPct val="112000"/>
+              </a:lnSpc>
+              <a:spcAft>
+                <a:spcPts val="900"/>
+              </a:spcAft>
+              <a:defRPr sz="2000">
+                <a:solidFill>
+                  <a:srgbClr val="1E2733"/>
+                </a:solidFill>
+                <a:latin typeface="Noto Sans TC"/>
+              </a:defRPr>
+            </a:pPr>
+            <a:r>
+              <a:rPr sz="2000" b="0">
+                <a:solidFill>
+                  <a:srgbClr val="1E2733"/>
+                </a:solidFill>
+                <a:latin typeface="Noto Sans TC"/>
+              </a:rPr>
+              <a:t>• 軟體與實機程序備妥；真實量測／介入待設備到位</a:t>
+            </a:r>
+          </a:p>
+        </p:txBody>
+      </p:sp>
+      <p:sp>
+        <p:nvSpPr>
+          <p:cNvPr id="7" name="footer_page_number"/>
+          <p:cNvSpPr txBox="1"/>
+          <p:nvPr/>
+        </p:nvSpPr>
+        <p:spPr>
+          <a:xfrm>
+            <a:off x="11201400" y="6400800"/>
+            <a:ext cx="548640" cy="228600"/>
+          </a:xfrm>
+          <a:prstGeom prst="rect">
+            <a:avLst/>
+          </a:prstGeom>
+          <a:noFill/>
+        </p:spPr>
+        <p:txBody>
+          <a:bodyPr wrap="none">
+            <a:spAutoFit/>
+          </a:bodyPr>
+          <a:lstStyle/>
+          <a:p>
+            <a:pPr algn="r"/>
+            <a:r>
+              <a:rPr sz="900">
+                <a:solidFill>
+                  <a:srgbClr val="46505C"/>
+                </a:solidFill>
+                <a:latin typeface="Arial"/>
+              </a:rPr>
+              <a:t>53</a:t>
             </a:r>
           </a:p>
         </p:txBody>

</xml_diff>

<commit_message>
research: audit bounded thermal structure selection and update HTML report
</commit_message>
<xml_diff>
--- a/docs/papers/thesis/thesis_presentation_zh.pptx
+++ b/docs/papers/thesis/thesis_presentation_zh.pptx
@@ -58,6 +58,7 @@
     <p:sldId id="306" r:id="rId58"/>
     <p:sldId id="307" r:id="rId59"/>
     <p:sldId id="308" r:id="rId60"/>
+    <p:sldId id="309" r:id="rId61"/>
   </p:sldIdLst>
   <p:sldSz cx="12191695" cy="6858000" type="screen4x3"/>
   <p:notesSz cx="6858000" cy="9144000"/>
@@ -810,6 +811,91 @@
           <a:p>
             <a:r>
               <a:t>全部 88 回合、10,560 筆已重算指標，核對時間、合成噪聲、原始感測警告、獨立熱動態與只讀觀測的流程回放；372 個歷史研究檔案未改動，一次性 E15 沒有重跑。時間偏移、同步真值偏移、風扇端點、原始觀測與指標五種破壞案例均被拒絕。</a:t>
+            </a:r>
+          </a:p>
+        </p:txBody>
+      </p:sp>
+      <p:sp>
+        <p:nvSpPr>
+          <p:cNvPr id="4" name="Slide Number Placeholder 3"/>
+          <p:cNvSpPr>
+            <a:spLocks noGrp="1"/>
+          </p:cNvSpPr>
+          <p:nvPr>
+            <p:ph type="sldNum" idx="5" sz="quarter"/>
+          </p:nvPr>
+        </p:nvSpPr>
+        <p:spPr/>
+      </p:sp>
+    </p:spTree>
+  </p:cSld>
+  <p:clrMapOvr>
+    <a:masterClrMapping/>
+  </p:clrMapOvr>
+</p:notes>
+</file>
+
+<file path=ppt/notesSlides/notesSlide5.xml><?xml version="1.0" encoding="utf-8"?>
+<p:notes xmlns:a="http://schemas.openxmlformats.org/drawingml/2006/main" xmlns:p="http://schemas.openxmlformats.org/presentationml/2006/main" xmlns:r="http://schemas.openxmlformats.org/officeDocument/2006/relationships">
+  <p:cSld>
+    <p:spTree>
+      <p:nvGrpSpPr>
+        <p:cNvPr id="1" name=""/>
+        <p:cNvGrpSpPr/>
+        <p:nvPr/>
+      </p:nvGrpSpPr>
+      <p:grpSpPr>
+        <a:xfrm>
+          <a:off x="0" y="0"/>
+          <a:ext cx="0" cy="0"/>
+          <a:chOff x="0" y="0"/>
+          <a:chExt cx="0" cy="0"/>
+        </a:xfrm>
+      </p:grpSpPr>
+      <p:sp>
+        <p:nvSpPr>
+          <p:cNvPr id="2" name="Slide Image Placeholder 1"/>
+          <p:cNvSpPr>
+            <a:spLocks noGrp="1"/>
+          </p:cNvSpPr>
+          <p:nvPr>
+            <p:ph type="sldImg" idx="2"/>
+          </p:nvPr>
+        </p:nvSpPr>
+        <p:spPr/>
+      </p:sp>
+      <p:sp>
+        <p:nvSpPr>
+          <p:cNvPr id="3" name="Notes Placeholder 2"/>
+          <p:cNvSpPr>
+            <a:spLocks noGrp="1"/>
+          </p:cNvSpPr>
+          <p:nvPr>
+            <p:ph type="body" idx="3" sz="quarter"/>
+          </p:nvPr>
+        </p:nvSpPr>
+        <p:spPr/>
+        <p:txBody>
+          <a:bodyPr/>
+          <a:lstStyle/>
+          <a:p>
+            <a:r>
+              <a:t>我接著測試四參數共同容量模型 S 與七參數模型 F，後者分別辨識三個熱容量，並增加熱源到空氣的熱導。每個平台僅用前 120 筆校正資料辨識，再用後 60 筆可見感測的加權誤差選擇；F 至少改善 5% 且求解成功才採用，選擇後不重新擬合。六個假設平台共 96 回合、11,520 筆新測試，校正合計 12 次擬合、993 次完整殘差呼叫、7.238 秒。三個平台選 F，另三個保留 S；沒有用熱源真值選模型。</a:t>
+            </a:r>
+          </a:p>
+          <a:p>
+            <a:r>
+              <a:t>新 holdout 的 S／選擇模型在稀疏校正後，熱源估測 MAE 為 1.0764／1.3468°C，平均誤差增加 25.12%，僅 2/6 組改善，H-ENC-71 不支持。S／選擇模型的六步追蹤 MAE 為 1.4661／1.5093°C，增加 2.95%，H-ENC-72 不支持；兩者平均取樣超溫皆為 20.00 秒／回合。全部閉迴路命令違例為零，仍不能推論溫度安全。</a:t>
+            </a:r>
+          </a:p>
+          <a:p>
+            <a:r>
+              <a:t>可見金屬片／空氣／風扇擬合較好，仍不足以保證隱藏熱源更準。對流失配平台的 F 熱源容量達下界、空氣容量達上界，提醒我模型係數可能互相補償；局部 Jacobian 條件數不是全域可辨識性證明。這次只隔離模型結構與 PI／六步排序，沒有重做全部控制器排名；前一階段 LQR／MPC 比較與負面結果仍保留。F 保留為探索候選，未因校正擬合較好就升格為較佳方法。這是有限校正後的合成溫度實驗，沒有設備量測、實體控制或完整三因子遷移證據。</a:t>
+            </a:r>
+          </a:p>
+          <a:p>
+            <a:r>
+              <a:t>我已重算全部 96 回合、11,520 筆指標，核對另 1,080 筆校正來源，檢查時序切分、選擇規則、獨立熱動態與只讀觀測回放；六種破壞案例均被拒絕。514 個歷史證據檔案位元組未變，一次性 E15 與先前機箱實驗沒有重跑。</a:t>
             </a:r>
           </a:p>
         </p:txBody>
@@ -42725,6 +42811,398 @@
                 <a:latin typeface="Arial"/>
               </a:rPr>
               <a:t>53</a:t>
+            </a:r>
+          </a:p>
+        </p:txBody>
+      </p:sp>
+    </p:spTree>
+  </p:cSld>
+  <p:clrMapOvr>
+    <a:masterClrMapping/>
+  </p:clrMapOvr>
+</p:sld>
+</file>
+
+<file path=ppt/slides/slide54.xml><?xml version="1.0" encoding="utf-8"?>
+<p:sld xmlns:a="http://schemas.openxmlformats.org/drawingml/2006/main" xmlns:p="http://schemas.openxmlformats.org/presentationml/2006/main" xmlns:r="http://schemas.openxmlformats.org/officeDocument/2006/relationships">
+  <p:cSld>
+    <p:bg>
+      <p:bgPr>
+        <a:solidFill>
+          <a:srgbClr val="F4F7FB"/>
+        </a:solidFill>
+        <a:effectLst/>
+      </p:bgPr>
+    </p:bg>
+    <p:spTree>
+      <p:nvGrpSpPr>
+        <p:cNvPr id="1" name=""/>
+        <p:cNvGrpSpPr/>
+        <p:nvPr/>
+      </p:nvGrpSpPr>
+      <p:grpSpPr/>
+      <p:sp>
+        <p:nvSpPr>
+          <p:cNvPr id="2" name="Rectangle 1"/>
+          <p:cNvSpPr/>
+          <p:nvPr/>
+        </p:nvSpPr>
+        <p:spPr>
+          <a:xfrm>
+            <a:off x="0" y="0"/>
+            <a:ext cx="12191695" cy="896112"/>
+          </a:xfrm>
+          <a:prstGeom prst="rect">
+            <a:avLst/>
+          </a:prstGeom>
+          <a:solidFill>
+            <a:srgbClr val="122033"/>
+          </a:solidFill>
+          <a:ln>
+            <a:solidFill>
+              <a:srgbClr val="122033"/>
+            </a:solidFill>
+          </a:ln>
+        </p:spPr>
+        <p:style>
+          <a:lnRef idx="1">
+            <a:schemeClr val="accent1"/>
+          </a:lnRef>
+          <a:fillRef idx="3">
+            <a:schemeClr val="accent1"/>
+          </a:fillRef>
+          <a:effectRef idx="2">
+            <a:schemeClr val="accent1"/>
+          </a:effectRef>
+          <a:fontRef idx="minor">
+            <a:schemeClr val="lt1"/>
+          </a:fontRef>
+        </p:style>
+        <p:txBody>
+          <a:bodyPr rtlCol="0" anchor="ctr"/>
+          <a:lstStyle/>
+          <a:p>
+            <a:pPr algn="ctr"/>
+          </a:p>
+        </p:txBody>
+      </p:sp>
+      <p:sp>
+        <p:nvSpPr>
+          <p:cNvPr id="3" name="Rectangle 2"/>
+          <p:cNvSpPr/>
+          <p:nvPr/>
+        </p:nvSpPr>
+        <p:spPr>
+          <a:xfrm>
+            <a:off x="0" y="868680"/>
+            <a:ext cx="12191695" cy="27432"/>
+          </a:xfrm>
+          <a:prstGeom prst="rect">
+            <a:avLst/>
+          </a:prstGeom>
+          <a:solidFill>
+            <a:srgbClr val="2D9BC8"/>
+          </a:solidFill>
+          <a:ln>
+            <a:solidFill>
+              <a:srgbClr val="2D9BC8"/>
+            </a:solidFill>
+          </a:ln>
+        </p:spPr>
+        <p:style>
+          <a:lnRef idx="1">
+            <a:schemeClr val="accent1"/>
+          </a:lnRef>
+          <a:fillRef idx="3">
+            <a:schemeClr val="accent1"/>
+          </a:fillRef>
+          <a:effectRef idx="2">
+            <a:schemeClr val="accent1"/>
+          </a:effectRef>
+          <a:fontRef idx="minor">
+            <a:schemeClr val="lt1"/>
+          </a:fontRef>
+        </p:style>
+        <p:txBody>
+          <a:bodyPr rtlCol="0" anchor="ctr"/>
+          <a:lstStyle/>
+          <a:p>
+            <a:pPr algn="ctr"/>
+          </a:p>
+        </p:txBody>
+      </p:sp>
+      <p:sp>
+        <p:nvSpPr>
+          <p:cNvPr id="4" name="TextBox 3"/>
+          <p:cNvSpPr txBox="1"/>
+          <p:nvPr/>
+        </p:nvSpPr>
+        <p:spPr>
+          <a:xfrm>
+            <a:off x="530352" y="109728"/>
+            <a:ext cx="11155680" cy="438912"/>
+          </a:xfrm>
+          <a:prstGeom prst="rect">
+            <a:avLst/>
+          </a:prstGeom>
+          <a:noFill/>
+        </p:spPr>
+        <p:txBody>
+          <a:bodyPr wrap="square" lIns="0" rIns="0" tIns="0" bIns="0">
+            <a:normAutofit/>
+          </a:bodyPr>
+          <a:lstStyle/>
+          <a:p>
+            <a:r>
+              <a:rPr sz="2000" b="1">
+                <a:solidFill>
+                  <a:srgbClr val="FFFFFF"/>
+                </a:solidFill>
+                <a:latin typeface="Noto Sans TC"/>
+              </a:rPr>
+              <a:t>有限熱結構選擇與隱藏熱源反例 2026-10-12</a:t>
+            </a:r>
+          </a:p>
+        </p:txBody>
+      </p:sp>
+      <p:sp>
+        <p:nvSpPr>
+          <p:cNvPr id="5" name="TextBox 4"/>
+          <p:cNvSpPr txBox="1"/>
+          <p:nvPr/>
+        </p:nvSpPr>
+        <p:spPr>
+          <a:xfrm>
+            <a:off x="548640" y="566928"/>
+            <a:ext cx="11064240" cy="237744"/>
+          </a:xfrm>
+          <a:prstGeom prst="rect">
+            <a:avLst/>
+          </a:prstGeom>
+          <a:noFill/>
+        </p:spPr>
+        <p:txBody>
+          <a:bodyPr wrap="none" lIns="0" rIns="0" tIns="0" bIns="0">
+            <a:normAutofit/>
+          </a:bodyPr>
+          <a:lstStyle/>
+          <a:p>
+            <a:r>
+              <a:rPr sz="1000">
+                <a:solidFill>
+                  <a:srgbClr val="D3E1F1"/>
+                </a:solidFill>
+                <a:latin typeface="Noto Sans TC"/>
+              </a:rPr>
+              <a:t>校正留出較好，新的隱藏熱源測試仍可能退步</a:t>
+            </a:r>
+          </a:p>
+        </p:txBody>
+      </p:sp>
+      <p:sp>
+        <p:nvSpPr>
+          <p:cNvPr id="6" name="TextBox 5"/>
+          <p:cNvSpPr txBox="1"/>
+          <p:nvPr/>
+        </p:nvSpPr>
+        <p:spPr>
+          <a:xfrm>
+            <a:off x="731520" y="1463040"/>
+            <a:ext cx="10698480" cy="4754880"/>
+          </a:xfrm>
+          <a:prstGeom prst="rect">
+            <a:avLst/>
+          </a:prstGeom>
+          <a:noFill/>
+        </p:spPr>
+        <p:txBody>
+          <a:bodyPr wrap="square" lIns="18288" rIns="18288" tIns="18288" bIns="18288">
+            <a:normAutofit/>
+          </a:bodyPr>
+          <a:lstStyle/>
+          <a:p>
+            <a:pPr>
+              <a:lnSpc>
+                <a:spcPct val="112000"/>
+              </a:lnSpc>
+              <a:spcAft>
+                <a:spcPts val="900"/>
+              </a:spcAft>
+              <a:defRPr sz="2000">
+                <a:solidFill>
+                  <a:srgbClr val="1E2733"/>
+                </a:solidFill>
+                <a:latin typeface="Noto Sans TC"/>
+              </a:defRPr>
+            </a:pPr>
+            <a:r>
+              <a:rPr sz="2000" b="0">
+                <a:solidFill>
+                  <a:srgbClr val="1E2733"/>
+                </a:solidFill>
+                <a:latin typeface="Noto Sans TC"/>
+              </a:rPr>
+              <a:t>• S：共同容量；F：獨立容量與熱源—空氣熱導</a:t>
+            </a:r>
+          </a:p>
+          <a:p>
+            <a:pPr>
+              <a:lnSpc>
+                <a:spcPct val="112000"/>
+              </a:lnSpc>
+              <a:spcAft>
+                <a:spcPts val="900"/>
+              </a:spcAft>
+              <a:defRPr sz="2000">
+                <a:solidFill>
+                  <a:srgbClr val="1E2733"/>
+                </a:solidFill>
+                <a:latin typeface="Noto Sans TC"/>
+              </a:defRPr>
+            </a:pPr>
+            <a:r>
+              <a:rPr sz="2000" b="0">
+                <a:solidFill>
+                  <a:srgbClr val="1E2733"/>
+                </a:solidFill>
+                <a:latin typeface="Noto Sans TC"/>
+              </a:rPr>
+              <a:t>• 前 120 筆辨識／後 60 筆選擇；不使用熱源真值</a:t>
+            </a:r>
+          </a:p>
+          <a:p>
+            <a:pPr>
+              <a:lnSpc>
+                <a:spcPct val="112000"/>
+              </a:lnSpc>
+              <a:spcAft>
+                <a:spcPts val="900"/>
+              </a:spcAft>
+              <a:defRPr sz="2000">
+                <a:solidFill>
+                  <a:srgbClr val="1E2733"/>
+                </a:solidFill>
+                <a:latin typeface="Noto Sans TC"/>
+              </a:defRPr>
+            </a:pPr>
+            <a:r>
+              <a:rPr sz="2000" b="0">
+                <a:solidFill>
+                  <a:srgbClr val="1E2733"/>
+                </a:solidFill>
+                <a:latin typeface="Noto Sans TC"/>
+              </a:rPr>
+              <a:t>• 96 回合／11,520 筆；三個平台選 F、三個保留 S</a:t>
+            </a:r>
+          </a:p>
+          <a:p>
+            <a:pPr>
+              <a:lnSpc>
+                <a:spcPct val="112000"/>
+              </a:lnSpc>
+              <a:spcAft>
+                <a:spcPts val="900"/>
+              </a:spcAft>
+              <a:defRPr sz="2000">
+                <a:solidFill>
+                  <a:srgbClr val="1E2733"/>
+                </a:solidFill>
+                <a:latin typeface="Noto Sans TC"/>
+              </a:defRPr>
+            </a:pPr>
+            <a:r>
+              <a:rPr sz="2000" b="0">
+                <a:solidFill>
+                  <a:srgbClr val="1E2733"/>
+                </a:solidFill>
+                <a:latin typeface="Noto Sans TC"/>
+              </a:rPr>
+              <a:t>• 隱藏熱源誤差增加 25.12%；僅 2/6 組改善</a:t>
+            </a:r>
+          </a:p>
+          <a:p>
+            <a:pPr>
+              <a:lnSpc>
+                <a:spcPct val="112000"/>
+              </a:lnSpc>
+              <a:spcAft>
+                <a:spcPts val="900"/>
+              </a:spcAft>
+              <a:defRPr sz="2000">
+                <a:solidFill>
+                  <a:srgbClr val="1E2733"/>
+                </a:solidFill>
+                <a:latin typeface="Noto Sans TC"/>
+              </a:defRPr>
+            </a:pPr>
+            <a:r>
+              <a:rPr sz="2000" b="0">
+                <a:solidFill>
+                  <a:srgbClr val="1E2733"/>
+                </a:solidFill>
+                <a:latin typeface="Noto Sans TC"/>
+              </a:rPr>
+              <a:t>• 六步追蹤誤差增加 2.95%；兩項判準皆不支持</a:t>
+            </a:r>
+          </a:p>
+          <a:p>
+            <a:pPr>
+              <a:lnSpc>
+                <a:spcPct val="112000"/>
+              </a:lnSpc>
+              <a:spcAft>
+                <a:spcPts val="900"/>
+              </a:spcAft>
+              <a:defRPr sz="2000">
+                <a:solidFill>
+                  <a:srgbClr val="1E2733"/>
+                </a:solidFill>
+                <a:latin typeface="Noto Sans TC"/>
+              </a:defRPr>
+            </a:pPr>
+            <a:r>
+              <a:rPr sz="2000" b="0">
+                <a:solidFill>
+                  <a:srgbClr val="1E2733"/>
+                </a:solidFill>
+                <a:latin typeface="Noto Sans TC"/>
+              </a:rPr>
+              <a:t>• 可見擬合較好不足以保證熱源準確；候選保留為探索</a:t>
+            </a:r>
+          </a:p>
+        </p:txBody>
+      </p:sp>
+      <p:sp>
+        <p:nvSpPr>
+          <p:cNvPr id="7" name="footer_page_number"/>
+          <p:cNvSpPr txBox="1"/>
+          <p:nvPr/>
+        </p:nvSpPr>
+        <p:spPr>
+          <a:xfrm>
+            <a:off x="11201400" y="6400800"/>
+            <a:ext cx="548640" cy="228600"/>
+          </a:xfrm>
+          <a:prstGeom prst="rect">
+            <a:avLst/>
+          </a:prstGeom>
+          <a:noFill/>
+        </p:spPr>
+        <p:txBody>
+          <a:bodyPr wrap="none">
+            <a:spAutoFit/>
+          </a:bodyPr>
+          <a:lstStyle/>
+          <a:p>
+            <a:pPr algn="r"/>
+            <a:r>
+              <a:rPr sz="900">
+                <a:solidFill>
+                  <a:srgbClr val="46505C"/>
+                </a:solidFill>
+                <a:latin typeface="Arial"/>
+              </a:rPr>
+              <a:t>54</a:t>
             </a:r>
           </a:p>
         </p:txBody>

</xml_diff>